<commit_message>
fix(woocommerce): preserve object payment gateways
</commit_message>
<xml_diff>
--- a/submission/agent-snr-hackathon-demo.pptx
+++ b/submission/agent-snr-hackathon-demo.pptx
@@ -2,23 +2,23 @@
 <file path=ppt/presentation.xml><?xml version="1.0" encoding="utf-8"?>
 <p:presentation xmlns:p="http://schemas.openxmlformats.org/presentationml/2006/main">
   <p:sldMasterIdLst>
-    <p:sldMasterId xmlns:r="http://schemas.openxmlformats.org/officeDocument/2006/relationships" id="2147483648" r:id="R37c9d08d21514f31"/>
+    <p:sldMasterId xmlns:r="http://schemas.openxmlformats.org/officeDocument/2006/relationships" id="2147483648" r:id="R94cc63fc9f764411"/>
   </p:sldMasterIdLst>
   <p:notesMasterIdLst>
-    <p:notesMasterId xmlns:r="http://schemas.openxmlformats.org/officeDocument/2006/relationships" r:id="R64f9ce9d6fe7464b"/>
+    <p:notesMasterId xmlns:r="http://schemas.openxmlformats.org/officeDocument/2006/relationships" r:id="R71aa42adffb143ae"/>
   </p:notesMasterIdLst>
   <p:sldIdLst>
-    <p:sldId xmlns:r="http://schemas.openxmlformats.org/officeDocument/2006/relationships" id="256" r:id="Rb0385b23a74e4888"/>
-    <p:sldId xmlns:r="http://schemas.openxmlformats.org/officeDocument/2006/relationships" id="257" r:id="R3095a9fb12444c60"/>
-    <p:sldId xmlns:r="http://schemas.openxmlformats.org/officeDocument/2006/relationships" id="258" r:id="R22fdf15f4555445d"/>
-    <p:sldId xmlns:r="http://schemas.openxmlformats.org/officeDocument/2006/relationships" id="259" r:id="R3c8e01f5f44248d6"/>
-    <p:sldId xmlns:r="http://schemas.openxmlformats.org/officeDocument/2006/relationships" id="260" r:id="Reffe7d3f97bb4b3d"/>
-    <p:sldId xmlns:r="http://schemas.openxmlformats.org/officeDocument/2006/relationships" id="261" r:id="R3902fdd1916d4def"/>
-    <p:sldId xmlns:r="http://schemas.openxmlformats.org/officeDocument/2006/relationships" id="262" r:id="R2c670f1666e44b7d"/>
-    <p:sldId xmlns:r="http://schemas.openxmlformats.org/officeDocument/2006/relationships" id="263" r:id="Re82f3cfc98954eb1"/>
-    <p:sldId xmlns:r="http://schemas.openxmlformats.org/officeDocument/2006/relationships" id="264" r:id="R47d58f09ace64e9d"/>
-    <p:sldId xmlns:r="http://schemas.openxmlformats.org/officeDocument/2006/relationships" id="265" r:id="Re58e22e180984a09"/>
-    <p:sldId xmlns:r="http://schemas.openxmlformats.org/officeDocument/2006/relationships" id="266" r:id="R0f4a37225338492c"/>
+    <p:sldId xmlns:r="http://schemas.openxmlformats.org/officeDocument/2006/relationships" id="256" r:id="Rb65f3025170a4160"/>
+    <p:sldId xmlns:r="http://schemas.openxmlformats.org/officeDocument/2006/relationships" id="257" r:id="R2c6b63bd5c624deb"/>
+    <p:sldId xmlns:r="http://schemas.openxmlformats.org/officeDocument/2006/relationships" id="258" r:id="Rb52c20b4d8434b28"/>
+    <p:sldId xmlns:r="http://schemas.openxmlformats.org/officeDocument/2006/relationships" id="259" r:id="R339d302aa6254999"/>
+    <p:sldId xmlns:r="http://schemas.openxmlformats.org/officeDocument/2006/relationships" id="260" r:id="R09926b557bae4a1d"/>
+    <p:sldId xmlns:r="http://schemas.openxmlformats.org/officeDocument/2006/relationships" id="261" r:id="Re826991beef5468a"/>
+    <p:sldId xmlns:r="http://schemas.openxmlformats.org/officeDocument/2006/relationships" id="262" r:id="R4f08212f25aa46e9"/>
+    <p:sldId xmlns:r="http://schemas.openxmlformats.org/officeDocument/2006/relationships" id="263" r:id="Rb40788e406be4f41"/>
+    <p:sldId xmlns:r="http://schemas.openxmlformats.org/officeDocument/2006/relationships" id="264" r:id="Rdd5d52613d764c52"/>
+    <p:sldId xmlns:r="http://schemas.openxmlformats.org/officeDocument/2006/relationships" id="265" r:id="Rcf90fcbb8c774ee5"/>
+    <p:sldId xmlns:r="http://schemas.openxmlformats.org/officeDocument/2006/relationships" id="266" r:id="R218fe9d4891d4f0b"/>
   </p:sldIdLst>
   <p:sldSz cx="12192000" cy="6858000"/>
   <p:notesSz cx="6858000" cy="9144000"/>
@@ -1505,7 +1505,7 @@
   </p:cSld>
   <p:clrMap bg1="lt1" tx1="dk1" bg2="lt2" tx2="dk2" accent1="accent1" accent2="accent2" accent3="accent3" accent4="accent4" accent5="accent5" accent6="accent6" hlink="hlink" folHlink="folHlink"/>
   <p:sldLayoutIdLst>
-    <p:sldLayoutId xmlns:r="http://schemas.openxmlformats.org/officeDocument/2006/relationships" id="2147483649" r:id="Rf2d6f06d47694c33"/>
+    <p:sldLayoutId xmlns:r="http://schemas.openxmlformats.org/officeDocument/2006/relationships" id="2147483649" r:id="R267956cda3d64b50"/>
   </p:sldLayoutIdLst>
   <p:txStyles>
     <p:titleStyle>
@@ -2401,7 +2401,7 @@
       </p:sp>
       <p:cxnSp>
         <p:nvCxnSpPr>
-          <p:cNvPr id="23" name=""/>
+          <p:cNvPr id="37" name=""/>
           <p:cNvCxnSpPr/>
           <p:nvPr/>
         </p:nvCxnSpPr>
@@ -2688,7 +2688,7 @@
       </p:sp>
       <p:cxnSp>
         <p:nvCxnSpPr>
-          <p:cNvPr id="48" name=""/>
+          <p:cNvPr id="92" name=""/>
           <p:cNvCxnSpPr/>
           <p:nvPr/>
         </p:nvCxnSpPr>
@@ -2887,7 +2887,7 @@
       </p:sp>
       <p:cxnSp>
         <p:nvCxnSpPr>
-          <p:cNvPr id="52" name=""/>
+          <p:cNvPr id="96" name=""/>
           <p:cNvCxnSpPr/>
           <p:nvPr/>
         </p:nvCxnSpPr>
@@ -3020,14 +3020,14 @@
                 <a:ea typeface="Helvetica Neue"/>
                 <a:cs typeface="Helvetica Neue"/>
               </a:rPr>
-              <a:t>65</a:t>
+              <a:t>68</a:t>
             </a:r>
           </a:p>
         </p:txBody>
       </p:sp>
       <p:cxnSp>
         <p:nvCxnSpPr>
-          <p:cNvPr id="55" name=""/>
+          <p:cNvPr id="99" name=""/>
           <p:cNvCxnSpPr/>
           <p:nvPr/>
         </p:nvCxnSpPr>
@@ -3101,7 +3101,7 @@
                 <a:ea typeface="Helvetica Neue"/>
                 <a:cs typeface="Helvetica Neue"/>
               </a:rPr>
-              <a:t>PHP tests / 597 assertions</a:t>
+              <a:t>PHP tests / 606 assertions</a:t>
             </a:r>
           </a:p>
         </p:txBody>
@@ -3167,7 +3167,7 @@
       </p:sp>
       <p:cxnSp>
         <p:nvCxnSpPr>
-          <p:cNvPr id="58" name=""/>
+          <p:cNvPr id="102" name=""/>
           <p:cNvCxnSpPr/>
           <p:nvPr/>
         </p:nvCxnSpPr>
@@ -3307,7 +3307,7 @@
       </p:sp>
       <p:cxnSp>
         <p:nvCxnSpPr>
-          <p:cNvPr id="61" name=""/>
+          <p:cNvPr id="105" name=""/>
           <p:cNvCxnSpPr/>
           <p:nvPr/>
         </p:nvCxnSpPr>
@@ -3447,7 +3447,7 @@
       </p:sp>
       <p:cxnSp>
         <p:nvCxnSpPr>
-          <p:cNvPr id="64" name=""/>
+          <p:cNvPr id="108" name=""/>
           <p:cNvCxnSpPr/>
           <p:nvPr/>
         </p:nvCxnSpPr>
@@ -3587,7 +3587,7 @@
       </p:sp>
       <p:cxnSp>
         <p:nvCxnSpPr>
-          <p:cNvPr id="67" name=""/>
+          <p:cNvPr id="111" name=""/>
           <p:cNvCxnSpPr/>
           <p:nvPr/>
         </p:nvCxnSpPr>
@@ -4534,7 +4534,7 @@
       </p:sp>
       <p:cxnSp>
         <p:nvCxnSpPr>
-          <p:cNvPr id="50" name=""/>
+          <p:cNvPr id="82" name=""/>
           <p:cNvCxnSpPr/>
           <p:nvPr/>
         </p:nvCxnSpPr>
@@ -4821,7 +4821,7 @@
       </p:sp>
       <p:cxnSp>
         <p:nvCxnSpPr>
-          <p:cNvPr id="33" name=""/>
+          <p:cNvPr id="45" name=""/>
           <p:cNvCxnSpPr/>
           <p:nvPr/>
         </p:nvCxnSpPr>
@@ -4961,7 +4961,7 @@
       </p:sp>
       <p:cxnSp>
         <p:nvCxnSpPr>
-          <p:cNvPr id="36" name=""/>
+          <p:cNvPr id="48" name=""/>
           <p:cNvCxnSpPr/>
           <p:nvPr/>
         </p:nvCxnSpPr>
@@ -6018,7 +6018,7 @@
       </p:sp>
       <p:cxnSp>
         <p:nvCxnSpPr>
-          <p:cNvPr id="41" name=""/>
+          <p:cNvPr id="75" name=""/>
           <p:cNvCxnSpPr/>
           <p:nvPr/>
         </p:nvCxnSpPr>
@@ -6335,7 +6335,7 @@
       </p:sp>
       <p:cxnSp>
         <p:nvCxnSpPr>
-          <p:cNvPr id="47" name=""/>
+          <p:cNvPr id="81" name=""/>
           <p:cNvCxnSpPr/>
           <p:nvPr/>
         </p:nvCxnSpPr>
@@ -6534,7 +6534,7 @@
       </p:sp>
       <p:cxnSp>
         <p:nvCxnSpPr>
-          <p:cNvPr id="51" name=""/>
+          <p:cNvPr id="85" name=""/>
           <p:cNvCxnSpPr/>
           <p:nvPr/>
         </p:nvCxnSpPr>
@@ -6733,7 +6733,7 @@
       </p:sp>
       <p:cxnSp>
         <p:nvCxnSpPr>
-          <p:cNvPr id="55" name=""/>
+          <p:cNvPr id="89" name=""/>
           <p:cNvCxnSpPr/>
           <p:nvPr/>
         </p:nvCxnSpPr>
@@ -7112,7 +7112,7 @@
       </p:sp>
       <p:cxnSp>
         <p:nvCxnSpPr>
-          <p:cNvPr id="61" name=""/>
+          <p:cNvPr id="87" name=""/>
           <p:cNvCxnSpPr/>
           <p:nvPr/>
         </p:nvCxnSpPr>
@@ -7561,7 +7561,7 @@
       </p:sp>
       <p:cxnSp>
         <p:nvCxnSpPr>
-          <p:cNvPr id="71" name=""/>
+          <p:cNvPr id="97" name=""/>
           <p:cNvCxnSpPr/>
           <p:nvPr/>
         </p:nvCxnSpPr>
@@ -9322,7 +9322,7 @@
       </p:sp>
       <p:cxnSp>
         <p:nvCxnSpPr>
-          <p:cNvPr id="22" name=""/>
+          <p:cNvPr id="28" name=""/>
           <p:cNvCxnSpPr/>
           <p:nvPr/>
         </p:nvCxnSpPr>
@@ -10424,7 +10424,7 @@
       </p:sp>
       <p:cxnSp>
         <p:nvCxnSpPr>
-          <p:cNvPr id="66" name=""/>
+          <p:cNvPr id="126" name=""/>
           <p:cNvCxnSpPr/>
           <p:nvPr/>
         </p:nvCxnSpPr>
@@ -10564,7 +10564,7 @@
       </p:sp>
       <p:cxnSp>
         <p:nvCxnSpPr>
-          <p:cNvPr id="69" name=""/>
+          <p:cNvPr id="129" name=""/>
           <p:cNvCxnSpPr/>
           <p:nvPr/>
         </p:nvCxnSpPr>
@@ -11789,7 +11789,7 @@
       </p:sp>
       <p:cxnSp>
         <p:nvCxnSpPr>
-          <p:cNvPr id="93" name=""/>
+          <p:cNvPr id="153" name=""/>
           <p:cNvCxnSpPr/>
           <p:nvPr/>
         </p:nvCxnSpPr>
@@ -12207,7 +12207,7 @@
       </p:sp>
       <p:cxnSp>
         <p:nvCxnSpPr>
-          <p:cNvPr id="31" name=""/>
+          <p:cNvPr id="39" name=""/>
           <p:cNvCxnSpPr/>
           <p:nvPr/>
         </p:nvCxnSpPr>
@@ -12347,14 +12347,14 @@
       </p:sp>
       <p:pic>
         <p:nvPicPr>
-          <p:cNvPr id="34" name=""/>
+          <p:cNvPr id="42" name=""/>
           <p:cNvPicPr>
             <a:picLocks xmlns:a="http://schemas.openxmlformats.org/drawingml/2006/main" noChangeAspect="1"/>
           </p:cNvPicPr>
           <p:nvPr/>
         </p:nvPicPr>
         <p:blipFill>
-          <a:blip xmlns:r="http://schemas.openxmlformats.org/officeDocument/2006/relationships" xmlns:a="http://schemas.openxmlformats.org/drawingml/2006/main" r:embed="R933719174cb54f71"/>
+          <a:blip xmlns:r="http://schemas.openxmlformats.org/officeDocument/2006/relationships" xmlns:a="http://schemas.openxmlformats.org/drawingml/2006/main" r:embed="Reecb667e3b9d41dc"/>
           <a:srcRect xmlns:a="http://schemas.openxmlformats.org/drawingml/2006/main" l="11607" t="0" r="11607" b="0"/>
           <a:stretch xmlns:a="http://schemas.openxmlformats.org/drawingml/2006/main">
             <a:fillRect l="0" t="0" r="0" b="0"/>
@@ -13453,7 +13453,7 @@
       </p:sp>
       <p:cxnSp>
         <p:nvCxnSpPr>
-          <p:cNvPr id="24" name=""/>
+          <p:cNvPr id="44" name=""/>
           <p:cNvCxnSpPr/>
           <p:nvPr/>
         </p:nvCxnSpPr>
@@ -13842,7 +13842,7 @@
       </p:sp>
       <p:cxnSp>
         <p:nvCxnSpPr>
-          <p:cNvPr id="30" name=""/>
+          <p:cNvPr id="50" name=""/>
           <p:cNvCxnSpPr/>
           <p:nvPr/>
         </p:nvCxnSpPr>
@@ -13923,14 +13923,14 @@
       </p:sp>
       <p:pic>
         <p:nvPicPr>
-          <p:cNvPr id="32" name=""/>
+          <p:cNvPr id="52" name=""/>
           <p:cNvPicPr>
             <a:picLocks xmlns:a="http://schemas.openxmlformats.org/drawingml/2006/main" noChangeAspect="1"/>
           </p:cNvPicPr>
           <p:nvPr/>
         </p:nvPicPr>
         <p:blipFill>
-          <a:blip xmlns:r="http://schemas.openxmlformats.org/officeDocument/2006/relationships" xmlns:a="http://schemas.openxmlformats.org/drawingml/2006/main" r:embed="Rcb12a6a63651443f"/>
+          <a:blip xmlns:r="http://schemas.openxmlformats.org/officeDocument/2006/relationships" xmlns:a="http://schemas.openxmlformats.org/drawingml/2006/main" r:embed="R6265239682d24715"/>
           <a:srcRect xmlns:a="http://schemas.openxmlformats.org/drawingml/2006/main" l="0" t="9356" r="0" b="9356"/>
           <a:stretch xmlns:a="http://schemas.openxmlformats.org/drawingml/2006/main">
             <a:fillRect l="0" t="0" r="0" b="0"/>
@@ -14097,7 +14097,7 @@
       </p:sp>
       <p:cxnSp>
         <p:nvCxnSpPr>
-          <p:cNvPr id="25" name=""/>
+          <p:cNvPr id="35" name=""/>
           <p:cNvCxnSpPr/>
           <p:nvPr/>
         </p:nvCxnSpPr>
@@ -14237,14 +14237,14 @@
       </p:sp>
       <p:pic>
         <p:nvPicPr>
-          <p:cNvPr id="28" name=""/>
+          <p:cNvPr id="38" name=""/>
           <p:cNvPicPr>
             <a:picLocks xmlns:a="http://schemas.openxmlformats.org/drawingml/2006/main" noChangeAspect="1"/>
           </p:cNvPicPr>
           <p:nvPr/>
         </p:nvPicPr>
         <p:blipFill>
-          <a:blip xmlns:r="http://schemas.openxmlformats.org/officeDocument/2006/relationships" xmlns:a="http://schemas.openxmlformats.org/drawingml/2006/main" r:embed="R8ce80d4520b74eed"/>
+          <a:blip xmlns:r="http://schemas.openxmlformats.org/officeDocument/2006/relationships" xmlns:a="http://schemas.openxmlformats.org/drawingml/2006/main" r:embed="R35d7be2b7e1b4973"/>
           <a:srcRect xmlns:a="http://schemas.openxmlformats.org/drawingml/2006/main" l="316" t="0" r="316" b="0"/>
           <a:stretch xmlns:a="http://schemas.openxmlformats.org/drawingml/2006/main">
             <a:fillRect l="0" t="0" r="0" b="0"/>
@@ -14264,14 +14264,14 @@
       </p:pic>
       <p:pic>
         <p:nvPicPr>
-          <p:cNvPr id="29" name=""/>
+          <p:cNvPr id="39" name=""/>
           <p:cNvPicPr>
             <a:picLocks xmlns:a="http://schemas.openxmlformats.org/drawingml/2006/main" noChangeAspect="1"/>
           </p:cNvPicPr>
           <p:nvPr/>
         </p:nvPicPr>
         <p:blipFill>
-          <a:blip xmlns:r="http://schemas.openxmlformats.org/officeDocument/2006/relationships" xmlns:a="http://schemas.openxmlformats.org/drawingml/2006/main" r:embed="R692bcf373018434d"/>
+          <a:blip xmlns:r="http://schemas.openxmlformats.org/officeDocument/2006/relationships" xmlns:a="http://schemas.openxmlformats.org/drawingml/2006/main" r:embed="Ra27ce19f6cad4193"/>
           <a:srcRect xmlns:a="http://schemas.openxmlformats.org/drawingml/2006/main" l="0" t="383" r="0" b="383"/>
           <a:stretch xmlns:a="http://schemas.openxmlformats.org/drawingml/2006/main">
             <a:fillRect l="0" t="0" r="0" b="0"/>

</xml_diff>

<commit_message>
feat(agent-snr): add guide, feedback, and opportunity signals
</commit_message>
<xml_diff>
--- a/submission/agent-snr-hackathon-demo.pptx
+++ b/submission/agent-snr-hackathon-demo.pptx
@@ -2,23 +2,23 @@
 <file path=ppt/presentation.xml><?xml version="1.0" encoding="utf-8"?>
 <p:presentation xmlns:p="http://schemas.openxmlformats.org/presentationml/2006/main">
   <p:sldMasterIdLst>
-    <p:sldMasterId xmlns:r="http://schemas.openxmlformats.org/officeDocument/2006/relationships" id="2147483648" r:id="R94cc63fc9f764411"/>
+    <p:sldMasterId xmlns:r="http://schemas.openxmlformats.org/officeDocument/2006/relationships" id="2147483648" r:id="R6b3840c3be404f90"/>
   </p:sldMasterIdLst>
   <p:notesMasterIdLst>
-    <p:notesMasterId xmlns:r="http://schemas.openxmlformats.org/officeDocument/2006/relationships" r:id="R71aa42adffb143ae"/>
+    <p:notesMasterId xmlns:r="http://schemas.openxmlformats.org/officeDocument/2006/relationships" r:id="Rbdb16cbb29434c09"/>
   </p:notesMasterIdLst>
   <p:sldIdLst>
-    <p:sldId xmlns:r="http://schemas.openxmlformats.org/officeDocument/2006/relationships" id="256" r:id="Rb65f3025170a4160"/>
-    <p:sldId xmlns:r="http://schemas.openxmlformats.org/officeDocument/2006/relationships" id="257" r:id="R2c6b63bd5c624deb"/>
-    <p:sldId xmlns:r="http://schemas.openxmlformats.org/officeDocument/2006/relationships" id="258" r:id="Rb52c20b4d8434b28"/>
-    <p:sldId xmlns:r="http://schemas.openxmlformats.org/officeDocument/2006/relationships" id="259" r:id="R339d302aa6254999"/>
-    <p:sldId xmlns:r="http://schemas.openxmlformats.org/officeDocument/2006/relationships" id="260" r:id="R09926b557bae4a1d"/>
-    <p:sldId xmlns:r="http://schemas.openxmlformats.org/officeDocument/2006/relationships" id="261" r:id="Re826991beef5468a"/>
-    <p:sldId xmlns:r="http://schemas.openxmlformats.org/officeDocument/2006/relationships" id="262" r:id="R4f08212f25aa46e9"/>
-    <p:sldId xmlns:r="http://schemas.openxmlformats.org/officeDocument/2006/relationships" id="263" r:id="Rb40788e406be4f41"/>
-    <p:sldId xmlns:r="http://schemas.openxmlformats.org/officeDocument/2006/relationships" id="264" r:id="Rdd5d52613d764c52"/>
-    <p:sldId xmlns:r="http://schemas.openxmlformats.org/officeDocument/2006/relationships" id="265" r:id="Rcf90fcbb8c774ee5"/>
-    <p:sldId xmlns:r="http://schemas.openxmlformats.org/officeDocument/2006/relationships" id="266" r:id="R218fe9d4891d4f0b"/>
+    <p:sldId xmlns:r="http://schemas.openxmlformats.org/officeDocument/2006/relationships" id="256" r:id="Rd41bb99b72cc4a62"/>
+    <p:sldId xmlns:r="http://schemas.openxmlformats.org/officeDocument/2006/relationships" id="257" r:id="R1328144698e14cbf"/>
+    <p:sldId xmlns:r="http://schemas.openxmlformats.org/officeDocument/2006/relationships" id="258" r:id="Rb1a93082560041f7"/>
+    <p:sldId xmlns:r="http://schemas.openxmlformats.org/officeDocument/2006/relationships" id="259" r:id="R2632ec83a627482d"/>
+    <p:sldId xmlns:r="http://schemas.openxmlformats.org/officeDocument/2006/relationships" id="260" r:id="Rd76d62ccb25049c2"/>
+    <p:sldId xmlns:r="http://schemas.openxmlformats.org/officeDocument/2006/relationships" id="261" r:id="R73bdfeafb8f84bdb"/>
+    <p:sldId xmlns:r="http://schemas.openxmlformats.org/officeDocument/2006/relationships" id="262" r:id="R56c4b36d4f55441a"/>
+    <p:sldId xmlns:r="http://schemas.openxmlformats.org/officeDocument/2006/relationships" id="263" r:id="Rc7cd82afbd4349f9"/>
+    <p:sldId xmlns:r="http://schemas.openxmlformats.org/officeDocument/2006/relationships" id="264" r:id="R7d54ee265d814db2"/>
+    <p:sldId xmlns:r="http://schemas.openxmlformats.org/officeDocument/2006/relationships" id="265" r:id="Rd5a094dd21bd4e0e"/>
+    <p:sldId xmlns:r="http://schemas.openxmlformats.org/officeDocument/2006/relationships" id="266" r:id="R8a229d25458b4658"/>
   </p:sldIdLst>
   <p:sldSz cx="12192000" cy="6858000"/>
   <p:notesSz cx="6858000" cy="9144000"/>
@@ -452,7 +452,7 @@
           <a:lstStyle xmlns:a="http://schemas.openxmlformats.org/drawingml/2006/main"/>
           <a:p xmlns:a="http://schemas.openxmlformats.org/drawingml/2006/main">
             <a:r>
-              <a:t>As websites expose tools directly to browser agents, a successful call is only the beginning. Agent SNR—signal-to-noise ratio—shows what agents could do, what they actually did, where a human took over, and what happened next.</a:t>
+              <a:t>Agent SNR—signal-to-noise ratio—shows what agents did, invites structured testimony about what worked or was missing, and proves what happened after the human checkpoint.</a:t>
             </a:r>
           </a:p>
           <a:p xmlns:a="http://schemas.openxmlformats.org/drawingml/2006/main">
@@ -547,7 +547,7 @@
           <a:lstStyle xmlns:a="http://schemas.openxmlformats.org/drawingml/2006/main"/>
           <a:p xmlns:a="http://schemas.openxmlformats.org/drawingml/2006/main">
             <a:r>
-              <a:t>The browser suite covers real classic checkout, cross-tab cart synchronization, bounded Workflow Replay, direct and influenced attribution, and human-only exclusion. Woo lifecycle tests cover unpaid and paid states, partial and full refunds, cancellation, and provenance-negative lines. The exact release ZIP was verified across three WordPress/WooCommerce environments.</a:t>
+              <a:t>The browser suite now includes guide discovery, automatic missed-demand recording, linked feedback, provenance labels, same-session isolation, real classic checkout, and existing replay/cart/attribution boundaries. PHP tests cover schema, privacy, OOS analysis, evidence scope, metric enrichment, output budgets, and database-enforced feedback slots.</a:t>
             </a:r>
           </a:p>
           <a:p xmlns:a="http://schemas.openxmlformats.org/drawingml/2006/main">
@@ -637,7 +637,7 @@
           <a:lstStyle xmlns:a="http://schemas.openxmlformats.org/drawingml/2006/main"/>
           <a:p xmlns:a="http://schemas.openxmlformats.org/drawingml/2006/main">
             <a:r>
-              <a:t>The memorable idea is not merely AI shopping. It is a website exposing useful agent capabilities while giving its operator the evidence and control needed to run them responsibly. The hosted top-level route is the intended judging path; Docker reproduces the complete local loop; Playground proves plugin portability while iframe tool discovery is not claimed.</a:t>
+              <a:t>The memorable idea is a website that can teach agents how to use it, record missed demand even when the agent stays silent, receive honest structured feedback, and prove the business outcome without collecting the conversation or weakening human authority.</a:t>
             </a:r>
           </a:p>
           <a:p xmlns:a="http://schemas.openxmlformats.org/drawingml/2006/main">
@@ -737,7 +737,7 @@
           <a:lstStyle xmlns:a="http://schemas.openxmlformats.org/drawingml/2006/main"/>
           <a:p xmlns:a="http://schemas.openxmlformats.org/drawingml/2006/main">
             <a:r>
-              <a:t>Most integrations stop at ‘the tool succeeded.’ That does not tell a merchant whether the customer bought, abandoned, refunded, or bought something unrelated. Agent SNR follows the evidence chain into the verified business outcome.</a:t>
+              <a:t>A search tool can succeed while returning no usable product. Agent SNR records that missed demand at the source, then keeps the agent’s explanation separate from the catalog and WooCommerce facts that the site can verify.</a:t>
             </a:r>
           </a:p>
           <a:p xmlns:a="http://schemas.openxmlformats.org/drawingml/2006/main">
@@ -752,12 +752,17 @@
           </a:p>
           <a:p xmlns:a="http://schemas.openxmlformats.org/drawingml/2006/main">
             <a:r>
-              <a:t>- README.md</a:t>
-            </a:r>
-          </a:p>
-          <a:p xmlns:a="http://schemas.openxmlformats.org/drawingml/2006/main">
-            <a:r>
               <a:t>- PRODUCT.md</a:t>
+            </a:r>
+          </a:p>
+          <a:p xmlns:a="http://schemas.openxmlformats.org/drawingml/2006/main">
+            <a:r>
+              <a:t>- demo/HACKATHON_RUNBOOK.md</a:t>
+            </a:r>
+          </a:p>
+          <a:p xmlns:a="http://schemas.openxmlformats.org/drawingml/2006/main">
+            <a:r>
+              <a:t>- submission/testing-instructions.md</a:t>
             </a:r>
           </a:p>
         </p:txBody>
@@ -827,7 +832,7 @@
           <a:lstStyle xmlns:a="http://schemas.openxmlformats.org/drawingml/2006/main"/>
           <a:p xmlns:a="http://schemas.openxmlformats.org/drawingml/2006/main">
             <a:r>
-              <a:t>The investigation pattern is familiar, but the object being observed is new. Agent SNR combines journey investigation, operational health, and business outcomes around the website’s own WebMCP tools. The comparison is conceptual; no third-party integration is claimed.</a:t>
+              <a:t>The investigation pattern is familiar, but the observed object is new. Agent SNR combines journey replay, operational health, direct agent feedback, and business outcomes around the website’s own WebMCP tools. The comparison is conceptual; no third-party integration is claimed.</a:t>
             </a:r>
           </a:p>
           <a:p xmlns:a="http://schemas.openxmlformats.org/drawingml/2006/main">
@@ -917,7 +922,7 @@
           <a:lstStyle xmlns:a="http://schemas.openxmlformats.org/drawingml/2006/main"/>
           <a:p xmlns:a="http://schemas.openxmlformats.org/drawingml/2006/main">
             <a:r>
-              <a:t>There are two independent top-level WebMCP surfaces: an 11-tool storefront and an 8-tool Agent SNR monitor, both generated from one first-party catalog. The gateway records one start and one terminal outcome. WooCommerce remains the source of order and refund truth. Human checkout is correlated evidence, not an agent workflow.</a:t>
+              <a:t>Two independent top-level WebMCP surfaces expose 13 storefront tools and 9 Agent SNR tools from one first-party catalog. The guide is shared by people and agents. WordPress records automatic opportunity evidence and structured agent testimony separately; catalog and WooCommerce facts resolve the verified measurements.</a:t>
             </a:r>
           </a:p>
           <a:p xmlns:a="http://schemas.openxmlformats.org/drawingml/2006/main">
@@ -932,11 +937,6 @@
           </a:p>
           <a:p xmlns:a="http://schemas.openxmlformats.org/drawingml/2006/main">
             <a:r>
-              <a:t>- README.md</a:t>
-            </a:r>
-          </a:p>
-          <a:p xmlns:a="http://schemas.openxmlformats.org/drawingml/2006/main">
-            <a:r>
               <a:t>- plugin/wmcp-agentops/src/Contract/ToolName.php</a:t>
             </a:r>
           </a:p>
@@ -947,12 +947,17 @@
           </a:p>
           <a:p xmlns:a="http://schemas.openxmlformats.org/drawingml/2006/main">
             <a:r>
+              <a:t>- plugin/wmcp-agentops/src/Guidance/AgentGuide.php</a:t>
+            </a:r>
+          </a:p>
+          <a:p xmlns:a="http://schemas.openxmlformats.org/drawingml/2006/main">
+            <a:r>
+              <a:t>- plugin/wmcp-agentops/src/Analytics/SignalService.php</a:t>
+            </a:r>
+          </a:p>
+          <a:p xmlns:a="http://schemas.openxmlformats.org/drawingml/2006/main">
+            <a:r>
               <a:t>- plugin/wmcp-agentops/src/WebMCP/ExecutionController.php</a:t>
-            </a:r>
-          </a:p>
-          <a:p xmlns:a="http://schemas.openxmlformats.org/drawingml/2006/main">
-            <a:r>
-              <a:t>- plugin/wmcp-agentops/src/Privacy/Redactor.php</a:t>
             </a:r>
           </a:p>
         </p:txBody>
@@ -1022,7 +1027,7 @@
           <a:lstStyle xmlns:a="http://schemas.openxmlformats.org/drawingml/2006/main"/>
           <a:p xmlns:a="http://schemas.openxmlformats.org/drawingml/2006/main">
             <a:r>
-              <a:t>The agent can reduce work without crossing the consequential boundary. It never places an order, accepts terms, submits customer details, charges, cancels, or refunds. The human checkpoint is deliberate, and the ledger stores bounded operational facts rather than the conversation or customer data.</a:t>
+              <a:t>The agent can reduce work and report friction without crossing the consequential boundary. It never places an order, accepts terms, submits customer details, charges, cancels, or refunds. Feedback is bounded testimony; the human decision and WooCommerce outcome remain separate facts.</a:t>
             </a:r>
           </a:p>
           <a:p xmlns:a="http://schemas.openxmlformats.org/drawingml/2006/main">
@@ -1042,7 +1047,12 @@
           </a:p>
           <a:p xmlns:a="http://schemas.openxmlformats.org/drawingml/2006/main">
             <a:r>
-              <a:t>- plugin/wmcp-agentops/src/Privacy/Redactor.php</a:t>
+              <a:t>- plugin/wmcp-agentops/src/Guidance/AgentGuide.php</a:t>
+            </a:r>
+          </a:p>
+          <a:p xmlns:a="http://schemas.openxmlformats.org/drawingml/2006/main">
+            <a:r>
+              <a:t>- plugin/wmcp-agentops/src/Analytics/FeedbackMetricResolver.php</a:t>
             </a:r>
           </a:p>
           <a:p xmlns:a="http://schemas.openxmlformats.org/drawingml/2006/main">
@@ -1117,7 +1127,7 @@
           <a:lstStyle xmlns:a="http://schemas.openxmlformats.org/drawingml/2006/main"/>
           <a:p xmlns:a="http://schemas.openxmlformats.org/drawingml/2006/main">
             <a:r>
-              <a:t>The current implementation proves the pattern with commerce. The same event-to-outcome loop can trace availability search to a human-confirmed booking, support diagnosis to escalation and resolution, or course discovery to enrollment and refund. Those are product directions, not claimed v0.1 features.</a:t>
+              <a:t>The current implementation proves the pattern with commerce: what happened, what broke, whether it mattered, what demand the site missed, what the agent experienced, and what the operator can change. The same evidence loop can extend to other WordPress workflows; those extensions are direction, not v0.1 claims.</a:t>
             </a:r>
           </a:p>
           <a:p xmlns:a="http://schemas.openxmlformats.org/drawingml/2006/main">
@@ -1207,7 +1217,7 @@
           <a:lstStyle xmlns:a="http://schemas.openxmlformats.org/drawingml/2006/main"/>
           <a:p xmlns:a="http://schemas.openxmlformats.org/drawingml/2006/main">
             <a:r>
-              <a:t>Architecture is easy to draw. The real test is whether one browser session can carry a shopper from evidence to a human order—and then give the merchant a trustworthy explanation. Start fresh, keep the same browser profile through checkout and the public Agent SNR monitor, and run these four stations in order.</a:t>
+              <a:t>The submitted run begins with the guide, records a real zero-result IPX5 opportunity under $100, recovers with two IPX4 alternatives, records linked agent feedback at handoff, then lets the human place the no-charge WooCommerce order. Agent SNR proves the outcome and restricts the next run.</a:t>
             </a:r>
           </a:p>
           <a:p xmlns:a="http://schemas.openxmlformats.org/drawingml/2006/main">
@@ -1307,7 +1317,7 @@
           <a:lstStyle xmlns:a="http://schemas.openxmlformats.org/drawingml/2006/main"/>
           <a:p xmlns:a="http://schemas.openxmlformats.org/drawingml/2006/main">
             <a:r>
-              <a:t>This is the real storefront after the tool sequence. The shopper can see the grounded products and the completed workflow rail. The agent has changed only the reversible session cart and prepared a checkout URL; no order exists until the human completes WooCommerce checkout.</a:t>
+              <a:t>The same canonical Agent Guide is rendered for the shopper and returned to the agent. It says where to start, which effects are reversible, what the person must do, what data is excluded, when feedback helps, and that at most two reports are accepted per workflow.</a:t>
             </a:r>
           </a:p>
           <a:p xmlns:a="http://schemas.openxmlformats.org/drawingml/2006/main">
@@ -1322,17 +1332,22 @@
           </a:p>
           <a:p xmlns:a="http://schemas.openxmlformats.org/drawingml/2006/main">
             <a:r>
-              <a:t>- submission/demo-screenshots/02-storefront-evidence.png</a:t>
-            </a:r>
-          </a:p>
-          <a:p xmlns:a="http://schemas.openxmlformats.org/drawingml/2006/main">
-            <a:r>
-              <a:t>- README.md</a:t>
-            </a:r>
-          </a:p>
-          <a:p xmlns:a="http://schemas.openxmlformats.org/drawingml/2006/main">
-            <a:r>
-              <a:t>- submission/testing-instructions.md</a:t>
+              <a:t>- submission/demo-screenshots/02-agent-guide.png</a:t>
+            </a:r>
+          </a:p>
+          <a:p xmlns:a="http://schemas.openxmlformats.org/drawingml/2006/main">
+            <a:r>
+              <a:t>- submission/demo-screenshots/03-zero-result-opportunity.png</a:t>
+            </a:r>
+          </a:p>
+          <a:p xmlns:a="http://schemas.openxmlformats.org/drawingml/2006/main">
+            <a:r>
+              <a:t>- submission/demo-screenshots/04-agent-feedback-handoff.png</a:t>
+            </a:r>
+          </a:p>
+          <a:p xmlns:a="http://schemas.openxmlformats.org/drawingml/2006/main">
+            <a:r>
+              <a:t>- plugin/wmcp-agentops/src/Guidance/AgentGuide.php</a:t>
             </a:r>
           </a:p>
         </p:txBody>
@@ -1402,7 +1417,7 @@
           <a:lstStyle xmlns:a="http://schemas.openxmlformats.org/drawingml/2006/main"/>
           <a:p xmlns:a="http://schemas.openxmlformats.org/drawingml/2006/main">
             <a:r>
-              <a:t>Agent SNR would rather say ‘unattributed’ than invent revenue. Direct requires matching agent cart evidence plus checkout handoff; assisted requires matching cart evidence; influenced requires matching product evidence; otherwise there is no match. Refunds reduce net. The operator can disable a storefront tool only for this demo session and later clear that override.</a:t>
+              <a:t>The Signals view shows the same demand group twice: zero results exist without feedback, while low coverage is corroborated by one agent report. Site measurements later verify the two products, IPX4 ceiling, paid order, and value. The opinion itself is never promoted to fact or allowed to change attribution.</a:t>
             </a:r>
           </a:p>
           <a:p xmlns:a="http://schemas.openxmlformats.org/drawingml/2006/main">
@@ -1417,27 +1432,22 @@
           </a:p>
           <a:p xmlns:a="http://schemas.openxmlformats.org/drawingml/2006/main">
             <a:r>
-              <a:t>- submission/demo-screenshots/05-workflow-replay.png</a:t>
-            </a:r>
-          </a:p>
-          <a:p xmlns:a="http://schemas.openxmlformats.org/drawingml/2006/main">
-            <a:r>
-              <a:t>- submission/demo-screenshots/07-refund-net-outcome.png</a:t>
-            </a:r>
-          </a:p>
-          <a:p xmlns:a="http://schemas.openxmlformats.org/drawingml/2006/main">
-            <a:r>
-              <a:t>- submission/demo-screenshots/06-session-controls.png</a:t>
+              <a:t>- submission/demo-screenshots/07-opportunity-signals.png</a:t>
+            </a:r>
+          </a:p>
+          <a:p xmlns:a="http://schemas.openxmlformats.org/drawingml/2006/main">
+            <a:r>
+              <a:t>- submission/demo-screenshots/08-workflow-replay.png</a:t>
+            </a:r>
+          </a:p>
+          <a:p xmlns:a="http://schemas.openxmlformats.org/drawingml/2006/main">
+            <a:r>
+              <a:t>- plugin/wmcp-agentops/src/Analytics/SignalService.php</a:t>
             </a:r>
           </a:p>
           <a:p xmlns:a="http://schemas.openxmlformats.org/drawingml/2006/main">
             <a:r>
               <a:t>- plugin/wmcp-agentops/src/WooCommerce/AttributionRules.php</a:t>
-            </a:r>
-          </a:p>
-          <a:p xmlns:a="http://schemas.openxmlformats.org/drawingml/2006/main">
-            <a:r>
-              <a:t>- PRODUCT.md</a:t>
             </a:r>
           </a:p>
         </p:txBody>
@@ -1505,7 +1515,7 @@
   </p:cSld>
   <p:clrMap bg1="lt1" tx1="dk1" bg2="lt2" tx2="dk2" accent1="accent1" accent2="accent2" accent3="accent3" accent4="accent4" accent5="accent5" accent6="accent6" hlink="hlink" folHlink="folHlink"/>
   <p:sldLayoutIdLst>
-    <p:sldLayoutId xmlns:r="http://schemas.openxmlformats.org/officeDocument/2006/relationships" id="2147483649" r:id="R267956cda3d64b50"/>
+    <p:sldLayoutId xmlns:r="http://schemas.openxmlformats.org/officeDocument/2006/relationships" id="2147483649" r:id="Rbe18ffa54d974590"/>
   </p:sldLayoutIdLst>
   <p:txStyles>
     <p:titleStyle>
@@ -2254,7 +2264,7 @@
         </p:spPr>
         <p:txBody>
           <a:bodyPr xmlns:a="http://schemas.openxmlformats.org/drawingml/2006/main" lIns="0" tIns="0" rIns="0" bIns="0" anchor="t">
-            <a:normAutofit fontScale="100000"/>
+            <a:normAutofit fontScale="98039"/>
           </a:bodyPr>
           <a:lstStyle xmlns:a="http://schemas.openxmlformats.org/drawingml/2006/main"/>
           <a:p xmlns:a="http://schemas.openxmlformats.org/drawingml/2006/main">
@@ -2302,7 +2312,31 @@
                 <a:ea typeface="Helvetica Neue"/>
                 <a:cs typeface="Helvetica Neue"/>
               </a:rPr>
-              <a:t>Prove what happened next.</a:t>
+              <a:t>Hear what they experienced.</a:t>
+            </a:r>
+          </a:p>
+          <a:p xmlns:a="http://schemas.openxmlformats.org/drawingml/2006/main">
+            <a:pPr algn="l">
+              <a:buNone/>
+              <a:defRPr sz="2550" b="1" i="0">
+                <a:solidFill>
+                  <a:srgbClr val="111111"/>
+                </a:solidFill>
+                <a:latin typeface="Helvetica Neue"/>
+                <a:ea typeface="Helvetica Neue"/>
+                <a:cs typeface="Helvetica Neue"/>
+              </a:defRPr>
+            </a:pPr>
+            <a:r>
+              <a:rPr sz="2550" b="1" i="0">
+                <a:solidFill>
+                  <a:srgbClr val="111111"/>
+                </a:solidFill>
+                <a:latin typeface="Helvetica Neue"/>
+                <a:ea typeface="Helvetica Neue"/>
+                <a:cs typeface="Helvetica Neue"/>
+              </a:rPr>
+              <a:t>Discover what your site is missing.</a:t>
             </a:r>
           </a:p>
         </p:txBody>
@@ -2401,7 +2435,7 @@
       </p:sp>
       <p:cxnSp>
         <p:nvCxnSpPr>
-          <p:cNvPr id="37" name=""/>
+          <p:cNvPr id="51" name=""/>
           <p:cNvCxnSpPr/>
           <p:nvPr/>
         </p:nvCxnSpPr>
@@ -2475,7 +2509,7 @@
                 <a:ea typeface="Menlo"/>
                 <a:cs typeface="Menlo"/>
               </a:rPr>
-              <a:t>STOREFRONT → AGENT → HUMAN → VERIFIED OUTCOME</a:t>
+              <a:t>GUIDE → AGENT → HUMAN → VERIFIED OUTCOME</a:t>
             </a:r>
           </a:p>
         </p:txBody>
@@ -2688,7 +2722,7 @@
       </p:sp>
       <p:cxnSp>
         <p:nvCxnSpPr>
-          <p:cNvPr id="92" name=""/>
+          <p:cNvPr id="136" name=""/>
           <p:cNvCxnSpPr/>
           <p:nvPr/>
         </p:nvCxnSpPr>
@@ -2880,14 +2914,14 @@
                 <a:ea typeface="Helvetica Neue"/>
                 <a:cs typeface="Helvetica Neue"/>
               </a:rPr>
-              <a:t>79</a:t>
+              <a:t>91</a:t>
             </a:r>
           </a:p>
         </p:txBody>
       </p:sp>
       <p:cxnSp>
         <p:nvCxnSpPr>
-          <p:cNvPr id="96" name=""/>
+          <p:cNvPr id="140" name=""/>
           <p:cNvCxnSpPr/>
           <p:nvPr/>
         </p:nvCxnSpPr>
@@ -3020,14 +3054,14 @@
                 <a:ea typeface="Helvetica Neue"/>
                 <a:cs typeface="Helvetica Neue"/>
               </a:rPr>
-              <a:t>68</a:t>
+              <a:t>102</a:t>
             </a:r>
           </a:p>
         </p:txBody>
       </p:sp>
       <p:cxnSp>
         <p:nvCxnSpPr>
-          <p:cNvPr id="99" name=""/>
+          <p:cNvPr id="143" name=""/>
           <p:cNvCxnSpPr/>
           <p:nvPr/>
         </p:nvCxnSpPr>
@@ -3101,7 +3135,7 @@
                 <a:ea typeface="Helvetica Neue"/>
                 <a:cs typeface="Helvetica Neue"/>
               </a:rPr>
-              <a:t>PHP tests / 606 assertions</a:t>
+              <a:t>PHP tests / 858 assertions</a:t>
             </a:r>
           </a:p>
         </p:txBody>
@@ -3160,14 +3194,14 @@
                 <a:ea typeface="Helvetica Neue"/>
                 <a:cs typeface="Helvetica Neue"/>
               </a:rPr>
-              <a:t>14/14</a:t>
+              <a:t>15/15</a:t>
             </a:r>
           </a:p>
         </p:txBody>
       </p:sp>
       <p:cxnSp>
         <p:nvCxnSpPr>
-          <p:cNvPr id="102" name=""/>
+          <p:cNvPr id="146" name=""/>
           <p:cNvCxnSpPr/>
           <p:nvPr/>
         </p:nvCxnSpPr>
@@ -3307,7 +3341,7 @@
       </p:sp>
       <p:cxnSp>
         <p:nvCxnSpPr>
-          <p:cNvPr id="105" name=""/>
+          <p:cNvPr id="149" name=""/>
           <p:cNvCxnSpPr/>
           <p:nvPr/>
         </p:nvCxnSpPr>
@@ -3447,7 +3481,7 @@
       </p:sp>
       <p:cxnSp>
         <p:nvCxnSpPr>
-          <p:cNvPr id="108" name=""/>
+          <p:cNvPr id="152" name=""/>
           <p:cNvCxnSpPr/>
           <p:nvPr/>
         </p:nvCxnSpPr>
@@ -3587,7 +3621,7 @@
       </p:sp>
       <p:cxnSp>
         <p:nvCxnSpPr>
-          <p:cNvPr id="111" name=""/>
+          <p:cNvPr id="155" name=""/>
           <p:cNvCxnSpPr/>
           <p:nvPr/>
         </p:nvCxnSpPr>
@@ -3749,7 +3783,7 @@
                 <a:ea typeface="Menlo"/>
                 <a:cs typeface="Menlo"/>
               </a:rPr>
-              <a:t>BUILD TRUST INTO THE AGENT LOOP</a:t>
+              <a:t>BUILD FEEDBACK INTO THE AGENT LOOP</a:t>
             </a:r>
           </a:p>
         </p:txBody>
@@ -3832,7 +3866,7 @@
                 <a:ea typeface="Helvetica Neue"/>
                 <a:cs typeface="Helvetica Neue"/>
               </a:rPr>
-              <a:t>journey a provable outcome.</a:t>
+              <a:t>journey a voice—and a provable outcome.</a:t>
             </a:r>
           </a:p>
         </p:txBody>
@@ -4044,7 +4078,7 @@
                 <a:ea typeface="Menlo"/>
                 <a:cs typeface="Menlo"/>
               </a:rPr>
-              <a:t>Public storefront + Agent SNR</a:t>
+              <a:t>13 storefront + 9 Agent SNR tools</a:t>
             </a:r>
           </a:p>
         </p:txBody>
@@ -4527,14 +4561,14 @@
                 <a:ea typeface="Helvetica Neue"/>
                 <a:cs typeface="Helvetica Neue"/>
               </a:rPr>
-              <a:t>Expose safe tools.  Observe real workflows.  Keep humans in control.  Improve the next run.</a:t>
+              <a:t>Guide the agent.  Observe missed demand.  Hear feedback.  Verify outcomes.  Improve the next run.</a:t>
             </a:r>
           </a:p>
         </p:txBody>
       </p:sp>
       <p:cxnSp>
         <p:nvCxnSpPr>
-          <p:cNvPr id="82" name=""/>
+          <p:cNvPr id="114" name=""/>
           <p:cNvCxnSpPr/>
           <p:nvPr/>
         </p:nvCxnSpPr>
@@ -4814,14 +4848,14 @@
                 <a:ea typeface="Helvetica Neue"/>
                 <a:cs typeface="Helvetica Neue"/>
               </a:rPr>
-              <a:t>A successful tool call can still hide a failed journey.</a:t>
+              <a:t>A successful tool call can still hide missed demand.</a:t>
             </a:r>
           </a:p>
         </p:txBody>
       </p:sp>
       <p:cxnSp>
         <p:nvCxnSpPr>
-          <p:cNvPr id="45" name=""/>
+          <p:cNvPr id="57" name=""/>
           <p:cNvCxnSpPr/>
           <p:nvPr/>
         </p:nvCxnSpPr>
@@ -4961,7 +4995,7 @@
       </p:sp>
       <p:cxnSp>
         <p:nvCxnSpPr>
-          <p:cNvPr id="48" name=""/>
+          <p:cNvPr id="60" name=""/>
           <p:cNvCxnSpPr/>
           <p:nvPr/>
         </p:nvCxnSpPr>
@@ -5127,7 +5161,7 @@
                 <a:ea typeface="Helvetica Neue"/>
                 <a:cs typeface="Helvetica Neue"/>
               </a:rPr>
-              <a:t>Product found</a:t>
+              <a:t>Search succeeded</a:t>
             </a:r>
           </a:p>
         </p:txBody>
@@ -5278,7 +5312,7 @@
                 <a:ea typeface="Helvetica Neue"/>
                 <a:cs typeface="Helvetica Neue"/>
               </a:rPr>
-              <a:t>Cart changed</a:t>
+              <a:t>Zero matches</a:t>
             </a:r>
           </a:p>
         </p:txBody>
@@ -5523,7 +5557,7 @@
                 <a:ea typeface="Menlo"/>
                 <a:cs typeface="Menlo"/>
               </a:rPr>
-              <a:t>PAID</a:t>
+              <a:t>RELAXED CONSTRAINTS</a:t>
             </a:r>
           </a:p>
         </p:txBody>
@@ -5617,7 +5651,7 @@
                 <a:ea typeface="Menlo"/>
                 <a:cs typeface="Menlo"/>
               </a:rPr>
-              <a:t>ABANDONED</a:t>
+              <a:t>AGENT FEEDBACK</a:t>
             </a:r>
           </a:p>
         </p:txBody>
@@ -5711,7 +5745,7 @@
                 <a:ea typeface="Menlo"/>
                 <a:cs typeface="Menlo"/>
               </a:rPr>
-              <a:t>REFUNDED</a:t>
+              <a:t>HUMAN ORDER</a:t>
             </a:r>
           </a:p>
         </p:txBody>
@@ -5805,7 +5839,7 @@
                 <a:ea typeface="Menlo"/>
                 <a:cs typeface="Menlo"/>
               </a:rPr>
-              <a:t>BOUGHT SOMETHING ELSE</a:t>
+              <a:t>SHOPPER LEFT</a:t>
             </a:r>
           </a:p>
         </p:txBody>
@@ -5864,7 +5898,7 @@
                 <a:ea typeface="Helvetica Neue"/>
                 <a:cs typeface="Helvetica Neue"/>
               </a:rPr>
-              <a:t>Operators need the chain, not another log.</a:t>
+              <a:t>Operators need the missing signal—not another success log.</a:t>
             </a:r>
           </a:p>
         </p:txBody>
@@ -6018,7 +6052,7 @@
       </p:sp>
       <p:cxnSp>
         <p:nvCxnSpPr>
-          <p:cNvPr id="75" name=""/>
+          <p:cNvPr id="109" name=""/>
           <p:cNvCxnSpPr/>
           <p:nvPr/>
         </p:nvCxnSpPr>
@@ -6335,7 +6369,7 @@
       </p:sp>
       <p:cxnSp>
         <p:nvCxnSpPr>
-          <p:cNvPr id="81" name=""/>
+          <p:cNvPr id="115" name=""/>
           <p:cNvCxnSpPr/>
           <p:nvPr/>
         </p:nvCxnSpPr>
@@ -6534,7 +6568,7 @@
       </p:sp>
       <p:cxnSp>
         <p:nvCxnSpPr>
-          <p:cNvPr id="85" name=""/>
+          <p:cNvPr id="119" name=""/>
           <p:cNvCxnSpPr/>
           <p:nvPr/>
         </p:nvCxnSpPr>
@@ -6733,7 +6767,7 @@
       </p:sp>
       <p:cxnSp>
         <p:nvCxnSpPr>
-          <p:cNvPr id="89" name=""/>
+          <p:cNvPr id="123" name=""/>
           <p:cNvCxnSpPr/>
           <p:nvPr/>
         </p:nvCxnSpPr>
@@ -6875,7 +6909,7 @@
         </p:spPr>
         <p:txBody>
           <a:bodyPr xmlns:a="http://schemas.openxmlformats.org/drawingml/2006/main" lIns="0" tIns="0" rIns="0" bIns="0" anchor="t">
-            <a:normAutofit fontScale="86074"/>
+            <a:normAutofit fontScale="83534"/>
           </a:bodyPr>
           <a:lstStyle xmlns:a="http://schemas.openxmlformats.org/drawingml/2006/main"/>
           <a:p xmlns:a="http://schemas.openxmlformats.org/drawingml/2006/main">
@@ -6899,7 +6933,7 @@
                 <a:ea typeface="Helvetica Neue"/>
                 <a:cs typeface="Helvetica Neue"/>
               </a:rPr>
-              <a:t>WebMCP inventory  ·  human checkpoints  ·  deterministic WooCommerce evidence</a:t>
+              <a:t>WebMCP inventory  ·  observed demand  ·  direct agent feedback  ·  verified outcomes</a:t>
             </a:r>
           </a:p>
         </p:txBody>
@@ -6958,7 +6992,7 @@
                 <a:ea typeface="Menlo"/>
                 <a:cs typeface="Menlo"/>
               </a:rPr>
-              <a:t>WORKFLOW REPLAY IS A REDACTED EVENT TIMELINE—NOT A SCREEN RECORDING.</a:t>
+              <a:t>OBSERVED, REPORTED, AND VERIFIED EVIDENCE STAY DISTINCT—NO SCREEN RECORDING.</a:t>
             </a:r>
           </a:p>
         </p:txBody>
@@ -7105,14 +7139,14 @@
                 <a:ea typeface="Helvetica Neue"/>
                 <a:cs typeface="Helvetica Neue"/>
               </a:rPr>
-              <a:t>The website authorizes every action—and only credits verified outcomes.</a:t>
+              <a:t>The website guides every action—and keeps testimony separate from proof.</a:t>
             </a:r>
           </a:p>
         </p:txBody>
       </p:sp>
       <p:cxnSp>
         <p:nvCxnSpPr>
-          <p:cNvPr id="87" name=""/>
+          <p:cNvPr id="113" name=""/>
           <p:cNvCxnSpPr/>
           <p:nvPr/>
         </p:nvCxnSpPr>
@@ -7561,7 +7595,7 @@
       </p:sp>
       <p:cxnSp>
         <p:nvCxnSpPr>
-          <p:cNvPr id="97" name=""/>
+          <p:cNvPr id="123" name=""/>
           <p:cNvCxnSpPr/>
           <p:nvPr/>
         </p:nvCxnSpPr>
@@ -7804,7 +7838,7 @@
         </p:spPr>
         <p:txBody>
           <a:bodyPr xmlns:a="http://schemas.openxmlformats.org/drawingml/2006/main" lIns="0" tIns="0" rIns="0" bIns="0" anchor="t">
-            <a:normAutofit fontScale="89744"/>
+            <a:normAutofit fontScale="100000"/>
           </a:bodyPr>
           <a:lstStyle xmlns:a="http://schemas.openxmlformats.org/drawingml/2006/main"/>
           <a:p xmlns:a="http://schemas.openxmlformats.org/drawingml/2006/main">
@@ -7828,7 +7862,7 @@
                 <a:ea typeface="Menlo"/>
                 <a:cs typeface="Menlo"/>
               </a:rPr>
-              <a:t>Human sees the same result</a:t>
+              <a:t>Reads the Agent Guide</a:t>
             </a:r>
           </a:p>
         </p:txBody>
@@ -7957,7 +7991,7 @@
         </p:spPr>
         <p:txBody>
           <a:bodyPr xmlns:a="http://schemas.openxmlformats.org/drawingml/2006/main" lIns="0" tIns="0" rIns="0" bIns="0" anchor="t">
-            <a:normAutofit fontScale="92596"/>
+            <a:normAutofit fontScale="100000"/>
           </a:bodyPr>
           <a:lstStyle xmlns:a="http://schemas.openxmlformats.org/drawingml/2006/main"/>
           <a:p xmlns:a="http://schemas.openxmlformats.org/drawingml/2006/main">
@@ -7981,7 +8015,7 @@
                 <a:ea typeface="Menlo"/>
                 <a:cs typeface="Menlo"/>
               </a:rPr>
-              <a:t>Policy-filtered manifest</a:t>
+              <a:t>13 storefront tools</a:t>
             </a:r>
           </a:p>
         </p:txBody>
@@ -8263,7 +8297,7 @@
         </p:spPr>
         <p:txBody>
           <a:bodyPr xmlns:a="http://schemas.openxmlformats.org/drawingml/2006/main" lIns="0" tIns="0" rIns="0" bIns="0" anchor="t">
-            <a:normAutofit fontScale="89744"/>
+            <a:normAutofit fontScale="100000"/>
           </a:bodyPr>
           <a:lstStyle xmlns:a="http://schemas.openxmlformats.org/drawingml/2006/main"/>
           <a:p xmlns:a="http://schemas.openxmlformats.org/drawingml/2006/main">
@@ -8287,7 +8321,7 @@
                 <a:ea typeface="Menlo"/>
                 <a:cs typeface="Menlo"/>
               </a:rPr>
-              <a:t>Schema · policy · rate limit</a:t>
+              <a:t>Schema · policy · rate</a:t>
             </a:r>
           </a:p>
         </p:txBody>
@@ -8663,7 +8697,7 @@
         </p:spPr>
         <p:txBody>
           <a:bodyPr xmlns:a="http://schemas.openxmlformats.org/drawingml/2006/main" lIns="0" tIns="0" rIns="0" bIns="0" anchor="t">
-            <a:normAutofit fontScale="95936"/>
+            <a:normAutofit fontScale="100000"/>
           </a:bodyPr>
           <a:lstStyle xmlns:a="http://schemas.openxmlformats.org/drawingml/2006/main"/>
           <a:p xmlns:a="http://schemas.openxmlformats.org/drawingml/2006/main">
@@ -8687,7 +8721,7 @@
                 <a:ea typeface="Helvetica Neue"/>
                 <a:cs typeface="Helvetica Neue"/>
               </a:rPr>
-              <a:t>Redacted evidence ledger</a:t>
+              <a:t>Signals ledger</a:t>
             </a:r>
           </a:p>
         </p:txBody>
@@ -8722,7 +8756,7 @@
         </p:spPr>
         <p:txBody>
           <a:bodyPr xmlns:a="http://schemas.openxmlformats.org/drawingml/2006/main" lIns="0" tIns="0" rIns="0" bIns="0" anchor="t">
-            <a:normAutofit fontScale="100000"/>
+            <a:normAutofit fontScale="90558"/>
           </a:bodyPr>
           <a:lstStyle xmlns:a="http://schemas.openxmlformats.org/drawingml/2006/main"/>
           <a:p xmlns:a="http://schemas.openxmlformats.org/drawingml/2006/main">
@@ -8746,7 +8780,7 @@
                 <a:ea typeface="Menlo"/>
                 <a:cs typeface="Menlo"/>
               </a:rPr>
-              <a:t>EVENTS · LINKS · GAPS</a:t>
+              <a:t>OBSERVED · REPORTED · VERIFIED</a:t>
             </a:r>
           </a:p>
         </p:txBody>
@@ -8875,7 +8909,7 @@
         </p:spPr>
         <p:txBody>
           <a:bodyPr xmlns:a="http://schemas.openxmlformats.org/drawingml/2006/main" lIns="0" tIns="0" rIns="0" bIns="0" anchor="t">
-            <a:normAutofit fontScale="100000"/>
+            <a:normAutofit fontScale="96881"/>
           </a:bodyPr>
           <a:lstStyle xmlns:a="http://schemas.openxmlformats.org/drawingml/2006/main"/>
           <a:p xmlns:a="http://schemas.openxmlformats.org/drawingml/2006/main">
@@ -8899,7 +8933,7 @@
                 <a:ea typeface="Menlo"/>
                 <a:cs typeface="Menlo"/>
               </a:rPr>
-              <a:t>REPLAY · HEALTH · NET</a:t>
+              <a:t>9 MONITOR TOOLS · REPLAY · NET</a:t>
             </a:r>
           </a:p>
         </p:txBody>
@@ -9050,7 +9084,7 @@
                 <a:ea typeface="Helvetica Neue"/>
                 <a:cs typeface="Helvetica Neue"/>
               </a:rPr>
-              <a:t>Outcome · latency · product IDs · currency/value · one-way hashes</a:t>
+              <a:t>Outcomes · canonical demand · feedback enums · evidence IDs · one-way hashes</a:t>
             </a:r>
           </a:p>
         </p:txBody>
@@ -9144,7 +9178,7 @@
         </p:spPr>
         <p:txBody>
           <a:bodyPr xmlns:a="http://schemas.openxmlformats.org/drawingml/2006/main" lIns="0" tIns="0" rIns="0" bIns="0" anchor="t">
-            <a:normAutofit fontScale="81911"/>
+            <a:normAutofit fontScale="71429"/>
           </a:bodyPr>
           <a:lstStyle xmlns:a="http://schemas.openxmlformats.org/drawingml/2006/main"/>
           <a:p xmlns:a="http://schemas.openxmlformats.org/drawingml/2006/main">
@@ -9168,7 +9202,7 @@
                 <a:ea typeface="Helvetica Neue"/>
                 <a:cs typeface="Helvetica Neue"/>
               </a:rPr>
-              <a:t>Prompts · identity · address · tokens · payment · DOM/video</a:t>
+              <a:t>Raw search/prompt · free text · identity · address · payment · DOM/video</a:t>
             </a:r>
           </a:p>
         </p:txBody>
@@ -9322,7 +9356,7 @@
       </p:sp>
       <p:cxnSp>
         <p:nvCxnSpPr>
-          <p:cNvPr id="28" name=""/>
+          <p:cNvPr id="34" name=""/>
           <p:cNvCxnSpPr/>
           <p:nvPr/>
         </p:nvCxnSpPr>
@@ -9608,7 +9642,7 @@
                 <a:ea typeface="Helvetica Neue"/>
                 <a:cs typeface="Helvetica Neue"/>
               </a:rPr>
-              <a:t>Find</a:t>
+              <a:t>Read guide</a:t>
             </a:r>
           </a:p>
           <a:p xmlns:a="http://schemas.openxmlformats.org/drawingml/2006/main">
@@ -9632,7 +9666,7 @@
                 <a:ea typeface="Helvetica Neue"/>
                 <a:cs typeface="Helvetica Neue"/>
               </a:rPr>
-              <a:t>Compare</a:t>
+              <a:t>Find · compare · cite policy</a:t>
             </a:r>
           </a:p>
           <a:p xmlns:a="http://schemas.openxmlformats.org/drawingml/2006/main">
@@ -9656,7 +9690,7 @@
                 <a:ea typeface="Helvetica Neue"/>
                 <a:cs typeface="Helvetica Neue"/>
               </a:rPr>
-              <a:t>Cite policy</a:t>
+              <a:t>Edit reversible cart</a:t>
             </a:r>
           </a:p>
           <a:p xmlns:a="http://schemas.openxmlformats.org/drawingml/2006/main">
@@ -9680,7 +9714,7 @@
                 <a:ea typeface="Helvetica Neue"/>
                 <a:cs typeface="Helvetica Neue"/>
               </a:rPr>
-              <a:t>Edit reversible cart</a:t>
+              <a:t>Report structured friction</a:t>
             </a:r>
           </a:p>
           <a:p xmlns:a="http://schemas.openxmlformats.org/drawingml/2006/main">
@@ -10270,7 +10304,7 @@
                 <a:ea typeface="Menlo"/>
                 <a:cs typeface="Menlo"/>
               </a:rPr>
-              <a:t>NEVER STORED: RAW PROMPTS · IDENTITY · ADDRESS · PAYMENT DETAILS</a:t>
+              <a:t>NEVER STORED: RAW SEARCH OR PROMPTS · FREE-TEXT FEEDBACK · IDENTITY · ADDRESS · PAYMENT</a:t>
             </a:r>
           </a:p>
         </p:txBody>
@@ -10424,7 +10458,7 @@
       </p:sp>
       <p:cxnSp>
         <p:nvCxnSpPr>
-          <p:cNvPr id="126" name=""/>
+          <p:cNvPr id="186" name=""/>
           <p:cNvCxnSpPr/>
           <p:nvPr/>
         </p:nvCxnSpPr>
@@ -10564,7 +10598,7 @@
       </p:sp>
       <p:cxnSp>
         <p:nvCxnSpPr>
-          <p:cNvPr id="129" name=""/>
+          <p:cNvPr id="189" name=""/>
           <p:cNvCxnSpPr/>
           <p:nvPr/>
         </p:nvCxnSpPr>
@@ -11419,7 +11453,7 @@
                 <a:ea typeface="Menlo"/>
                 <a:cs typeface="Menlo"/>
               </a:rPr>
-              <a:t>CAPABILITY SIGNALS</a:t>
+              <a:t>OBSERVED DEMAND · AGENT FEEDBACK</a:t>
             </a:r>
           </a:p>
         </p:txBody>
@@ -11789,7 +11823,7 @@
       </p:sp>
       <p:cxnSp>
         <p:nvCxnSpPr>
-          <p:cNvPr id="153" name=""/>
+          <p:cNvPr id="213" name=""/>
           <p:cNvCxnSpPr/>
           <p:nvPr/>
         </p:nvCxnSpPr>
@@ -12200,14 +12234,14 @@
                 <a:ea typeface="Helvetica Neue"/>
                 <a:cs typeface="Helvetica Neue"/>
               </a:rPr>
-              <a:t>One clean session tests success, honesty, attribution, and control.</a:t>
+              <a:t>One clean session tests discovery, missed demand, feedback, proof, and control.</a:t>
             </a:r>
           </a:p>
         </p:txBody>
       </p:sp>
       <p:cxnSp>
         <p:nvCxnSpPr>
-          <p:cNvPr id="39" name=""/>
+          <p:cNvPr id="47" name=""/>
           <p:cNvCxnSpPr/>
           <p:nvPr/>
         </p:nvCxnSpPr>
@@ -12347,28 +12381,26 @@
       </p:sp>
       <p:pic>
         <p:nvPicPr>
-          <p:cNvPr id="42" name=""/>
+          <p:cNvPr id="50" name=""/>
           <p:cNvPicPr>
             <a:picLocks xmlns:a="http://schemas.openxmlformats.org/drawingml/2006/main" noChangeAspect="1"/>
           </p:cNvPicPr>
           <p:nvPr/>
         </p:nvPicPr>
         <p:blipFill>
-          <a:blip xmlns:r="http://schemas.openxmlformats.org/officeDocument/2006/relationships" xmlns:a="http://schemas.openxmlformats.org/drawingml/2006/main" r:embed="Reecb667e3b9d41dc"/>
+          <a:blip xmlns:r="http://schemas.openxmlformats.org/officeDocument/2006/relationships" xmlns:a="http://schemas.openxmlformats.org/drawingml/2006/main" r:embed="R8898b70b423a43a8"/>
           <a:srcRect xmlns:a="http://schemas.openxmlformats.org/drawingml/2006/main" l="11607" t="0" r="11607" b="0"/>
           <a:stretch xmlns:a="http://schemas.openxmlformats.org/drawingml/2006/main">
             <a:fillRect l="0" t="0" r="0" b="0"/>
           </a:stretch>
         </p:blipFill>
         <p:spPr>
-          <a:xfrm xmlns:a="http://schemas.openxmlformats.org/drawingml/2006/main">
+          <a:xfrm xmlns:a="http://schemas.openxmlformats.org/drawingml/2006/main" flipH="0" flipV="0">
             <a:off x="6743700" y="1600200"/>
             <a:ext cx="4914900" cy="4000500"/>
           </a:xfrm>
           <a:prstGeom xmlns:a="http://schemas.openxmlformats.org/drawingml/2006/main" prst="roundRect">
-            <a:avLst>
-              <a:gd name="adj" fmla="val 2857"/>
-            </a:avLst>
+            <a:avLst/>
           </a:prstGeom>
         </p:spPr>
       </p:pic>
@@ -12518,7 +12550,7 @@
                 <a:ea typeface="Menlo"/>
                 <a:cs typeface="Menlo"/>
               </a:rPr>
-              <a:t>SHOP</a:t>
+              <a:t>START HERE</a:t>
             </a:r>
           </a:p>
         </p:txBody>
@@ -12577,7 +12609,7 @@
                 <a:ea typeface="Helvetica Neue"/>
                 <a:cs typeface="Helvetica Neue"/>
               </a:rPr>
-              <a:t>Search · compare · policy · cart</a:t>
+              <a:t>Read the Agent Guide</a:t>
             </a:r>
           </a:p>
         </p:txBody>
@@ -12728,7 +12760,7 @@
                 <a:ea typeface="Menlo"/>
                 <a:cs typeface="Menlo"/>
               </a:rPr>
-              <a:t>BE HONEST</a:t>
+              <a:t>OBSERVE</a:t>
             </a:r>
           </a:p>
         </p:txBody>
@@ -12787,7 +12819,7 @@
                 <a:ea typeface="Helvetica Neue"/>
                 <a:cs typeface="Helvetica Neue"/>
               </a:rPr>
-              <a:t>Record an unsupported alert</a:t>
+              <a:t>IPX5 search → zero; relax</a:t>
             </a:r>
           </a:p>
         </p:txBody>
@@ -12938,7 +12970,7 @@
                 <a:ea typeface="Menlo"/>
                 <a:cs typeface="Menlo"/>
               </a:rPr>
-              <a:t>HAND OFF</a:t>
+              <a:t>REPORT + HAND OFF</a:t>
             </a:r>
           </a:p>
         </p:txBody>
@@ -12997,7 +13029,7 @@
                 <a:ea typeface="Helvetica Neue"/>
                 <a:cs typeface="Helvetica Neue"/>
               </a:rPr>
-              <a:t>Human places a no-charge order</a:t>
+              <a:t>Feedback first; human places order</a:t>
             </a:r>
           </a:p>
         </p:txBody>
@@ -13148,7 +13180,7 @@
                 <a:ea typeface="Menlo"/>
                 <a:cs typeface="Menlo"/>
               </a:rPr>
-              <a:t>INVESTIGATE</a:t>
+              <a:t>VERIFY + CONTROL</a:t>
             </a:r>
           </a:p>
         </p:txBody>
@@ -13207,7 +13239,7 @@
                 <a:ea typeface="Helvetica Neue"/>
                 <a:cs typeface="Helvetica Neue"/>
               </a:rPr>
-              <a:t>Replay · attribute · restrict</a:t>
+              <a:t>Signals · replay · restrict</a:t>
             </a:r>
           </a:p>
         </p:txBody>
@@ -13299,7 +13331,7 @@
                 <a:ea typeface="Menlo"/>
                 <a:cs typeface="Menlo"/>
               </a:rPr>
-              <a:t>START FRESH DEMO → SAME BROWSER SCOPE → NO MIXED TEST TRAFFIC</a:t>
+              <a:t>GUIDE → ZERO RESULT → IPX4 RECOVERY → FEEDBACK → HUMAN ORDER → PROOF</a:t>
             </a:r>
           </a:p>
         </p:txBody>
@@ -13422,7 +13454,7 @@
         </p:spPr>
         <p:txBody>
           <a:bodyPr xmlns:a="http://schemas.openxmlformats.org/drawingml/2006/main" lIns="0" tIns="0" rIns="0" bIns="0" anchor="t">
-            <a:normAutofit fontScale="100000"/>
+            <a:normAutofit fontScale="89286"/>
           </a:bodyPr>
           <a:lstStyle xmlns:a="http://schemas.openxmlformats.org/drawingml/2006/main"/>
           <a:p xmlns:a="http://schemas.openxmlformats.org/drawingml/2006/main">
@@ -13446,14 +13478,14 @@
                 <a:ea typeface="Helvetica Neue"/>
                 <a:cs typeface="Helvetica Neue"/>
               </a:rPr>
-              <a:t>The agent’s actions remain visible to the shopper.</a:t>
+              <a:t>The guide, missed demand, and feedback remain visible to the shopper.</a:t>
             </a:r>
           </a:p>
         </p:txBody>
       </p:sp>
       <p:cxnSp>
         <p:nvCxnSpPr>
-          <p:cNvPr id="44" name=""/>
+          <p:cNvPr id="64" name=""/>
           <p:cNvCxnSpPr/>
           <p:nvPr/>
         </p:nvCxnSpPr>
@@ -13715,7 +13747,7 @@
         </p:spPr>
         <p:txBody>
           <a:bodyPr xmlns:a="http://schemas.openxmlformats.org/drawingml/2006/main" lIns="0" tIns="0" rIns="0" bIns="0" anchor="t">
-            <a:normAutofit fontScale="100000"/>
+            <a:normAutofit fontScale="89861"/>
           </a:bodyPr>
           <a:lstStyle xmlns:a="http://schemas.openxmlformats.org/drawingml/2006/main"/>
           <a:p xmlns:a="http://schemas.openxmlformats.org/drawingml/2006/main">
@@ -13739,7 +13771,7 @@
                 <a:ea typeface="Helvetica Neue"/>
                 <a:cs typeface="Helvetica Neue"/>
               </a:rPr>
-              <a:t>Search</a:t>
+              <a:t>Read Agent Guide</a:t>
             </a:r>
           </a:p>
           <a:p xmlns:a="http://schemas.openxmlformats.org/drawingml/2006/main">
@@ -13763,7 +13795,7 @@
                 <a:ea typeface="Helvetica Neue"/>
                 <a:cs typeface="Helvetica Neue"/>
               </a:rPr>
-              <a:t>Compare</a:t>
+              <a:t>Zero-result signal</a:t>
             </a:r>
           </a:p>
           <a:p xmlns:a="http://schemas.openxmlformats.org/drawingml/2006/main">
@@ -13787,7 +13819,7 @@
                 <a:ea typeface="Helvetica Neue"/>
                 <a:cs typeface="Helvetica Neue"/>
               </a:rPr>
-              <a:t>Return policy</a:t>
+              <a:t>Compare two IPX4 options</a:t>
             </a:r>
           </a:p>
           <a:p xmlns:a="http://schemas.openxmlformats.org/drawingml/2006/main">
@@ -13811,7 +13843,7 @@
                 <a:ea typeface="Helvetica Neue"/>
                 <a:cs typeface="Helvetica Neue"/>
               </a:rPr>
-              <a:t>Cart write</a:t>
+              <a:t>Linked feedback receipt</a:t>
             </a:r>
           </a:p>
           <a:p xmlns:a="http://schemas.openxmlformats.org/drawingml/2006/main">
@@ -13842,7 +13874,7 @@
       </p:sp>
       <p:cxnSp>
         <p:nvCxnSpPr>
-          <p:cNvPr id="50" name=""/>
+          <p:cNvPr id="70" name=""/>
           <p:cNvCxnSpPr/>
           <p:nvPr/>
         </p:nvCxnSpPr>
@@ -13892,7 +13924,7 @@
         </p:spPr>
         <p:txBody>
           <a:bodyPr xmlns:a="http://schemas.openxmlformats.org/drawingml/2006/main" lIns="0" tIns="0" rIns="0" bIns="0" anchor="t">
-            <a:normAutofit fontScale="77719"/>
+            <a:normAutofit fontScale="76923"/>
           </a:bodyPr>
           <a:lstStyle xmlns:a="http://schemas.openxmlformats.org/drawingml/2006/main"/>
           <a:p xmlns:a="http://schemas.openxmlformats.org/drawingml/2006/main">
@@ -13916,35 +13948,33 @@
                 <a:ea typeface="Menlo"/>
                 <a:cs typeface="Menlo"/>
               </a:rPr>
-              <a:t>REVERSIBLE UNTIL HUMAN CHECKPOINT</a:t>
+              <a:t>OBSERVED + REPORTED BEFORE THE HUMAN CHECKPOINT</a:t>
             </a:r>
           </a:p>
         </p:txBody>
       </p:sp>
       <p:pic>
         <p:nvPicPr>
-          <p:cNvPr id="52" name=""/>
+          <p:cNvPr id="72" name=""/>
           <p:cNvPicPr>
             <a:picLocks xmlns:a="http://schemas.openxmlformats.org/drawingml/2006/main" noChangeAspect="1"/>
           </p:cNvPicPr>
           <p:nvPr/>
         </p:nvPicPr>
         <p:blipFill>
-          <a:blip xmlns:r="http://schemas.openxmlformats.org/officeDocument/2006/relationships" xmlns:a="http://schemas.openxmlformats.org/drawingml/2006/main" r:embed="R6265239682d24715"/>
+          <a:blip xmlns:r="http://schemas.openxmlformats.org/officeDocument/2006/relationships" xmlns:a="http://schemas.openxmlformats.org/drawingml/2006/main" r:embed="R3991df8d44434100"/>
           <a:srcRect xmlns:a="http://schemas.openxmlformats.org/drawingml/2006/main" l="0" t="9356" r="0" b="9356"/>
           <a:stretch xmlns:a="http://schemas.openxmlformats.org/drawingml/2006/main">
             <a:fillRect l="0" t="0" r="0" b="0"/>
           </a:stretch>
         </p:blipFill>
         <p:spPr>
-          <a:xfrm xmlns:a="http://schemas.openxmlformats.org/drawingml/2006/main">
+          <a:xfrm xmlns:a="http://schemas.openxmlformats.org/drawingml/2006/main" flipH="0" flipV="0">
             <a:off x="3371850" y="1638300"/>
             <a:ext cx="8286750" cy="4210050"/>
           </a:xfrm>
           <a:prstGeom xmlns:a="http://schemas.openxmlformats.org/drawingml/2006/main" prst="roundRect">
-            <a:avLst>
-              <a:gd name="adj" fmla="val 2715"/>
-            </a:avLst>
+            <a:avLst/>
           </a:prstGeom>
         </p:spPr>
       </p:pic>
@@ -14066,7 +14096,7 @@
         </p:spPr>
         <p:txBody>
           <a:bodyPr xmlns:a="http://schemas.openxmlformats.org/drawingml/2006/main" lIns="0" tIns="0" rIns="0" bIns="0" anchor="t">
-            <a:normAutofit fontScale="99106"/>
+            <a:normAutofit fontScale="100000"/>
           </a:bodyPr>
           <a:lstStyle xmlns:a="http://schemas.openxmlformats.org/drawingml/2006/main"/>
           <a:p xmlns:a="http://schemas.openxmlformats.org/drawingml/2006/main">
@@ -14090,14 +14120,14 @@
                 <a:ea typeface="Helvetica Neue"/>
                 <a:cs typeface="Helvetica Neue"/>
               </a:rPr>
-              <a:t>Replay the path. Credit only matching evidence. Close the loop.</a:t>
+              <a:t>Agent testimony stays separate from verified evidence.</a:t>
             </a:r>
           </a:p>
         </p:txBody>
       </p:sp>
       <p:cxnSp>
         <p:nvCxnSpPr>
-          <p:cNvPr id="35" name=""/>
+          <p:cNvPr id="45" name=""/>
           <p:cNvCxnSpPr/>
           <p:nvPr/>
         </p:nvCxnSpPr>
@@ -14237,55 +14267,51 @@
       </p:sp>
       <p:pic>
         <p:nvPicPr>
-          <p:cNvPr id="38" name=""/>
+          <p:cNvPr id="48" name=""/>
           <p:cNvPicPr>
             <a:picLocks xmlns:a="http://schemas.openxmlformats.org/drawingml/2006/main" noChangeAspect="1"/>
           </p:cNvPicPr>
           <p:nvPr/>
         </p:nvPicPr>
         <p:blipFill>
-          <a:blip xmlns:r="http://schemas.openxmlformats.org/officeDocument/2006/relationships" xmlns:a="http://schemas.openxmlformats.org/drawingml/2006/main" r:embed="R35d7be2b7e1b4973"/>
+          <a:blip xmlns:r="http://schemas.openxmlformats.org/officeDocument/2006/relationships" xmlns:a="http://schemas.openxmlformats.org/drawingml/2006/main" r:embed="Rfda67edf09794ebe"/>
           <a:srcRect xmlns:a="http://schemas.openxmlformats.org/drawingml/2006/main" l="316" t="0" r="316" b="0"/>
           <a:stretch xmlns:a="http://schemas.openxmlformats.org/drawingml/2006/main">
             <a:fillRect l="0" t="0" r="0" b="0"/>
           </a:stretch>
         </p:blipFill>
         <p:spPr>
-          <a:xfrm xmlns:a="http://schemas.openxmlformats.org/drawingml/2006/main">
+          <a:xfrm xmlns:a="http://schemas.openxmlformats.org/drawingml/2006/main" flipH="0" flipV="0">
             <a:off x="533400" y="1676400"/>
             <a:ext cx="5391150" cy="3390900"/>
           </a:xfrm>
           <a:prstGeom xmlns:a="http://schemas.openxmlformats.org/drawingml/2006/main" prst="roundRect">
-            <a:avLst>
-              <a:gd name="adj" fmla="val 3371"/>
-            </a:avLst>
+            <a:avLst/>
           </a:prstGeom>
         </p:spPr>
       </p:pic>
       <p:pic>
         <p:nvPicPr>
-          <p:cNvPr id="39" name=""/>
+          <p:cNvPr id="49" name=""/>
           <p:cNvPicPr>
             <a:picLocks xmlns:a="http://schemas.openxmlformats.org/drawingml/2006/main" noChangeAspect="1"/>
           </p:cNvPicPr>
           <p:nvPr/>
         </p:nvPicPr>
         <p:blipFill>
-          <a:blip xmlns:r="http://schemas.openxmlformats.org/officeDocument/2006/relationships" xmlns:a="http://schemas.openxmlformats.org/drawingml/2006/main" r:embed="Ra27ce19f6cad4193"/>
+          <a:blip xmlns:r="http://schemas.openxmlformats.org/officeDocument/2006/relationships" xmlns:a="http://schemas.openxmlformats.org/drawingml/2006/main" r:embed="R4d472687e4994c02"/>
           <a:srcRect xmlns:a="http://schemas.openxmlformats.org/drawingml/2006/main" l="0" t="383" r="0" b="383"/>
           <a:stretch xmlns:a="http://schemas.openxmlformats.org/drawingml/2006/main">
             <a:fillRect l="0" t="0" r="0" b="0"/>
           </a:stretch>
         </p:blipFill>
         <p:spPr>
-          <a:xfrm xmlns:a="http://schemas.openxmlformats.org/drawingml/2006/main">
+          <a:xfrm xmlns:a="http://schemas.openxmlformats.org/drawingml/2006/main" flipH="0" flipV="0">
             <a:off x="6191250" y="1676400"/>
             <a:ext cx="5467350" cy="3390900"/>
           </a:xfrm>
           <a:prstGeom xmlns:a="http://schemas.openxmlformats.org/drawingml/2006/main" prst="roundRect">
-            <a:avLst>
-              <a:gd name="adj" fmla="val 3371"/>
-            </a:avLst>
+            <a:avLst/>
           </a:prstGeom>
         </p:spPr>
       </p:pic>
@@ -14343,7 +14369,7 @@
                 <a:ea typeface="Menlo"/>
                 <a:cs typeface="Menlo"/>
               </a:rPr>
-              <a:t>DIRECT</a:t>
+              <a:t>SITE OBSERVED</a:t>
             </a:r>
           </a:p>
         </p:txBody>
@@ -14402,7 +14428,7 @@
                 <a:ea typeface="Helvetica Neue"/>
                 <a:cs typeface="Helvetica Neue"/>
               </a:rPr>
-              <a:t>Matching agent cart + handoff</a:t>
+              <a:t>Zero result + low coverage</a:t>
             </a:r>
           </a:p>
         </p:txBody>
@@ -14461,7 +14487,7 @@
                 <a:ea typeface="Menlo"/>
                 <a:cs typeface="Menlo"/>
               </a:rPr>
-              <a:t>ASSISTED</a:t>
+              <a:t>AGENT REPORTED</a:t>
             </a:r>
           </a:p>
         </p:txBody>
@@ -14520,7 +14546,7 @@
                 <a:ea typeface="Helvetica Neue"/>
                 <a:cs typeface="Helvetica Neue"/>
               </a:rPr>
-              <a:t>Matching cart evidence</a:t>
+              <a:t>Constraint + ratings + action</a:t>
             </a:r>
           </a:p>
         </p:txBody>
@@ -14579,7 +14605,7 @@
                 <a:ea typeface="Menlo"/>
                 <a:cs typeface="Menlo"/>
               </a:rPr>
-              <a:t>INFLUENCED</a:t>
+              <a:t>SITE VERIFIED</a:t>
             </a:r>
           </a:p>
         </p:txBody>
@@ -14638,7 +14664,7 @@
                 <a:ea typeface="Helvetica Neue"/>
                 <a:cs typeface="Helvetica Neue"/>
               </a:rPr>
-              <a:t>Matching product evidence</a:t>
+              <a:t>2 eligible · IPX4 · paid order</a:t>
             </a:r>
           </a:p>
         </p:txBody>
@@ -14697,7 +14723,7 @@
                 <a:ea typeface="Menlo"/>
                 <a:cs typeface="Menlo"/>
               </a:rPr>
-              <a:t>NO MATCH</a:t>
+              <a:t>NEVER CLAIMED</a:t>
             </a:r>
           </a:p>
         </p:txBody>
@@ -14756,7 +14782,7 @@
                 <a:ea typeface="Helvetica Neue"/>
                 <a:cs typeface="Helvetica Neue"/>
               </a:rPr>
-              <a:t>No attribution</a:t>
+              <a:t>Lost revenue or verified opinion</a:t>
             </a:r>
           </a:p>
         </p:txBody>
@@ -14848,7 +14874,7 @@
                 <a:ea typeface="Menlo"/>
                 <a:cs typeface="Menlo"/>
               </a:rPr>
-              <a:t>GROSS − REFUNDS = NET · SESSION-ONLY CONTROLS CAN RESTRICT THE NEXT RUN</a:t>
+              <a:t>FEEDBACK NEVER CHANGES ATTRIBUTION · REFUNDS STILL REDUCE NET</a:t>
             </a:r>
           </a:p>
         </p:txBody>

</xml_diff>

<commit_message>
feat(webmcp): align tool contracts and add eval gates
</commit_message>
<xml_diff>
--- a/submission/agent-snr-hackathon-demo.pptx
+++ b/submission/agent-snr-hackathon-demo.pptx
@@ -2,23 +2,24 @@
 <file path=ppt/presentation.xml><?xml version="1.0" encoding="utf-8"?>
 <p:presentation xmlns:p="http://schemas.openxmlformats.org/presentationml/2006/main">
   <p:sldMasterIdLst>
-    <p:sldMasterId xmlns:r="http://schemas.openxmlformats.org/officeDocument/2006/relationships" id="2147483648" r:id="R6b3840c3be404f90"/>
+    <p:sldMasterId xmlns:r="http://schemas.openxmlformats.org/officeDocument/2006/relationships" id="2147483648" r:id="R7b1f538e05f64dba"/>
   </p:sldMasterIdLst>
   <p:notesMasterIdLst>
-    <p:notesMasterId xmlns:r="http://schemas.openxmlformats.org/officeDocument/2006/relationships" r:id="Rbdb16cbb29434c09"/>
+    <p:notesMasterId xmlns:r="http://schemas.openxmlformats.org/officeDocument/2006/relationships" r:id="R408a100d73d5422a"/>
   </p:notesMasterIdLst>
   <p:sldIdLst>
-    <p:sldId xmlns:r="http://schemas.openxmlformats.org/officeDocument/2006/relationships" id="256" r:id="Rd41bb99b72cc4a62"/>
-    <p:sldId xmlns:r="http://schemas.openxmlformats.org/officeDocument/2006/relationships" id="257" r:id="R1328144698e14cbf"/>
-    <p:sldId xmlns:r="http://schemas.openxmlformats.org/officeDocument/2006/relationships" id="258" r:id="Rb1a93082560041f7"/>
-    <p:sldId xmlns:r="http://schemas.openxmlformats.org/officeDocument/2006/relationships" id="259" r:id="R2632ec83a627482d"/>
-    <p:sldId xmlns:r="http://schemas.openxmlformats.org/officeDocument/2006/relationships" id="260" r:id="Rd76d62ccb25049c2"/>
-    <p:sldId xmlns:r="http://schemas.openxmlformats.org/officeDocument/2006/relationships" id="261" r:id="R73bdfeafb8f84bdb"/>
-    <p:sldId xmlns:r="http://schemas.openxmlformats.org/officeDocument/2006/relationships" id="262" r:id="R56c4b36d4f55441a"/>
-    <p:sldId xmlns:r="http://schemas.openxmlformats.org/officeDocument/2006/relationships" id="263" r:id="Rc7cd82afbd4349f9"/>
-    <p:sldId xmlns:r="http://schemas.openxmlformats.org/officeDocument/2006/relationships" id="264" r:id="R7d54ee265d814db2"/>
-    <p:sldId xmlns:r="http://schemas.openxmlformats.org/officeDocument/2006/relationships" id="265" r:id="Rd5a094dd21bd4e0e"/>
-    <p:sldId xmlns:r="http://schemas.openxmlformats.org/officeDocument/2006/relationships" id="266" r:id="R8a229d25458b4658"/>
+    <p:sldId xmlns:r="http://schemas.openxmlformats.org/officeDocument/2006/relationships" id="256" r:id="R01823746f837464c"/>
+    <p:sldId xmlns:r="http://schemas.openxmlformats.org/officeDocument/2006/relationships" id="257" r:id="R1d3b1b4311614e69"/>
+    <p:sldId xmlns:r="http://schemas.openxmlformats.org/officeDocument/2006/relationships" id="258" r:id="R7de896ce7b9a4d77"/>
+    <p:sldId xmlns:r="http://schemas.openxmlformats.org/officeDocument/2006/relationships" id="259" r:id="R991816a3d4034549"/>
+    <p:sldId xmlns:r="http://schemas.openxmlformats.org/officeDocument/2006/relationships" id="260" r:id="R6fea63dd63f344d1"/>
+    <p:sldId xmlns:r="http://schemas.openxmlformats.org/officeDocument/2006/relationships" id="261" r:id="Rc28c7e3665664b97"/>
+    <p:sldId xmlns:r="http://schemas.openxmlformats.org/officeDocument/2006/relationships" id="262" r:id="Rc3bc69174763480a"/>
+    <p:sldId xmlns:r="http://schemas.openxmlformats.org/officeDocument/2006/relationships" id="263" r:id="R2b84c46b89fc4636"/>
+    <p:sldId xmlns:r="http://schemas.openxmlformats.org/officeDocument/2006/relationships" id="264" r:id="R35f9148df5b04a98"/>
+    <p:sldId xmlns:r="http://schemas.openxmlformats.org/officeDocument/2006/relationships" id="265" r:id="Rb1d47839f4d3438a"/>
+    <p:sldId xmlns:r="http://schemas.openxmlformats.org/officeDocument/2006/relationships" id="266" r:id="R7d5732a4756e46b8"/>
+    <p:sldId xmlns:r="http://schemas.openxmlformats.org/officeDocument/2006/relationships" id="267" r:id="R760added1df94896"/>
   </p:sldIdLst>
   <p:sldSz cx="12192000" cy="6858000"/>
   <p:notesSz cx="6858000" cy="9144000"/>
@@ -547,27 +548,37 @@
           <a:lstStyle xmlns:a="http://schemas.openxmlformats.org/drawingml/2006/main"/>
           <a:p xmlns:a="http://schemas.openxmlformats.org/drawingml/2006/main">
             <a:r>
-              <a:t>The browser suite now includes guide discovery, automatic missed-demand recording, linked feedback, provenance labels, same-session isolation, real classic checkout, and existing replay/cart/attribution boundaries. PHP tests cover schema, privacy, OOS analysis, evidence scope, metric enrichment, output budgets, and database-enforced feedback slots.</a:t>
-            </a:r>
-          </a:p>
-          <a:p xmlns:a="http://schemas.openxmlformats.org/drawingml/2006/main">
-            <a:r>
-              <a:t/>
-            </a:r>
-          </a:p>
-          <a:p xmlns:a="http://schemas.openxmlformats.org/drawingml/2006/main">
-            <a:r>
               <a:t>[Sources]</a:t>
             </a:r>
           </a:p>
           <a:p xmlns:a="http://schemas.openxmlformats.org/drawingml/2006/main">
             <a:r>
-              <a:t>- submission/verification-report.md</a:t>
-            </a:r>
-          </a:p>
-          <a:p xmlns:a="http://schemas.openxmlformats.org/drawingml/2006/main">
-            <a:r>
-              <a:t>- TESTING.md</a:t>
+              <a:t>- https://github.com/GoogleChromeLabs/webmcp-tools/tree/v0.0.4/webmcp-evals</a:t>
+            </a:r>
+          </a:p>
+          <a:p xmlns:a="http://schemas.openxmlformats.org/drawingml/2006/main">
+            <a:r>
+              <a:t>- https://developer.chrome.com/docs/ai/webmcp/evals</a:t>
+            </a:r>
+          </a:p>
+          <a:p xmlns:a="http://schemas.openxmlformats.org/drawingml/2006/main">
+            <a:r>
+              <a:t>- https://chromewebstore.google.com/detail/nekuda-webmcp-workbench/amochnnbmnkjjlblolhpddkokhnalkjp</a:t>
+            </a:r>
+          </a:p>
+          <a:p xmlns:a="http://schemas.openxmlformats.org/drawingml/2006/main">
+            <a:r>
+              <a:t>- https://webmcp.com/methodology</a:t>
+            </a:r>
+          </a:p>
+          <a:p xmlns:a="http://schemas.openxmlformats.org/drawingml/2006/main">
+            <a:r>
+              <a:t>[/Sources]</a:t>
+            </a:r>
+          </a:p>
+          <a:p xmlns:a="http://schemas.openxmlformats.org/drawingml/2006/main">
+            <a:r>
+              <a:t>The first two gates are reproducible repository evidence. Model-backed, Workbench, scanner, and directory evidence are owner gates against the frozen release.</a:t>
             </a:r>
           </a:p>
         </p:txBody>
@@ -637,6 +648,96 @@
           <a:lstStyle xmlns:a="http://schemas.openxmlformats.org/drawingml/2006/main"/>
           <a:p xmlns:a="http://schemas.openxmlformats.org/drawingml/2006/main">
             <a:r>
+              <a:t>[Sources]</a:t>
+            </a:r>
+          </a:p>
+          <a:p xmlns:a="http://schemas.openxmlformats.org/drawingml/2006/main">
+            <a:r>
+              <a:t>- submission/verification-report.md</a:t>
+            </a:r>
+          </a:p>
+          <a:p xmlns:a="http://schemas.openxmlformats.org/drawingml/2006/main">
+            <a:r>
+              <a:t>- evals/README.md</a:t>
+            </a:r>
+          </a:p>
+          <a:p xmlns:a="http://schemas.openxmlformats.org/drawingml/2006/main">
+            <a:r>
+              <a:t>[/Sources]</a:t>
+            </a:r>
+          </a:p>
+          <a:p xmlns:a="http://schemas.openxmlformats.org/drawingml/2006/main">
+            <a:r>
+              <a:t>Counts reflect the exact final artifact and repository verification run.</a:t>
+            </a:r>
+          </a:p>
+        </p:txBody>
+      </p:sp>
+      <p:sp>
+        <p:nvSpPr>
+          <p:cNvPr id="4" name="Slide Number Placeholder 3"/>
+          <p:cNvSpPr>
+            <a:spLocks xmlns:a="http://schemas.openxmlformats.org/drawingml/2006/main" noGrp="1"/>
+          </p:cNvSpPr>
+          <p:nvPr>
+            <p:ph type="sldNum" idx="5"/>
+          </p:nvPr>
+        </p:nvSpPr>
+        <p:spPr/>
+        <p:txBody>
+          <a:bodyPr xmlns:a="http://schemas.openxmlformats.org/drawingml/2006/main"/>
+          <a:lstStyle xmlns:a="http://schemas.openxmlformats.org/drawingml/2006/main"/>
+          <a:p xmlns:a="http://schemas.openxmlformats.org/drawingml/2006/main"/>
+        </p:txBody>
+      </p:sp>
+    </p:spTree>
+  </p:cSld>
+  <p:clrMapOvr>
+    <a:masterClrMapping xmlns:a="http://schemas.openxmlformats.org/drawingml/2006/main"/>
+  </p:clrMapOvr>
+</p:notes>
+</file>
+
+<file path=ppt/notesSlides/notesSlide12.xml><?xml version="1.0" encoding="utf-8"?>
+<p:notes xmlns:p="http://schemas.openxmlformats.org/presentationml/2006/main">
+  <p:cSld>
+    <p:spTree>
+      <p:nvGrpSpPr>
+        <p:cNvPr id="1" name=""/>
+        <p:cNvGrpSpPr/>
+        <p:nvPr/>
+      </p:nvGrpSpPr>
+      <p:grpSpPr>
+        <a:xfrm xmlns:a="http://schemas.openxmlformats.org/drawingml/2006/main"/>
+      </p:grpSpPr>
+      <p:sp>
+        <p:nvSpPr>
+          <p:cNvPr id="2" name="Slide Image Placeholder 1"/>
+          <p:cNvSpPr>
+            <a:spLocks xmlns:a="http://schemas.openxmlformats.org/drawingml/2006/main" noGrp="1"/>
+          </p:cNvSpPr>
+          <p:nvPr>
+            <p:ph type="sldImg" idx="0"/>
+          </p:nvPr>
+        </p:nvSpPr>
+        <p:spPr/>
+      </p:sp>
+      <p:sp>
+        <p:nvSpPr>
+          <p:cNvPr id="3" name="Notes Placeholder 2"/>
+          <p:cNvSpPr>
+            <a:spLocks xmlns:a="http://schemas.openxmlformats.org/drawingml/2006/main" noGrp="1"/>
+          </p:cNvSpPr>
+          <p:nvPr>
+            <p:ph type="body" idx="1"/>
+          </p:nvPr>
+        </p:nvSpPr>
+        <p:spPr/>
+        <p:txBody>
+          <a:bodyPr xmlns:a="http://schemas.openxmlformats.org/drawingml/2006/main"/>
+          <a:lstStyle xmlns:a="http://schemas.openxmlformats.org/drawingml/2006/main"/>
+          <a:p xmlns:a="http://schemas.openxmlformats.org/drawingml/2006/main">
+            <a:r>
               <a:t>The memorable idea is a website that can teach agents how to use it, record missed demand even when the agent stays silent, receive honest structured feedback, and prove the business outcome without collecting the conversation or weakening human authority.</a:t>
             </a:r>
           </a:p>
@@ -922,7 +1023,7 @@
           <a:lstStyle xmlns:a="http://schemas.openxmlformats.org/drawingml/2006/main"/>
           <a:p xmlns:a="http://schemas.openxmlformats.org/drawingml/2006/main">
             <a:r>
-              <a:t>Two independent top-level WebMCP surfaces expose 13 storefront tools and 9 Agent SNR tools from one first-party catalog. The guide is shared by people and agents. WordPress records automatic opportunity evidence and structured agent testimony separately; catalog and WooCommerce facts resolve the verified measurements.</a:t>
+              <a:t>Two independent top-level WebMCP surfaces expose 12 storefront tools and 8 Agent SNR tools from one first-party catalog. Two older gap abilities remain registered only for compatibility and are absent from public discovery. Guide 1.1 is shared by people and agents. WordPress keeps opportunity evidence, agent testimony, catalog facts, and WooCommerce outcomes separate.</a:t>
             </a:r>
           </a:p>
           <a:p xmlns:a="http://schemas.openxmlformats.org/drawingml/2006/main">
@@ -958,6 +1059,11 @@
           <a:p xmlns:a="http://schemas.openxmlformats.org/drawingml/2006/main">
             <a:r>
               <a:t>- plugin/wmcp-agentops/src/WebMCP/ExecutionController.php</a:t>
+            </a:r>
+          </a:p>
+          <a:p xmlns:a="http://schemas.openxmlformats.org/drawingml/2006/main">
+            <a:r>
+              <a:t>[/Sources]</a:t>
             </a:r>
           </a:p>
         </p:txBody>
@@ -1317,7 +1423,7 @@
           <a:lstStyle xmlns:a="http://schemas.openxmlformats.org/drawingml/2006/main"/>
           <a:p xmlns:a="http://schemas.openxmlformats.org/drawingml/2006/main">
             <a:r>
-              <a:t>The same canonical Agent Guide is rendered for the shopper and returned to the agent. It says where to start, which effects are reversible, what the person must do, what data is excluded, when feedback helps, and that at most two reports are accepted per workflow.</a:t>
+              <a:t>Guide 1.1 declares top-level co-browsing, unattended execution as unsupported, two outcome journeys, zero Sensitive Action tools, the subtotal/final-total boundary, privacy exclusions, and optional structured feedback. The same canonical object is rendered for the shopper and returned to the agent.</a:t>
             </a:r>
           </a:p>
           <a:p xmlns:a="http://schemas.openxmlformats.org/drawingml/2006/main">
@@ -1348,6 +1454,11 @@
           <a:p xmlns:a="http://schemas.openxmlformats.org/drawingml/2006/main">
             <a:r>
               <a:t>- plugin/wmcp-agentops/src/Guidance/AgentGuide.php</a:t>
+            </a:r>
+          </a:p>
+          <a:p xmlns:a="http://schemas.openxmlformats.org/drawingml/2006/main">
+            <a:r>
+              <a:t>[/Sources]</a:t>
             </a:r>
           </a:p>
         </p:txBody>
@@ -1515,7 +1626,7 @@
   </p:cSld>
   <p:clrMap bg1="lt1" tx1="dk1" bg2="lt2" tx2="dk2" accent1="accent1" accent2="accent2" accent3="accent3" accent4="accent4" accent5="accent5" accent6="accent6" hlink="hlink" folHlink="folHlink"/>
   <p:sldLayoutIdLst>
-    <p:sldLayoutId xmlns:r="http://schemas.openxmlformats.org/officeDocument/2006/relationships" id="2147483649" r:id="Rbe18ffa54d974590"/>
+    <p:sldLayoutId xmlns:r="http://schemas.openxmlformats.org/officeDocument/2006/relationships" id="2147483649" r:id="R357c7a790e8049d6"/>
   </p:sldLayoutIdLst>
   <p:txStyles>
     <p:titleStyle>
@@ -2435,7 +2546,7 @@
       </p:sp>
       <p:cxnSp>
         <p:nvCxnSpPr>
-          <p:cNvPr id="51" name=""/>
+          <p:cNvPr id="65" name=""/>
           <p:cNvCxnSpPr/>
           <p:nvPr/>
         </p:nvCxnSpPr>
@@ -2604,10 +2715,10 @@
       </p:grpSpPr>
       <p:sp>
         <p:nvSpPr>
-          <p:cNvPr id="24" name="">
-            <a:extLst xmlns:a="http://schemas.openxmlformats.org/drawingml/2006/main">
-              <a:ext uri="{FF2B5EF4-FFF2-40B4-BE49-F238E27FC236}">
-                <a16:creationId xmlns:a16="http://schemas.microsoft.com/office/drawing/2014/main" id="{AB2191F0-2E06-41A8-A101-0072BB1AB539}"/>
+          <p:cNvPr id="34" name="">
+            <a:extLst xmlns:a="http://schemas.openxmlformats.org/drawingml/2006/main">
+              <a:ext uri="{FF2B5EF4-FFF2-40B4-BE49-F238E27FC236}">
+                <a16:creationId xmlns:a16="http://schemas.microsoft.com/office/drawing/2014/main" id="{C5D00C83-EE4F-421B-8915-34B0B2D2C7E8}"/>
               </a:ext>
             </a:extLst>
           </p:cNvPr>
@@ -2656,7 +2767,7 @@
                 <a:ea typeface="Menlo"/>
                 <a:cs typeface="Menlo"/>
               </a:rPr>
-              <a:t>PROOF</a:t>
+              <a:t>WEBMCP QUALITY LOOP</a:t>
             </a:r>
           </a:p>
         </p:txBody>
@@ -2666,7 +2777,7 @@
           <p:cNvPr id="2" name="">
             <a:extLst xmlns:a="http://schemas.openxmlformats.org/drawingml/2006/main">
               <a:ext uri="{FF2B5EF4-FFF2-40B4-BE49-F238E27FC236}">
-                <a16:creationId xmlns:a16="http://schemas.microsoft.com/office/drawing/2014/main" id="{554A02D3-69CF-45D7-8D83-4914905B8499}"/>
+                <a16:creationId xmlns:a16="http://schemas.microsoft.com/office/drawing/2014/main" id="{99FE1F28-B38F-42BC-BCB3-14B56E17D493}"/>
               </a:ext>
             </a:extLst>
           </p:cNvPr>
@@ -2715,14 +2826,14 @@
                 <a:ea typeface="Helvetica Neue"/>
                 <a:cs typeface="Helvetica Neue"/>
               </a:rPr>
-              <a:t>The critical boundaries are tested, not staged.</a:t>
+              <a:t>The journey is evaluated before it is published.</a:t>
             </a:r>
           </a:p>
         </p:txBody>
       </p:sp>
       <p:cxnSp>
         <p:nvCxnSpPr>
-          <p:cNvPr id="136" name=""/>
+          <p:cNvPr id="246" name=""/>
           <p:cNvCxnSpPr/>
           <p:nvPr/>
         </p:nvCxnSpPr>
@@ -2747,7 +2858,7 @@
           <p:cNvPr id="4" name="">
             <a:extLst xmlns:a="http://schemas.openxmlformats.org/drawingml/2006/main">
               <a:ext uri="{FF2B5EF4-FFF2-40B4-BE49-F238E27FC236}">
-                <a16:creationId xmlns:a16="http://schemas.microsoft.com/office/drawing/2014/main" id="{E20B2E0A-BB09-46B7-82E4-234C9EA69585}"/>
+                <a16:creationId xmlns:a16="http://schemas.microsoft.com/office/drawing/2014/main" id="{9A6A5D05-FC4A-48C1-9EA1-989EFB1B794E}"/>
               </a:ext>
             </a:extLst>
           </p:cNvPr>
@@ -2806,7 +2917,7 @@
           <p:cNvPr id="5" name="">
             <a:extLst xmlns:a="http://schemas.openxmlformats.org/drawingml/2006/main">
               <a:ext uri="{FF2B5EF4-FFF2-40B4-BE49-F238E27FC236}">
-                <a16:creationId xmlns:a16="http://schemas.microsoft.com/office/drawing/2014/main" id="{392DEE81-DBCB-409E-885A-490F268243F6}"/>
+                <a16:creationId xmlns:a16="http://schemas.microsoft.com/office/drawing/2014/main" id="{ACF9D3D2-0085-4AB7-9CB4-715D1BFC0C4F}"/>
               </a:ext>
             </a:extLst>
           </p:cNvPr>
@@ -2860,6 +2971,1789 @@
           </a:p>
         </p:txBody>
       </p:sp>
+      <p:cxnSp>
+        <p:nvCxnSpPr>
+          <p:cNvPr id="249" name=""/>
+          <p:cNvCxnSpPr/>
+          <p:nvPr/>
+        </p:nvCxnSpPr>
+        <p:spPr>
+          <a:xfrm xmlns:a="http://schemas.openxmlformats.org/drawingml/2006/main">
+            <a:off x="1066800" y="1981200"/>
+            <a:ext cx="0" cy="3429000"/>
+          </a:xfrm>
+          <a:prstGeom xmlns:a="http://schemas.openxmlformats.org/drawingml/2006/main" prst="straightConnector1">
+            <a:avLst/>
+          </a:prstGeom>
+          <a:ln xmlns:a="http://schemas.openxmlformats.org/drawingml/2006/main" w="47625">
+            <a:solidFill>
+              <a:srgbClr val="1769FF"/>
+            </a:solidFill>
+            <a:prstDash val="solid"/>
+          </a:ln>
+        </p:spPr>
+      </p:cxnSp>
+      <p:sp>
+        <p:nvSpPr>
+          <p:cNvPr id="7" name="">
+            <a:extLst xmlns:a="http://schemas.openxmlformats.org/drawingml/2006/main">
+              <a:ext uri="{FF2B5EF4-FFF2-40B4-BE49-F238E27FC236}">
+                <a16:creationId xmlns:a16="http://schemas.microsoft.com/office/drawing/2014/main" id="{A2FA3395-C11B-4B28-9E18-9C13D31FD7B1}"/>
+              </a:ext>
+            </a:extLst>
+          </p:cNvPr>
+          <p:cNvSpPr>
+            <a:spLocks xmlns:a="http://schemas.openxmlformats.org/drawingml/2006/main" noGrp="1"/>
+          </p:cNvSpPr>
+          <p:nvPr/>
+        </p:nvSpPr>
+        <p:spPr>
+          <a:xfrm xmlns:a="http://schemas.openxmlformats.org/drawingml/2006/main">
+            <a:off x="866775" y="1809750"/>
+            <a:ext cx="400050" cy="400050"/>
+          </a:xfrm>
+          <a:prstGeom xmlns:a="http://schemas.openxmlformats.org/drawingml/2006/main" prst="roundRect">
+            <a:avLst>
+              <a:gd name="adj" fmla="val 28571"/>
+            </a:avLst>
+          </a:prstGeom>
+          <a:solidFill xmlns:a="http://schemas.openxmlformats.org/drawingml/2006/main">
+            <a:srgbClr val="1769FF"/>
+          </a:solidFill>
+          <a:ln xmlns:a="http://schemas.openxmlformats.org/drawingml/2006/main" w="0">
+            <a:noFill/>
+            <a:prstDash val="solid"/>
+          </a:ln>
+        </p:spPr>
+      </p:sp>
+      <p:sp>
+        <p:nvSpPr>
+          <p:cNvPr id="8" name="">
+            <a:extLst xmlns:a="http://schemas.openxmlformats.org/drawingml/2006/main">
+              <a:ext uri="{FF2B5EF4-FFF2-40B4-BE49-F238E27FC236}">
+                <a16:creationId xmlns:a16="http://schemas.microsoft.com/office/drawing/2014/main" id="{0B5C2877-4A68-4A5A-BC16-036E5FB1C798}"/>
+              </a:ext>
+            </a:extLst>
+          </p:cNvPr>
+          <p:cNvSpPr>
+            <a:spLocks xmlns:a="http://schemas.openxmlformats.org/drawingml/2006/main" noGrp="1"/>
+          </p:cNvSpPr>
+          <p:nvPr/>
+        </p:nvSpPr>
+        <p:spPr>
+          <a:xfrm xmlns:a="http://schemas.openxmlformats.org/drawingml/2006/main">
+            <a:off x="866775" y="1933575"/>
+            <a:ext cx="400050" cy="152400"/>
+          </a:xfrm>
+          <a:prstGeom xmlns:a="http://schemas.openxmlformats.org/drawingml/2006/main" prst="rect">
+            <a:avLst/>
+          </a:prstGeom>
+          <a:noFill xmlns:a="http://schemas.openxmlformats.org/drawingml/2006/main"/>
+          <a:ln xmlns:a="http://schemas.openxmlformats.org/drawingml/2006/main" w="0">
+            <a:noFill/>
+            <a:prstDash val="solid"/>
+          </a:ln>
+        </p:spPr>
+        <p:txBody>
+          <a:bodyPr xmlns:a="http://schemas.openxmlformats.org/drawingml/2006/main" lIns="0" tIns="0" rIns="0" bIns="0" anchor="t">
+            <a:normAutofit fontScale="100000"/>
+          </a:bodyPr>
+          <a:lstStyle xmlns:a="http://schemas.openxmlformats.org/drawingml/2006/main"/>
+          <a:p xmlns:a="http://schemas.openxmlformats.org/drawingml/2006/main">
+            <a:pPr algn="ctr">
+              <a:buNone/>
+              <a:defRPr sz="825" b="1" i="0">
+                <a:solidFill>
+                  <a:srgbClr val="FFFFFF"/>
+                </a:solidFill>
+                <a:latin typeface="Menlo"/>
+                <a:ea typeface="Menlo"/>
+                <a:cs typeface="Menlo"/>
+              </a:defRPr>
+            </a:pPr>
+            <a:r>
+              <a:rPr sz="825" b="1" i="0">
+                <a:solidFill>
+                  <a:srgbClr val="FFFFFF"/>
+                </a:solidFill>
+                <a:latin typeface="Menlo"/>
+                <a:ea typeface="Menlo"/>
+                <a:cs typeface="Menlo"/>
+              </a:rPr>
+              <a:t>01</a:t>
+            </a:r>
+          </a:p>
+        </p:txBody>
+      </p:sp>
+      <p:sp>
+        <p:nvSpPr>
+          <p:cNvPr id="9" name="">
+            <a:extLst xmlns:a="http://schemas.openxmlformats.org/drawingml/2006/main">
+              <a:ext uri="{FF2B5EF4-FFF2-40B4-BE49-F238E27FC236}">
+                <a16:creationId xmlns:a16="http://schemas.microsoft.com/office/drawing/2014/main" id="{DD5791A2-1EB4-4920-B268-B001ECB3AD73}"/>
+              </a:ext>
+            </a:extLst>
+          </p:cNvPr>
+          <p:cNvSpPr>
+            <a:spLocks xmlns:a="http://schemas.openxmlformats.org/drawingml/2006/main" noGrp="1"/>
+          </p:cNvSpPr>
+          <p:nvPr/>
+        </p:nvSpPr>
+        <p:spPr>
+          <a:xfrm xmlns:a="http://schemas.openxmlformats.org/drawingml/2006/main">
+            <a:off x="1543050" y="1790700"/>
+            <a:ext cx="3143250" cy="323850"/>
+          </a:xfrm>
+          <a:prstGeom xmlns:a="http://schemas.openxmlformats.org/drawingml/2006/main" prst="rect">
+            <a:avLst/>
+          </a:prstGeom>
+          <a:noFill xmlns:a="http://schemas.openxmlformats.org/drawingml/2006/main"/>
+          <a:ln xmlns:a="http://schemas.openxmlformats.org/drawingml/2006/main" w="0">
+            <a:noFill/>
+            <a:prstDash val="solid"/>
+          </a:ln>
+        </p:spPr>
+        <p:txBody>
+          <a:bodyPr xmlns:a="http://schemas.openxmlformats.org/drawingml/2006/main" lIns="0" tIns="0" rIns="0" bIns="0" anchor="t">
+            <a:normAutofit fontScale="100000"/>
+          </a:bodyPr>
+          <a:lstStyle xmlns:a="http://schemas.openxmlformats.org/drawingml/2006/main"/>
+          <a:p xmlns:a="http://schemas.openxmlformats.org/drawingml/2006/main">
+            <a:pPr algn="l">
+              <a:buNone/>
+              <a:defRPr sz="1725" b="1" i="0">
+                <a:solidFill>
+                  <a:srgbClr val="111111"/>
+                </a:solidFill>
+                <a:latin typeface="Helvetica Neue"/>
+                <a:ea typeface="Helvetica Neue"/>
+                <a:cs typeface="Helvetica Neue"/>
+              </a:defRPr>
+            </a:pPr>
+            <a:r>
+              <a:rPr sz="1725" b="1" i="0">
+                <a:solidFill>
+                  <a:srgbClr val="111111"/>
+                </a:solidFill>
+                <a:latin typeface="Helvetica Neue"/>
+                <a:ea typeface="Helvetica Neue"/>
+                <a:cs typeface="Helvetica Neue"/>
+              </a:rPr>
+              <a:t>Contract parity</a:t>
+            </a:r>
+          </a:p>
+        </p:txBody>
+      </p:sp>
+      <p:sp>
+        <p:nvSpPr>
+          <p:cNvPr id="10" name="">
+            <a:extLst xmlns:a="http://schemas.openxmlformats.org/drawingml/2006/main">
+              <a:ext uri="{FF2B5EF4-FFF2-40B4-BE49-F238E27FC236}">
+                <a16:creationId xmlns:a16="http://schemas.microsoft.com/office/drawing/2014/main" id="{9A58CD9D-2850-4E99-9EB3-C37DA6E650B2}"/>
+              </a:ext>
+            </a:extLst>
+          </p:cNvPr>
+          <p:cNvSpPr>
+            <a:spLocks xmlns:a="http://schemas.openxmlformats.org/drawingml/2006/main" noGrp="1"/>
+          </p:cNvSpPr>
+          <p:nvPr/>
+        </p:nvSpPr>
+        <p:spPr>
+          <a:xfrm xmlns:a="http://schemas.openxmlformats.org/drawingml/2006/main">
+            <a:off x="1543050" y="2124075"/>
+            <a:ext cx="3714750" cy="228600"/>
+          </a:xfrm>
+          <a:prstGeom xmlns:a="http://schemas.openxmlformats.org/drawingml/2006/main" prst="rect">
+            <a:avLst/>
+          </a:prstGeom>
+          <a:noFill xmlns:a="http://schemas.openxmlformats.org/drawingml/2006/main"/>
+          <a:ln xmlns:a="http://schemas.openxmlformats.org/drawingml/2006/main" w="0">
+            <a:noFill/>
+            <a:prstDash val="solid"/>
+          </a:ln>
+        </p:spPr>
+        <p:txBody>
+          <a:bodyPr xmlns:a="http://schemas.openxmlformats.org/drawingml/2006/main" lIns="0" tIns="0" rIns="0" bIns="0" anchor="t">
+            <a:normAutofit fontScale="100000"/>
+          </a:bodyPr>
+          <a:lstStyle xmlns:a="http://schemas.openxmlformats.org/drawingml/2006/main"/>
+          <a:p xmlns:a="http://schemas.openxmlformats.org/drawingml/2006/main">
+            <a:pPr algn="l">
+              <a:buNone/>
+              <a:defRPr sz="975" b="1" i="0">
+                <a:solidFill>
+                  <a:srgbClr val="5E666D"/>
+                </a:solidFill>
+                <a:latin typeface="Menlo"/>
+                <a:ea typeface="Menlo"/>
+                <a:cs typeface="Menlo"/>
+              </a:defRPr>
+            </a:pPr>
+            <a:r>
+              <a:rPr sz="975" b="1" i="0">
+                <a:solidFill>
+                  <a:srgbClr val="5E666D"/>
+                </a:solidFill>
+                <a:latin typeface="Menlo"/>
+                <a:ea typeface="Menlo"/>
+                <a:cs typeface="Menlo"/>
+              </a:rPr>
+              <a:t>20 PUBLIC TOOLS · STRICT SCHEMAS</a:t>
+            </a:r>
+          </a:p>
+        </p:txBody>
+      </p:sp>
+      <p:sp>
+        <p:nvSpPr>
+          <p:cNvPr id="11" name="">
+            <a:extLst xmlns:a="http://schemas.openxmlformats.org/drawingml/2006/main">
+              <a:ext uri="{FF2B5EF4-FFF2-40B4-BE49-F238E27FC236}">
+                <a16:creationId xmlns:a16="http://schemas.microsoft.com/office/drawing/2014/main" id="{1C7F587E-09F3-4160-8DB8-5991D232B21A}"/>
+              </a:ext>
+            </a:extLst>
+          </p:cNvPr>
+          <p:cNvSpPr>
+            <a:spLocks xmlns:a="http://schemas.openxmlformats.org/drawingml/2006/main" noGrp="1"/>
+          </p:cNvSpPr>
+          <p:nvPr/>
+        </p:nvSpPr>
+        <p:spPr>
+          <a:xfrm xmlns:a="http://schemas.openxmlformats.org/drawingml/2006/main">
+            <a:off x="866775" y="2543175"/>
+            <a:ext cx="400050" cy="400050"/>
+          </a:xfrm>
+          <a:prstGeom xmlns:a="http://schemas.openxmlformats.org/drawingml/2006/main" prst="roundRect">
+            <a:avLst>
+              <a:gd name="adj" fmla="val 28571"/>
+            </a:avLst>
+          </a:prstGeom>
+          <a:solidFill xmlns:a="http://schemas.openxmlformats.org/drawingml/2006/main">
+            <a:srgbClr val="1769FF"/>
+          </a:solidFill>
+          <a:ln xmlns:a="http://schemas.openxmlformats.org/drawingml/2006/main" w="0">
+            <a:noFill/>
+            <a:prstDash val="solid"/>
+          </a:ln>
+        </p:spPr>
+      </p:sp>
+      <p:sp>
+        <p:nvSpPr>
+          <p:cNvPr id="12" name="">
+            <a:extLst xmlns:a="http://schemas.openxmlformats.org/drawingml/2006/main">
+              <a:ext uri="{FF2B5EF4-FFF2-40B4-BE49-F238E27FC236}">
+                <a16:creationId xmlns:a16="http://schemas.microsoft.com/office/drawing/2014/main" id="{CADF2322-6576-49D4-995C-9A639D680227}"/>
+              </a:ext>
+            </a:extLst>
+          </p:cNvPr>
+          <p:cNvSpPr>
+            <a:spLocks xmlns:a="http://schemas.openxmlformats.org/drawingml/2006/main" noGrp="1"/>
+          </p:cNvSpPr>
+          <p:nvPr/>
+        </p:nvSpPr>
+        <p:spPr>
+          <a:xfrm xmlns:a="http://schemas.openxmlformats.org/drawingml/2006/main">
+            <a:off x="866775" y="2667000"/>
+            <a:ext cx="400050" cy="152400"/>
+          </a:xfrm>
+          <a:prstGeom xmlns:a="http://schemas.openxmlformats.org/drawingml/2006/main" prst="rect">
+            <a:avLst/>
+          </a:prstGeom>
+          <a:noFill xmlns:a="http://schemas.openxmlformats.org/drawingml/2006/main"/>
+          <a:ln xmlns:a="http://schemas.openxmlformats.org/drawingml/2006/main" w="0">
+            <a:noFill/>
+            <a:prstDash val="solid"/>
+          </a:ln>
+        </p:spPr>
+        <p:txBody>
+          <a:bodyPr xmlns:a="http://schemas.openxmlformats.org/drawingml/2006/main" lIns="0" tIns="0" rIns="0" bIns="0" anchor="t">
+            <a:normAutofit fontScale="100000"/>
+          </a:bodyPr>
+          <a:lstStyle xmlns:a="http://schemas.openxmlformats.org/drawingml/2006/main"/>
+          <a:p xmlns:a="http://schemas.openxmlformats.org/drawingml/2006/main">
+            <a:pPr algn="ctr">
+              <a:buNone/>
+              <a:defRPr sz="825" b="1" i="0">
+                <a:solidFill>
+                  <a:srgbClr val="FFFFFF"/>
+                </a:solidFill>
+                <a:latin typeface="Menlo"/>
+                <a:ea typeface="Menlo"/>
+                <a:cs typeface="Menlo"/>
+              </a:defRPr>
+            </a:pPr>
+            <a:r>
+              <a:rPr sz="825" b="1" i="0">
+                <a:solidFill>
+                  <a:srgbClr val="FFFFFF"/>
+                </a:solidFill>
+                <a:latin typeface="Menlo"/>
+                <a:ea typeface="Menlo"/>
+                <a:cs typeface="Menlo"/>
+              </a:rPr>
+              <a:t>02</a:t>
+            </a:r>
+          </a:p>
+        </p:txBody>
+      </p:sp>
+      <p:sp>
+        <p:nvSpPr>
+          <p:cNvPr id="13" name="">
+            <a:extLst xmlns:a="http://schemas.openxmlformats.org/drawingml/2006/main">
+              <a:ext uri="{FF2B5EF4-FFF2-40B4-BE49-F238E27FC236}">
+                <a16:creationId xmlns:a16="http://schemas.microsoft.com/office/drawing/2014/main" id="{2C0A6668-446E-48F3-8687-0F268731485A}"/>
+              </a:ext>
+            </a:extLst>
+          </p:cNvPr>
+          <p:cNvSpPr>
+            <a:spLocks xmlns:a="http://schemas.openxmlformats.org/drawingml/2006/main" noGrp="1"/>
+          </p:cNvSpPr>
+          <p:nvPr/>
+        </p:nvSpPr>
+        <p:spPr>
+          <a:xfrm xmlns:a="http://schemas.openxmlformats.org/drawingml/2006/main">
+            <a:off x="1543050" y="2524125"/>
+            <a:ext cx="3143250" cy="323850"/>
+          </a:xfrm>
+          <a:prstGeom xmlns:a="http://schemas.openxmlformats.org/drawingml/2006/main" prst="rect">
+            <a:avLst/>
+          </a:prstGeom>
+          <a:noFill xmlns:a="http://schemas.openxmlformats.org/drawingml/2006/main"/>
+          <a:ln xmlns:a="http://schemas.openxmlformats.org/drawingml/2006/main" w="0">
+            <a:noFill/>
+            <a:prstDash val="solid"/>
+          </a:ln>
+        </p:spPr>
+        <p:txBody>
+          <a:bodyPr xmlns:a="http://schemas.openxmlformats.org/drawingml/2006/main" lIns="0" tIns="0" rIns="0" bIns="0" anchor="t">
+            <a:normAutofit fontScale="100000"/>
+          </a:bodyPr>
+          <a:lstStyle xmlns:a="http://schemas.openxmlformats.org/drawingml/2006/main"/>
+          <a:p xmlns:a="http://schemas.openxmlformats.org/drawingml/2006/main">
+            <a:pPr algn="l">
+              <a:buNone/>
+              <a:defRPr sz="1725" b="1" i="0">
+                <a:solidFill>
+                  <a:srgbClr val="111111"/>
+                </a:solidFill>
+                <a:latin typeface="Helvetica Neue"/>
+                <a:ea typeface="Helvetica Neue"/>
+                <a:cs typeface="Helvetica Neue"/>
+              </a:defRPr>
+            </a:pPr>
+            <a:r>
+              <a:rPr sz="1725" b="1" i="0">
+                <a:solidFill>
+                  <a:srgbClr val="111111"/>
+                </a:solidFill>
+                <a:latin typeface="Helvetica Neue"/>
+                <a:ea typeface="Helvetica Neue"/>
+                <a:cs typeface="Helvetica Neue"/>
+              </a:rPr>
+              <a:t>Native smoke</a:t>
+            </a:r>
+          </a:p>
+        </p:txBody>
+      </p:sp>
+      <p:sp>
+        <p:nvSpPr>
+          <p:cNvPr id="14" name="">
+            <a:extLst xmlns:a="http://schemas.openxmlformats.org/drawingml/2006/main">
+              <a:ext uri="{FF2B5EF4-FFF2-40B4-BE49-F238E27FC236}">
+                <a16:creationId xmlns:a16="http://schemas.microsoft.com/office/drawing/2014/main" id="{7BD406D8-C5F1-415E-912F-DA9FC36F0AB9}"/>
+              </a:ext>
+            </a:extLst>
+          </p:cNvPr>
+          <p:cNvSpPr>
+            <a:spLocks xmlns:a="http://schemas.openxmlformats.org/drawingml/2006/main" noGrp="1"/>
+          </p:cNvSpPr>
+          <p:nvPr/>
+        </p:nvSpPr>
+        <p:spPr>
+          <a:xfrm xmlns:a="http://schemas.openxmlformats.org/drawingml/2006/main">
+            <a:off x="1543050" y="2857500"/>
+            <a:ext cx="3714750" cy="228600"/>
+          </a:xfrm>
+          <a:prstGeom xmlns:a="http://schemas.openxmlformats.org/drawingml/2006/main" prst="rect">
+            <a:avLst/>
+          </a:prstGeom>
+          <a:noFill xmlns:a="http://schemas.openxmlformats.org/drawingml/2006/main"/>
+          <a:ln xmlns:a="http://schemas.openxmlformats.org/drawingml/2006/main" w="0">
+            <a:noFill/>
+            <a:prstDash val="solid"/>
+          </a:ln>
+        </p:spPr>
+        <p:txBody>
+          <a:bodyPr xmlns:a="http://schemas.openxmlformats.org/drawingml/2006/main" lIns="0" tIns="0" rIns="0" bIns="0" anchor="t">
+            <a:normAutofit fontScale="100000"/>
+          </a:bodyPr>
+          <a:lstStyle xmlns:a="http://schemas.openxmlformats.org/drawingml/2006/main"/>
+          <a:p xmlns:a="http://schemas.openxmlformats.org/drawingml/2006/main">
+            <a:pPr algn="l">
+              <a:buNone/>
+              <a:defRPr sz="975" b="1" i="0">
+                <a:solidFill>
+                  <a:srgbClr val="5E666D"/>
+                </a:solidFill>
+                <a:latin typeface="Menlo"/>
+                <a:ea typeface="Menlo"/>
+                <a:cs typeface="Menlo"/>
+              </a:defRPr>
+            </a:pPr>
+            <a:r>
+              <a:rPr sz="975" b="1" i="0">
+                <a:solidFill>
+                  <a:srgbClr val="5E666D"/>
+                </a:solidFill>
+                <a:latin typeface="Menlo"/>
+                <a:ea typeface="Menlo"/>
+                <a:cs typeface="Menlo"/>
+              </a:rPr>
+              <a:t>11/11 KEYLESS CHROME CALLS</a:t>
+            </a:r>
+          </a:p>
+        </p:txBody>
+      </p:sp>
+      <p:sp>
+        <p:nvSpPr>
+          <p:cNvPr id="15" name="">
+            <a:extLst xmlns:a="http://schemas.openxmlformats.org/drawingml/2006/main">
+              <a:ext uri="{FF2B5EF4-FFF2-40B4-BE49-F238E27FC236}">
+                <a16:creationId xmlns:a16="http://schemas.microsoft.com/office/drawing/2014/main" id="{B8B4F8D9-E9F5-4FDD-925C-D183CBCC6848}"/>
+              </a:ext>
+            </a:extLst>
+          </p:cNvPr>
+          <p:cNvSpPr>
+            <a:spLocks xmlns:a="http://schemas.openxmlformats.org/drawingml/2006/main" noGrp="1"/>
+          </p:cNvSpPr>
+          <p:nvPr/>
+        </p:nvSpPr>
+        <p:spPr>
+          <a:xfrm xmlns:a="http://schemas.openxmlformats.org/drawingml/2006/main">
+            <a:off x="866775" y="3276600"/>
+            <a:ext cx="400050" cy="400050"/>
+          </a:xfrm>
+          <a:prstGeom xmlns:a="http://schemas.openxmlformats.org/drawingml/2006/main" prst="roundRect">
+            <a:avLst>
+              <a:gd name="adj" fmla="val 28571"/>
+            </a:avLst>
+          </a:prstGeom>
+          <a:solidFill xmlns:a="http://schemas.openxmlformats.org/drawingml/2006/main">
+            <a:srgbClr val="1769FF"/>
+          </a:solidFill>
+          <a:ln xmlns:a="http://schemas.openxmlformats.org/drawingml/2006/main" w="0">
+            <a:noFill/>
+            <a:prstDash val="solid"/>
+          </a:ln>
+        </p:spPr>
+      </p:sp>
+      <p:sp>
+        <p:nvSpPr>
+          <p:cNvPr id="16" name="">
+            <a:extLst xmlns:a="http://schemas.openxmlformats.org/drawingml/2006/main">
+              <a:ext uri="{FF2B5EF4-FFF2-40B4-BE49-F238E27FC236}">
+                <a16:creationId xmlns:a16="http://schemas.microsoft.com/office/drawing/2014/main" id="{5C6A2EEB-1BDF-4B61-A846-24F198E381C7}"/>
+              </a:ext>
+            </a:extLst>
+          </p:cNvPr>
+          <p:cNvSpPr>
+            <a:spLocks xmlns:a="http://schemas.openxmlformats.org/drawingml/2006/main" noGrp="1"/>
+          </p:cNvSpPr>
+          <p:nvPr/>
+        </p:nvSpPr>
+        <p:spPr>
+          <a:xfrm xmlns:a="http://schemas.openxmlformats.org/drawingml/2006/main">
+            <a:off x="866775" y="3400425"/>
+            <a:ext cx="400050" cy="152400"/>
+          </a:xfrm>
+          <a:prstGeom xmlns:a="http://schemas.openxmlformats.org/drawingml/2006/main" prst="rect">
+            <a:avLst/>
+          </a:prstGeom>
+          <a:noFill xmlns:a="http://schemas.openxmlformats.org/drawingml/2006/main"/>
+          <a:ln xmlns:a="http://schemas.openxmlformats.org/drawingml/2006/main" w="0">
+            <a:noFill/>
+            <a:prstDash val="solid"/>
+          </a:ln>
+        </p:spPr>
+        <p:txBody>
+          <a:bodyPr xmlns:a="http://schemas.openxmlformats.org/drawingml/2006/main" lIns="0" tIns="0" rIns="0" bIns="0" anchor="t">
+            <a:normAutofit fontScale="100000"/>
+          </a:bodyPr>
+          <a:lstStyle xmlns:a="http://schemas.openxmlformats.org/drawingml/2006/main"/>
+          <a:p xmlns:a="http://schemas.openxmlformats.org/drawingml/2006/main">
+            <a:pPr algn="ctr">
+              <a:buNone/>
+              <a:defRPr sz="825" b="1" i="0">
+                <a:solidFill>
+                  <a:srgbClr val="FFFFFF"/>
+                </a:solidFill>
+                <a:latin typeface="Menlo"/>
+                <a:ea typeface="Menlo"/>
+                <a:cs typeface="Menlo"/>
+              </a:defRPr>
+            </a:pPr>
+            <a:r>
+              <a:rPr sz="825" b="1" i="0">
+                <a:solidFill>
+                  <a:srgbClr val="FFFFFF"/>
+                </a:solidFill>
+                <a:latin typeface="Menlo"/>
+                <a:ea typeface="Menlo"/>
+                <a:cs typeface="Menlo"/>
+              </a:rPr>
+              <a:t>03</a:t>
+            </a:r>
+          </a:p>
+        </p:txBody>
+      </p:sp>
+      <p:sp>
+        <p:nvSpPr>
+          <p:cNvPr id="17" name="">
+            <a:extLst xmlns:a="http://schemas.openxmlformats.org/drawingml/2006/main">
+              <a:ext uri="{FF2B5EF4-FFF2-40B4-BE49-F238E27FC236}">
+                <a16:creationId xmlns:a16="http://schemas.microsoft.com/office/drawing/2014/main" id="{A5CBDFC3-EBEF-4836-8119-B63E570DA10C}"/>
+              </a:ext>
+            </a:extLst>
+          </p:cNvPr>
+          <p:cNvSpPr>
+            <a:spLocks xmlns:a="http://schemas.openxmlformats.org/drawingml/2006/main" noGrp="1"/>
+          </p:cNvSpPr>
+          <p:nvPr/>
+        </p:nvSpPr>
+        <p:spPr>
+          <a:xfrm xmlns:a="http://schemas.openxmlformats.org/drawingml/2006/main">
+            <a:off x="1543050" y="3257550"/>
+            <a:ext cx="3143250" cy="323850"/>
+          </a:xfrm>
+          <a:prstGeom xmlns:a="http://schemas.openxmlformats.org/drawingml/2006/main" prst="rect">
+            <a:avLst/>
+          </a:prstGeom>
+          <a:noFill xmlns:a="http://schemas.openxmlformats.org/drawingml/2006/main"/>
+          <a:ln xmlns:a="http://schemas.openxmlformats.org/drawingml/2006/main" w="0">
+            <a:noFill/>
+            <a:prstDash val="solid"/>
+          </a:ln>
+        </p:spPr>
+        <p:txBody>
+          <a:bodyPr xmlns:a="http://schemas.openxmlformats.org/drawingml/2006/main" lIns="0" tIns="0" rIns="0" bIns="0" anchor="t">
+            <a:normAutofit fontScale="100000"/>
+          </a:bodyPr>
+          <a:lstStyle xmlns:a="http://schemas.openxmlformats.org/drawingml/2006/main"/>
+          <a:p xmlns:a="http://schemas.openxmlformats.org/drawingml/2006/main">
+            <a:pPr algn="l">
+              <a:buNone/>
+              <a:defRPr sz="1725" b="1" i="0">
+                <a:solidFill>
+                  <a:srgbClr val="111111"/>
+                </a:solidFill>
+                <a:latin typeface="Helvetica Neue"/>
+                <a:ea typeface="Helvetica Neue"/>
+                <a:cs typeface="Helvetica Neue"/>
+              </a:defRPr>
+            </a:pPr>
+            <a:r>
+              <a:rPr sz="1725" b="1" i="0">
+                <a:solidFill>
+                  <a:srgbClr val="111111"/>
+                </a:solidFill>
+                <a:latin typeface="Helvetica Neue"/>
+                <a:ea typeface="Helvetica Neue"/>
+                <a:cs typeface="Helvetica Neue"/>
+              </a:rPr>
+              <a:t>Model behavior</a:t>
+            </a:r>
+          </a:p>
+        </p:txBody>
+      </p:sp>
+      <p:sp>
+        <p:nvSpPr>
+          <p:cNvPr id="18" name="">
+            <a:extLst xmlns:a="http://schemas.openxmlformats.org/drawingml/2006/main">
+              <a:ext uri="{FF2B5EF4-FFF2-40B4-BE49-F238E27FC236}">
+                <a16:creationId xmlns:a16="http://schemas.microsoft.com/office/drawing/2014/main" id="{2E6E3F81-2EDB-4472-8CEE-C61FBF9D99AF}"/>
+              </a:ext>
+            </a:extLst>
+          </p:cNvPr>
+          <p:cNvSpPr>
+            <a:spLocks xmlns:a="http://schemas.openxmlformats.org/drawingml/2006/main" noGrp="1"/>
+          </p:cNvSpPr>
+          <p:nvPr/>
+        </p:nvSpPr>
+        <p:spPr>
+          <a:xfrm xmlns:a="http://schemas.openxmlformats.org/drawingml/2006/main">
+            <a:off x="1543050" y="3590925"/>
+            <a:ext cx="3714750" cy="228600"/>
+          </a:xfrm>
+          <a:prstGeom xmlns:a="http://schemas.openxmlformats.org/drawingml/2006/main" prst="rect">
+            <a:avLst/>
+          </a:prstGeom>
+          <a:noFill xmlns:a="http://schemas.openxmlformats.org/drawingml/2006/main"/>
+          <a:ln xmlns:a="http://schemas.openxmlformats.org/drawingml/2006/main" w="0">
+            <a:noFill/>
+            <a:prstDash val="solid"/>
+          </a:ln>
+        </p:spPr>
+        <p:txBody>
+          <a:bodyPr xmlns:a="http://schemas.openxmlformats.org/drawingml/2006/main" lIns="0" tIns="0" rIns="0" bIns="0" anchor="t">
+            <a:normAutofit fontScale="100000"/>
+          </a:bodyPr>
+          <a:lstStyle xmlns:a="http://schemas.openxmlformats.org/drawingml/2006/main"/>
+          <a:p xmlns:a="http://schemas.openxmlformats.org/drawingml/2006/main">
+            <a:pPr algn="l">
+              <a:buNone/>
+              <a:defRPr sz="975" b="1" i="0">
+                <a:solidFill>
+                  <a:srgbClr val="5E666D"/>
+                </a:solidFill>
+                <a:latin typeface="Menlo"/>
+                <a:ea typeface="Menlo"/>
+                <a:cs typeface="Menlo"/>
+              </a:defRPr>
+            </a:pPr>
+            <a:r>
+              <a:rPr sz="975" b="1" i="0">
+                <a:solidFill>
+                  <a:srgbClr val="5E666D"/>
+                </a:solidFill>
+                <a:latin typeface="Menlo"/>
+                <a:ea typeface="Menlo"/>
+                <a:cs typeface="Menlo"/>
+              </a:rPr>
+              <a:t>SELECTION · RECOVERY · NO-CALL</a:t>
+            </a:r>
+          </a:p>
+        </p:txBody>
+      </p:sp>
+      <p:sp>
+        <p:nvSpPr>
+          <p:cNvPr id="19" name="">
+            <a:extLst xmlns:a="http://schemas.openxmlformats.org/drawingml/2006/main">
+              <a:ext uri="{FF2B5EF4-FFF2-40B4-BE49-F238E27FC236}">
+                <a16:creationId xmlns:a16="http://schemas.microsoft.com/office/drawing/2014/main" id="{6B987522-8C2D-4C4D-86C7-0BE5D7826950}"/>
+              </a:ext>
+            </a:extLst>
+          </p:cNvPr>
+          <p:cNvSpPr>
+            <a:spLocks xmlns:a="http://schemas.openxmlformats.org/drawingml/2006/main" noGrp="1"/>
+          </p:cNvSpPr>
+          <p:nvPr/>
+        </p:nvSpPr>
+        <p:spPr>
+          <a:xfrm xmlns:a="http://schemas.openxmlformats.org/drawingml/2006/main">
+            <a:off x="866775" y="4010025"/>
+            <a:ext cx="400050" cy="400050"/>
+          </a:xfrm>
+          <a:prstGeom xmlns:a="http://schemas.openxmlformats.org/drawingml/2006/main" prst="roundRect">
+            <a:avLst>
+              <a:gd name="adj" fmla="val 28571"/>
+            </a:avLst>
+          </a:prstGeom>
+          <a:solidFill xmlns:a="http://schemas.openxmlformats.org/drawingml/2006/main">
+            <a:srgbClr val="1769FF"/>
+          </a:solidFill>
+          <a:ln xmlns:a="http://schemas.openxmlformats.org/drawingml/2006/main" w="0">
+            <a:noFill/>
+            <a:prstDash val="solid"/>
+          </a:ln>
+        </p:spPr>
+      </p:sp>
+      <p:sp>
+        <p:nvSpPr>
+          <p:cNvPr id="20" name="">
+            <a:extLst xmlns:a="http://schemas.openxmlformats.org/drawingml/2006/main">
+              <a:ext uri="{FF2B5EF4-FFF2-40B4-BE49-F238E27FC236}">
+                <a16:creationId xmlns:a16="http://schemas.microsoft.com/office/drawing/2014/main" id="{99B203BB-87CE-43F8-86D2-FA819E171153}"/>
+              </a:ext>
+            </a:extLst>
+          </p:cNvPr>
+          <p:cNvSpPr>
+            <a:spLocks xmlns:a="http://schemas.openxmlformats.org/drawingml/2006/main" noGrp="1"/>
+          </p:cNvSpPr>
+          <p:nvPr/>
+        </p:nvSpPr>
+        <p:spPr>
+          <a:xfrm xmlns:a="http://schemas.openxmlformats.org/drawingml/2006/main">
+            <a:off x="866775" y="4133850"/>
+            <a:ext cx="400050" cy="152400"/>
+          </a:xfrm>
+          <a:prstGeom xmlns:a="http://schemas.openxmlformats.org/drawingml/2006/main" prst="rect">
+            <a:avLst/>
+          </a:prstGeom>
+          <a:noFill xmlns:a="http://schemas.openxmlformats.org/drawingml/2006/main"/>
+          <a:ln xmlns:a="http://schemas.openxmlformats.org/drawingml/2006/main" w="0">
+            <a:noFill/>
+            <a:prstDash val="solid"/>
+          </a:ln>
+        </p:spPr>
+        <p:txBody>
+          <a:bodyPr xmlns:a="http://schemas.openxmlformats.org/drawingml/2006/main" lIns="0" tIns="0" rIns="0" bIns="0" anchor="t">
+            <a:normAutofit fontScale="100000"/>
+          </a:bodyPr>
+          <a:lstStyle xmlns:a="http://schemas.openxmlformats.org/drawingml/2006/main"/>
+          <a:p xmlns:a="http://schemas.openxmlformats.org/drawingml/2006/main">
+            <a:pPr algn="ctr">
+              <a:buNone/>
+              <a:defRPr sz="825" b="1" i="0">
+                <a:solidFill>
+                  <a:srgbClr val="FFFFFF"/>
+                </a:solidFill>
+                <a:latin typeface="Menlo"/>
+                <a:ea typeface="Menlo"/>
+                <a:cs typeface="Menlo"/>
+              </a:defRPr>
+            </a:pPr>
+            <a:r>
+              <a:rPr sz="825" b="1" i="0">
+                <a:solidFill>
+                  <a:srgbClr val="FFFFFF"/>
+                </a:solidFill>
+                <a:latin typeface="Menlo"/>
+                <a:ea typeface="Menlo"/>
+                <a:cs typeface="Menlo"/>
+              </a:rPr>
+              <a:t>04</a:t>
+            </a:r>
+          </a:p>
+        </p:txBody>
+      </p:sp>
+      <p:sp>
+        <p:nvSpPr>
+          <p:cNvPr id="21" name="">
+            <a:extLst xmlns:a="http://schemas.openxmlformats.org/drawingml/2006/main">
+              <a:ext uri="{FF2B5EF4-FFF2-40B4-BE49-F238E27FC236}">
+                <a16:creationId xmlns:a16="http://schemas.microsoft.com/office/drawing/2014/main" id="{44E0907A-66E6-4641-8BA1-7632004EFE69}"/>
+              </a:ext>
+            </a:extLst>
+          </p:cNvPr>
+          <p:cNvSpPr>
+            <a:spLocks xmlns:a="http://schemas.openxmlformats.org/drawingml/2006/main" noGrp="1"/>
+          </p:cNvSpPr>
+          <p:nvPr/>
+        </p:nvSpPr>
+        <p:spPr>
+          <a:xfrm xmlns:a="http://schemas.openxmlformats.org/drawingml/2006/main">
+            <a:off x="1543050" y="3990975"/>
+            <a:ext cx="3143250" cy="323850"/>
+          </a:xfrm>
+          <a:prstGeom xmlns:a="http://schemas.openxmlformats.org/drawingml/2006/main" prst="rect">
+            <a:avLst/>
+          </a:prstGeom>
+          <a:noFill xmlns:a="http://schemas.openxmlformats.org/drawingml/2006/main"/>
+          <a:ln xmlns:a="http://schemas.openxmlformats.org/drawingml/2006/main" w="0">
+            <a:noFill/>
+            <a:prstDash val="solid"/>
+          </a:ln>
+        </p:spPr>
+        <p:txBody>
+          <a:bodyPr xmlns:a="http://schemas.openxmlformats.org/drawingml/2006/main" lIns="0" tIns="0" rIns="0" bIns="0" anchor="t">
+            <a:normAutofit fontScale="100000"/>
+          </a:bodyPr>
+          <a:lstStyle xmlns:a="http://schemas.openxmlformats.org/drawingml/2006/main"/>
+          <a:p xmlns:a="http://schemas.openxmlformats.org/drawingml/2006/main">
+            <a:pPr algn="l">
+              <a:buNone/>
+              <a:defRPr sz="1725" b="1" i="0">
+                <a:solidFill>
+                  <a:srgbClr val="111111"/>
+                </a:solidFill>
+                <a:latin typeface="Helvetica Neue"/>
+                <a:ea typeface="Helvetica Neue"/>
+                <a:cs typeface="Helvetica Neue"/>
+              </a:defRPr>
+            </a:pPr>
+            <a:r>
+              <a:rPr sz="1725" b="1" i="0">
+                <a:solidFill>
+                  <a:srgbClr val="111111"/>
+                </a:solidFill>
+                <a:latin typeface="Helvetica Neue"/>
+                <a:ea typeface="Helvetica Neue"/>
+                <a:cs typeface="Helvetica Neue"/>
+              </a:rPr>
+              <a:t>Workbench</a:t>
+            </a:r>
+          </a:p>
+        </p:txBody>
+      </p:sp>
+      <p:sp>
+        <p:nvSpPr>
+          <p:cNvPr id="22" name="">
+            <a:extLst xmlns:a="http://schemas.openxmlformats.org/drawingml/2006/main">
+              <a:ext uri="{FF2B5EF4-FFF2-40B4-BE49-F238E27FC236}">
+                <a16:creationId xmlns:a16="http://schemas.microsoft.com/office/drawing/2014/main" id="{A284B02F-A558-4641-BF0D-D07FE801933F}"/>
+              </a:ext>
+            </a:extLst>
+          </p:cNvPr>
+          <p:cNvSpPr>
+            <a:spLocks xmlns:a="http://schemas.openxmlformats.org/drawingml/2006/main" noGrp="1"/>
+          </p:cNvSpPr>
+          <p:nvPr/>
+        </p:nvSpPr>
+        <p:spPr>
+          <a:xfrm xmlns:a="http://schemas.openxmlformats.org/drawingml/2006/main">
+            <a:off x="1543050" y="4324350"/>
+            <a:ext cx="3714750" cy="228600"/>
+          </a:xfrm>
+          <a:prstGeom xmlns:a="http://schemas.openxmlformats.org/drawingml/2006/main" prst="rect">
+            <a:avLst/>
+          </a:prstGeom>
+          <a:noFill xmlns:a="http://schemas.openxmlformats.org/drawingml/2006/main"/>
+          <a:ln xmlns:a="http://schemas.openxmlformats.org/drawingml/2006/main" w="0">
+            <a:noFill/>
+            <a:prstDash val="solid"/>
+          </a:ln>
+        </p:spPr>
+        <p:txBody>
+          <a:bodyPr xmlns:a="http://schemas.openxmlformats.org/drawingml/2006/main" lIns="0" tIns="0" rIns="0" bIns="0" anchor="t">
+            <a:normAutofit fontScale="100000"/>
+          </a:bodyPr>
+          <a:lstStyle xmlns:a="http://schemas.openxmlformats.org/drawingml/2006/main"/>
+          <a:p xmlns:a="http://schemas.openxmlformats.org/drawingml/2006/main">
+            <a:pPr algn="l">
+              <a:buNone/>
+              <a:defRPr sz="975" b="1" i="0">
+                <a:solidFill>
+                  <a:srgbClr val="5E666D"/>
+                </a:solidFill>
+                <a:latin typeface="Menlo"/>
+                <a:ea typeface="Menlo"/>
+                <a:cs typeface="Menlo"/>
+              </a:defRPr>
+            </a:pPr>
+            <a:r>
+              <a:rPr sz="975" b="1" i="0">
+                <a:solidFill>
+                  <a:srgbClr val="5E666D"/>
+                </a:solidFill>
+                <a:latin typeface="Menlo"/>
+                <a:ea typeface="Menlo"/>
+                <a:cs typeface="Menlo"/>
+              </a:rPr>
+              <a:t>AUDIT · REPLAY · USER MODE</a:t>
+            </a:r>
+          </a:p>
+        </p:txBody>
+      </p:sp>
+      <p:sp>
+        <p:nvSpPr>
+          <p:cNvPr id="23" name="">
+            <a:extLst xmlns:a="http://schemas.openxmlformats.org/drawingml/2006/main">
+              <a:ext uri="{FF2B5EF4-FFF2-40B4-BE49-F238E27FC236}">
+                <a16:creationId xmlns:a16="http://schemas.microsoft.com/office/drawing/2014/main" id="{0984F2CF-D070-4F8D-B9DD-DB294E3A7E17}"/>
+              </a:ext>
+            </a:extLst>
+          </p:cNvPr>
+          <p:cNvSpPr>
+            <a:spLocks xmlns:a="http://schemas.openxmlformats.org/drawingml/2006/main" noGrp="1"/>
+          </p:cNvSpPr>
+          <p:nvPr/>
+        </p:nvSpPr>
+        <p:spPr>
+          <a:xfrm xmlns:a="http://schemas.openxmlformats.org/drawingml/2006/main">
+            <a:off x="866775" y="4743450"/>
+            <a:ext cx="400050" cy="400050"/>
+          </a:xfrm>
+          <a:prstGeom xmlns:a="http://schemas.openxmlformats.org/drawingml/2006/main" prst="roundRect">
+            <a:avLst>
+              <a:gd name="adj" fmla="val 28571"/>
+            </a:avLst>
+          </a:prstGeom>
+          <a:solidFill xmlns:a="http://schemas.openxmlformats.org/drawingml/2006/main">
+            <a:srgbClr val="1769FF"/>
+          </a:solidFill>
+          <a:ln xmlns:a="http://schemas.openxmlformats.org/drawingml/2006/main" w="0">
+            <a:noFill/>
+            <a:prstDash val="solid"/>
+          </a:ln>
+        </p:spPr>
+      </p:sp>
+      <p:sp>
+        <p:nvSpPr>
+          <p:cNvPr id="24" name="">
+            <a:extLst xmlns:a="http://schemas.openxmlformats.org/drawingml/2006/main">
+              <a:ext uri="{FF2B5EF4-FFF2-40B4-BE49-F238E27FC236}">
+                <a16:creationId xmlns:a16="http://schemas.microsoft.com/office/drawing/2014/main" id="{C91FCE5F-E792-4194-BC46-D305CB272B34}"/>
+              </a:ext>
+            </a:extLst>
+          </p:cNvPr>
+          <p:cNvSpPr>
+            <a:spLocks xmlns:a="http://schemas.openxmlformats.org/drawingml/2006/main" noGrp="1"/>
+          </p:cNvSpPr>
+          <p:nvPr/>
+        </p:nvSpPr>
+        <p:spPr>
+          <a:xfrm xmlns:a="http://schemas.openxmlformats.org/drawingml/2006/main">
+            <a:off x="866775" y="4867275"/>
+            <a:ext cx="400050" cy="152400"/>
+          </a:xfrm>
+          <a:prstGeom xmlns:a="http://schemas.openxmlformats.org/drawingml/2006/main" prst="rect">
+            <a:avLst/>
+          </a:prstGeom>
+          <a:noFill xmlns:a="http://schemas.openxmlformats.org/drawingml/2006/main"/>
+          <a:ln xmlns:a="http://schemas.openxmlformats.org/drawingml/2006/main" w="0">
+            <a:noFill/>
+            <a:prstDash val="solid"/>
+          </a:ln>
+        </p:spPr>
+        <p:txBody>
+          <a:bodyPr xmlns:a="http://schemas.openxmlformats.org/drawingml/2006/main" lIns="0" tIns="0" rIns="0" bIns="0" anchor="t">
+            <a:normAutofit fontScale="100000"/>
+          </a:bodyPr>
+          <a:lstStyle xmlns:a="http://schemas.openxmlformats.org/drawingml/2006/main"/>
+          <a:p xmlns:a="http://schemas.openxmlformats.org/drawingml/2006/main">
+            <a:pPr algn="ctr">
+              <a:buNone/>
+              <a:defRPr sz="825" b="1" i="0">
+                <a:solidFill>
+                  <a:srgbClr val="FFFFFF"/>
+                </a:solidFill>
+                <a:latin typeface="Menlo"/>
+                <a:ea typeface="Menlo"/>
+                <a:cs typeface="Menlo"/>
+              </a:defRPr>
+            </a:pPr>
+            <a:r>
+              <a:rPr sz="825" b="1" i="0">
+                <a:solidFill>
+                  <a:srgbClr val="FFFFFF"/>
+                </a:solidFill>
+                <a:latin typeface="Menlo"/>
+                <a:ea typeface="Menlo"/>
+                <a:cs typeface="Menlo"/>
+              </a:rPr>
+              <a:t>05</a:t>
+            </a:r>
+          </a:p>
+        </p:txBody>
+      </p:sp>
+      <p:sp>
+        <p:nvSpPr>
+          <p:cNvPr id="25" name="">
+            <a:extLst xmlns:a="http://schemas.openxmlformats.org/drawingml/2006/main">
+              <a:ext uri="{FF2B5EF4-FFF2-40B4-BE49-F238E27FC236}">
+                <a16:creationId xmlns:a16="http://schemas.microsoft.com/office/drawing/2014/main" id="{63B0682D-1427-41B3-82DB-147D087C56D3}"/>
+              </a:ext>
+            </a:extLst>
+          </p:cNvPr>
+          <p:cNvSpPr>
+            <a:spLocks xmlns:a="http://schemas.openxmlformats.org/drawingml/2006/main" noGrp="1"/>
+          </p:cNvSpPr>
+          <p:nvPr/>
+        </p:nvSpPr>
+        <p:spPr>
+          <a:xfrm xmlns:a="http://schemas.openxmlformats.org/drawingml/2006/main">
+            <a:off x="1543050" y="4724400"/>
+            <a:ext cx="3143250" cy="323850"/>
+          </a:xfrm>
+          <a:prstGeom xmlns:a="http://schemas.openxmlformats.org/drawingml/2006/main" prst="rect">
+            <a:avLst/>
+          </a:prstGeom>
+          <a:noFill xmlns:a="http://schemas.openxmlformats.org/drawingml/2006/main"/>
+          <a:ln xmlns:a="http://schemas.openxmlformats.org/drawingml/2006/main" w="0">
+            <a:noFill/>
+            <a:prstDash val="solid"/>
+          </a:ln>
+        </p:spPr>
+        <p:txBody>
+          <a:bodyPr xmlns:a="http://schemas.openxmlformats.org/drawingml/2006/main" lIns="0" tIns="0" rIns="0" bIns="0" anchor="t">
+            <a:normAutofit fontScale="100000"/>
+          </a:bodyPr>
+          <a:lstStyle xmlns:a="http://schemas.openxmlformats.org/drawingml/2006/main"/>
+          <a:p xmlns:a="http://schemas.openxmlformats.org/drawingml/2006/main">
+            <a:pPr algn="l">
+              <a:buNone/>
+              <a:defRPr sz="1725" b="1" i="0">
+                <a:solidFill>
+                  <a:srgbClr val="111111"/>
+                </a:solidFill>
+                <a:latin typeface="Helvetica Neue"/>
+                <a:ea typeface="Helvetica Neue"/>
+                <a:cs typeface="Helvetica Neue"/>
+              </a:defRPr>
+            </a:pPr>
+            <a:r>
+              <a:rPr sz="1725" b="1" i="0">
+                <a:solidFill>
+                  <a:srgbClr val="111111"/>
+                </a:solidFill>
+                <a:latin typeface="Helvetica Neue"/>
+                <a:ea typeface="Helvetica Neue"/>
+                <a:cs typeface="Helvetica Neue"/>
+              </a:rPr>
+              <a:t>Public listing</a:t>
+            </a:r>
+          </a:p>
+        </p:txBody>
+      </p:sp>
+      <p:sp>
+        <p:nvSpPr>
+          <p:cNvPr id="26" name="">
+            <a:extLst xmlns:a="http://schemas.openxmlformats.org/drawingml/2006/main">
+              <a:ext uri="{FF2B5EF4-FFF2-40B4-BE49-F238E27FC236}">
+                <a16:creationId xmlns:a16="http://schemas.microsoft.com/office/drawing/2014/main" id="{53DB5D56-7281-4F56-968D-0C5FC89A3327}"/>
+              </a:ext>
+            </a:extLst>
+          </p:cNvPr>
+          <p:cNvSpPr>
+            <a:spLocks xmlns:a="http://schemas.openxmlformats.org/drawingml/2006/main" noGrp="1"/>
+          </p:cNvSpPr>
+          <p:nvPr/>
+        </p:nvSpPr>
+        <p:spPr>
+          <a:xfrm xmlns:a="http://schemas.openxmlformats.org/drawingml/2006/main">
+            <a:off x="1543050" y="5057775"/>
+            <a:ext cx="3714750" cy="228600"/>
+          </a:xfrm>
+          <a:prstGeom xmlns:a="http://schemas.openxmlformats.org/drawingml/2006/main" prst="rect">
+            <a:avLst/>
+          </a:prstGeom>
+          <a:noFill xmlns:a="http://schemas.openxmlformats.org/drawingml/2006/main"/>
+          <a:ln xmlns:a="http://schemas.openxmlformats.org/drawingml/2006/main" w="0">
+            <a:noFill/>
+            <a:prstDash val="solid"/>
+          </a:ln>
+        </p:spPr>
+        <p:txBody>
+          <a:bodyPr xmlns:a="http://schemas.openxmlformats.org/drawingml/2006/main" lIns="0" tIns="0" rIns="0" bIns="0" anchor="t">
+            <a:normAutofit fontScale="100000"/>
+          </a:bodyPr>
+          <a:lstStyle xmlns:a="http://schemas.openxmlformats.org/drawingml/2006/main"/>
+          <a:p xmlns:a="http://schemas.openxmlformats.org/drawingml/2006/main">
+            <a:pPr algn="l">
+              <a:buNone/>
+              <a:defRPr sz="975" b="1" i="0">
+                <a:solidFill>
+                  <a:srgbClr val="5E666D"/>
+                </a:solidFill>
+                <a:latin typeface="Menlo"/>
+                <a:ea typeface="Menlo"/>
+                <a:cs typeface="Menlo"/>
+              </a:defRPr>
+            </a:pPr>
+            <a:r>
+              <a:rPr sz="975" b="1" i="0">
+                <a:solidFill>
+                  <a:srgbClr val="5E666D"/>
+                </a:solidFill>
+                <a:latin typeface="Menlo"/>
+                <a:ea typeface="Menlo"/>
+                <a:cs typeface="Menlo"/>
+              </a:rPr>
+              <a:t>SCANNER · DIRECTORY API</a:t>
+            </a:r>
+          </a:p>
+        </p:txBody>
+      </p:sp>
+      <p:sp>
+        <p:nvSpPr>
+          <p:cNvPr id="27" name="">
+            <a:extLst xmlns:a="http://schemas.openxmlformats.org/drawingml/2006/main">
+              <a:ext uri="{FF2B5EF4-FFF2-40B4-BE49-F238E27FC236}">
+                <a16:creationId xmlns:a16="http://schemas.microsoft.com/office/drawing/2014/main" id="{4BCD8BBC-EEDE-4134-89BC-B3773AF8D1E8}"/>
+              </a:ext>
+            </a:extLst>
+          </p:cNvPr>
+          <p:cNvSpPr>
+            <a:spLocks xmlns:a="http://schemas.openxmlformats.org/drawingml/2006/main" noGrp="1"/>
+          </p:cNvSpPr>
+          <p:nvPr/>
+        </p:nvSpPr>
+        <p:spPr>
+          <a:xfrm xmlns:a="http://schemas.openxmlformats.org/drawingml/2006/main">
+            <a:off x="6667500" y="1952625"/>
+            <a:ext cx="4591050" cy="3162300"/>
+          </a:xfrm>
+          <a:prstGeom xmlns:a="http://schemas.openxmlformats.org/drawingml/2006/main" prst="roundRect">
+            <a:avLst>
+              <a:gd name="adj" fmla="val 3614"/>
+            </a:avLst>
+          </a:prstGeom>
+          <a:solidFill xmlns:a="http://schemas.openxmlformats.org/drawingml/2006/main">
+            <a:srgbClr val="111111"/>
+          </a:solidFill>
+          <a:ln xmlns:a="http://schemas.openxmlformats.org/drawingml/2006/main" w="9525">
+            <a:solidFill>
+              <a:srgbClr val="111111"/>
+            </a:solidFill>
+            <a:prstDash val="solid"/>
+          </a:ln>
+        </p:spPr>
+      </p:sp>
+      <p:sp>
+        <p:nvSpPr>
+          <p:cNvPr id="28" name="">
+            <a:extLst xmlns:a="http://schemas.openxmlformats.org/drawingml/2006/main">
+              <a:ext uri="{FF2B5EF4-FFF2-40B4-BE49-F238E27FC236}">
+                <a16:creationId xmlns:a16="http://schemas.microsoft.com/office/drawing/2014/main" id="{7352F084-42B1-4C54-8E52-C6861992BDBA}"/>
+              </a:ext>
+            </a:extLst>
+          </p:cNvPr>
+          <p:cNvSpPr>
+            <a:spLocks xmlns:a="http://schemas.openxmlformats.org/drawingml/2006/main" noGrp="1"/>
+          </p:cNvSpPr>
+          <p:nvPr/>
+        </p:nvSpPr>
+        <p:spPr>
+          <a:xfrm xmlns:a="http://schemas.openxmlformats.org/drawingml/2006/main">
+            <a:off x="6953250" y="2238375"/>
+            <a:ext cx="1714500" cy="228600"/>
+          </a:xfrm>
+          <a:prstGeom xmlns:a="http://schemas.openxmlformats.org/drawingml/2006/main" prst="rect">
+            <a:avLst/>
+          </a:prstGeom>
+          <a:noFill xmlns:a="http://schemas.openxmlformats.org/drawingml/2006/main"/>
+          <a:ln xmlns:a="http://schemas.openxmlformats.org/drawingml/2006/main" w="0">
+            <a:noFill/>
+            <a:prstDash val="solid"/>
+          </a:ln>
+        </p:spPr>
+        <p:txBody>
+          <a:bodyPr xmlns:a="http://schemas.openxmlformats.org/drawingml/2006/main" lIns="0" tIns="0" rIns="0" bIns="0" anchor="t">
+            <a:normAutofit fontScale="100000"/>
+          </a:bodyPr>
+          <a:lstStyle xmlns:a="http://schemas.openxmlformats.org/drawingml/2006/main"/>
+          <a:p xmlns:a="http://schemas.openxmlformats.org/drawingml/2006/main">
+            <a:pPr algn="l">
+              <a:buNone/>
+              <a:defRPr sz="975" b="1" i="0">
+                <a:solidFill>
+                  <a:srgbClr val="DCE8FF"/>
+                </a:solidFill>
+                <a:latin typeface="Menlo"/>
+                <a:ea typeface="Menlo"/>
+                <a:cs typeface="Menlo"/>
+              </a:defRPr>
+            </a:pPr>
+            <a:r>
+              <a:rPr sz="975" b="1" i="0">
+                <a:solidFill>
+                  <a:srgbClr val="DCE8FF"/>
+                </a:solidFill>
+                <a:latin typeface="Menlo"/>
+                <a:ea typeface="Menlo"/>
+                <a:cs typeface="Menlo"/>
+              </a:rPr>
+              <a:t>PROVEN LOCALLY</a:t>
+            </a:r>
+          </a:p>
+        </p:txBody>
+      </p:sp>
+      <p:sp>
+        <p:nvSpPr>
+          <p:cNvPr id="29" name="">
+            <a:extLst xmlns:a="http://schemas.openxmlformats.org/drawingml/2006/main">
+              <a:ext uri="{FF2B5EF4-FFF2-40B4-BE49-F238E27FC236}">
+                <a16:creationId xmlns:a16="http://schemas.microsoft.com/office/drawing/2014/main" id="{04A728AE-B6DC-4406-9019-6B025444FED8}"/>
+              </a:ext>
+            </a:extLst>
+          </p:cNvPr>
+          <p:cNvSpPr>
+            <a:spLocks xmlns:a="http://schemas.openxmlformats.org/drawingml/2006/main" noGrp="1"/>
+          </p:cNvSpPr>
+          <p:nvPr/>
+        </p:nvSpPr>
+        <p:spPr>
+          <a:xfrm xmlns:a="http://schemas.openxmlformats.org/drawingml/2006/main">
+            <a:off x="6953250" y="2600325"/>
+            <a:ext cx="3714750" cy="514350"/>
+          </a:xfrm>
+          <a:prstGeom xmlns:a="http://schemas.openxmlformats.org/drawingml/2006/main" prst="rect">
+            <a:avLst/>
+          </a:prstGeom>
+          <a:noFill xmlns:a="http://schemas.openxmlformats.org/drawingml/2006/main"/>
+          <a:ln xmlns:a="http://schemas.openxmlformats.org/drawingml/2006/main" w="0">
+            <a:noFill/>
+            <a:prstDash val="solid"/>
+          </a:ln>
+        </p:spPr>
+        <p:txBody>
+          <a:bodyPr xmlns:a="http://schemas.openxmlformats.org/drawingml/2006/main" lIns="0" tIns="0" rIns="0" bIns="0" anchor="t">
+            <a:normAutofit fontScale="100000"/>
+          </a:bodyPr>
+          <a:lstStyle xmlns:a="http://schemas.openxmlformats.org/drawingml/2006/main"/>
+          <a:p xmlns:a="http://schemas.openxmlformats.org/drawingml/2006/main">
+            <a:pPr algn="l">
+              <a:buNone/>
+              <a:defRPr sz="2700" b="1" i="0">
+                <a:solidFill>
+                  <a:srgbClr val="FFFFFF"/>
+                </a:solidFill>
+                <a:latin typeface="Helvetica Neue"/>
+                <a:ea typeface="Helvetica Neue"/>
+                <a:cs typeface="Helvetica Neue"/>
+              </a:defRPr>
+            </a:pPr>
+            <a:r>
+              <a:rPr sz="2700" b="1" i="0">
+                <a:solidFill>
+                  <a:srgbClr val="FFFFFF"/>
+                </a:solidFill>
+                <a:latin typeface="Helvetica Neue"/>
+                <a:ea typeface="Helvetica Neue"/>
+                <a:cs typeface="Helvetica Neue"/>
+              </a:rPr>
+              <a:t>Native + deterministic</a:t>
+            </a:r>
+          </a:p>
+        </p:txBody>
+      </p:sp>
+      <p:cxnSp>
+        <p:nvCxnSpPr>
+          <p:cNvPr id="273" name=""/>
+          <p:cNvCxnSpPr/>
+          <p:nvPr/>
+        </p:nvCxnSpPr>
+        <p:spPr>
+          <a:xfrm xmlns:a="http://schemas.openxmlformats.org/drawingml/2006/main">
+            <a:off x="6953250" y="3248025"/>
+            <a:ext cx="3714750" cy="0"/>
+          </a:xfrm>
+          <a:prstGeom xmlns:a="http://schemas.openxmlformats.org/drawingml/2006/main" prst="straightConnector1">
+            <a:avLst/>
+          </a:prstGeom>
+          <a:ln xmlns:a="http://schemas.openxmlformats.org/drawingml/2006/main" w="9525">
+            <a:solidFill>
+              <a:srgbClr val="4A5260"/>
+            </a:solidFill>
+            <a:prstDash val="solid"/>
+          </a:ln>
+        </p:spPr>
+      </p:cxnSp>
+      <p:sp>
+        <p:nvSpPr>
+          <p:cNvPr id="31" name="">
+            <a:extLst xmlns:a="http://schemas.openxmlformats.org/drawingml/2006/main">
+              <a:ext uri="{FF2B5EF4-FFF2-40B4-BE49-F238E27FC236}">
+                <a16:creationId xmlns:a16="http://schemas.microsoft.com/office/drawing/2014/main" id="{724B710B-93AD-4F55-860C-8F692366B170}"/>
+              </a:ext>
+            </a:extLst>
+          </p:cNvPr>
+          <p:cNvSpPr>
+            <a:spLocks xmlns:a="http://schemas.openxmlformats.org/drawingml/2006/main" noGrp="1"/>
+          </p:cNvSpPr>
+          <p:nvPr/>
+        </p:nvSpPr>
+        <p:spPr>
+          <a:xfrm xmlns:a="http://schemas.openxmlformats.org/drawingml/2006/main">
+            <a:off x="6953250" y="3533775"/>
+            <a:ext cx="3714750" cy="228600"/>
+          </a:xfrm>
+          <a:prstGeom xmlns:a="http://schemas.openxmlformats.org/drawingml/2006/main" prst="rect">
+            <a:avLst/>
+          </a:prstGeom>
+          <a:noFill xmlns:a="http://schemas.openxmlformats.org/drawingml/2006/main"/>
+          <a:ln xmlns:a="http://schemas.openxmlformats.org/drawingml/2006/main" w="0">
+            <a:noFill/>
+            <a:prstDash val="solid"/>
+          </a:ln>
+        </p:spPr>
+        <p:txBody>
+          <a:bodyPr xmlns:a="http://schemas.openxmlformats.org/drawingml/2006/main" lIns="0" tIns="0" rIns="0" bIns="0" anchor="t">
+            <a:normAutofit fontScale="100000"/>
+          </a:bodyPr>
+          <a:lstStyle xmlns:a="http://schemas.openxmlformats.org/drawingml/2006/main"/>
+          <a:p xmlns:a="http://schemas.openxmlformats.org/drawingml/2006/main">
+            <a:pPr algn="l">
+              <a:buNone/>
+              <a:defRPr sz="975" b="1" i="0">
+                <a:solidFill>
+                  <a:srgbClr val="AEB5BE"/>
+                </a:solidFill>
+                <a:latin typeface="Menlo"/>
+                <a:ea typeface="Menlo"/>
+                <a:cs typeface="Menlo"/>
+              </a:defRPr>
+            </a:pPr>
+            <a:r>
+              <a:rPr sz="975" b="1" i="0">
+                <a:solidFill>
+                  <a:srgbClr val="AEB5BE"/>
+                </a:solidFill>
+                <a:latin typeface="Menlo"/>
+                <a:ea typeface="Menlo"/>
+                <a:cs typeface="Menlo"/>
+              </a:rPr>
+              <a:t>RELEASE OWNER GATES</a:t>
+            </a:r>
+          </a:p>
+        </p:txBody>
+      </p:sp>
+      <p:sp>
+        <p:nvSpPr>
+          <p:cNvPr id="32" name="">
+            <a:extLst xmlns:a="http://schemas.openxmlformats.org/drawingml/2006/main">
+              <a:ext uri="{FF2B5EF4-FFF2-40B4-BE49-F238E27FC236}">
+                <a16:creationId xmlns:a16="http://schemas.microsoft.com/office/drawing/2014/main" id="{EA0685BA-B383-4726-A0BD-88A9CEA8E137}"/>
+              </a:ext>
+            </a:extLst>
+          </p:cNvPr>
+          <p:cNvSpPr>
+            <a:spLocks xmlns:a="http://schemas.openxmlformats.org/drawingml/2006/main" noGrp="1"/>
+          </p:cNvSpPr>
+          <p:nvPr/>
+        </p:nvSpPr>
+        <p:spPr>
+          <a:xfrm xmlns:a="http://schemas.openxmlformats.org/drawingml/2006/main">
+            <a:off x="6953250" y="3886200"/>
+            <a:ext cx="3714750" cy="1028700"/>
+          </a:xfrm>
+          <a:prstGeom xmlns:a="http://schemas.openxmlformats.org/drawingml/2006/main" prst="rect">
+            <a:avLst/>
+          </a:prstGeom>
+          <a:noFill xmlns:a="http://schemas.openxmlformats.org/drawingml/2006/main"/>
+          <a:ln xmlns:a="http://schemas.openxmlformats.org/drawingml/2006/main" w="0">
+            <a:noFill/>
+            <a:prstDash val="solid"/>
+          </a:ln>
+        </p:spPr>
+        <p:txBody>
+          <a:bodyPr xmlns:a="http://schemas.openxmlformats.org/drawingml/2006/main" lIns="0" tIns="0" rIns="0" bIns="0" anchor="t">
+            <a:normAutofit fontScale="93750"/>
+          </a:bodyPr>
+          <a:lstStyle xmlns:a="http://schemas.openxmlformats.org/drawingml/2006/main"/>
+          <a:p xmlns:a="http://schemas.openxmlformats.org/drawingml/2006/main">
+            <a:pPr algn="l">
+              <a:buNone/>
+              <a:defRPr sz="1800" b="1" i="0">
+                <a:solidFill>
+                  <a:srgbClr val="FFFFFF"/>
+                </a:solidFill>
+                <a:latin typeface="Helvetica Neue"/>
+                <a:ea typeface="Helvetica Neue"/>
+                <a:cs typeface="Helvetica Neue"/>
+              </a:defRPr>
+            </a:pPr>
+            <a:r>
+              <a:rPr sz="1800" b="1" i="0">
+                <a:solidFill>
+                  <a:srgbClr val="FFFFFF"/>
+                </a:solidFill>
+                <a:latin typeface="Helvetica Neue"/>
+                <a:ea typeface="Helvetica Neue"/>
+                <a:cs typeface="Helvetica Neue"/>
+              </a:rPr>
+              <a:t>Model evals</a:t>
+            </a:r>
+          </a:p>
+          <a:p xmlns:a="http://schemas.openxmlformats.org/drawingml/2006/main">
+            <a:pPr algn="l">
+              <a:buNone/>
+              <a:defRPr sz="1800" b="1" i="0">
+                <a:solidFill>
+                  <a:srgbClr val="FFFFFF"/>
+                </a:solidFill>
+                <a:latin typeface="Helvetica Neue"/>
+                <a:ea typeface="Helvetica Neue"/>
+                <a:cs typeface="Helvetica Neue"/>
+              </a:defRPr>
+            </a:pPr>
+            <a:r>
+              <a:rPr sz="1800" b="1" i="0">
+                <a:solidFill>
+                  <a:srgbClr val="FFFFFF"/>
+                </a:solidFill>
+                <a:latin typeface="Helvetica Neue"/>
+                <a:ea typeface="Helvetica Neue"/>
+                <a:cs typeface="Helvetica Neue"/>
+              </a:rPr>
+              <a:t>Workbench</a:t>
+            </a:r>
+          </a:p>
+          <a:p xmlns:a="http://schemas.openxmlformats.org/drawingml/2006/main">
+            <a:pPr algn="l">
+              <a:buNone/>
+              <a:defRPr sz="1800" b="1" i="0">
+                <a:solidFill>
+                  <a:srgbClr val="FFFFFF"/>
+                </a:solidFill>
+                <a:latin typeface="Helvetica Neue"/>
+                <a:ea typeface="Helvetica Neue"/>
+                <a:cs typeface="Helvetica Neue"/>
+              </a:defRPr>
+            </a:pPr>
+            <a:r>
+              <a:rPr sz="1800" b="1" i="0">
+                <a:solidFill>
+                  <a:srgbClr val="FFFFFF"/>
+                </a:solidFill>
+                <a:latin typeface="Helvetica Neue"/>
+                <a:ea typeface="Helvetica Neue"/>
+                <a:cs typeface="Helvetica Neue"/>
+              </a:rPr>
+              <a:t>Hosted scanner</a:t>
+            </a:r>
+          </a:p>
+          <a:p xmlns:a="http://schemas.openxmlformats.org/drawingml/2006/main">
+            <a:pPr algn="l">
+              <a:buNone/>
+              <a:defRPr sz="1800" b="1" i="0">
+                <a:solidFill>
+                  <a:srgbClr val="FFFFFF"/>
+                </a:solidFill>
+                <a:latin typeface="Helvetica Neue"/>
+                <a:ea typeface="Helvetica Neue"/>
+                <a:cs typeface="Helvetica Neue"/>
+              </a:defRPr>
+            </a:pPr>
+            <a:r>
+              <a:rPr sz="1800" b="1" i="0">
+                <a:solidFill>
+                  <a:srgbClr val="FFFFFF"/>
+                </a:solidFill>
+                <a:latin typeface="Helvetica Neue"/>
+                <a:ea typeface="Helvetica Neue"/>
+                <a:cs typeface="Helvetica Neue"/>
+              </a:rPr>
+              <a:t>Directory listing</a:t>
+            </a:r>
+          </a:p>
+        </p:txBody>
+      </p:sp>
+      <p:sp>
+        <p:nvSpPr>
+          <p:cNvPr id="33" name="">
+            <a:extLst xmlns:a="http://schemas.openxmlformats.org/drawingml/2006/main">
+              <a:ext uri="{FF2B5EF4-FFF2-40B4-BE49-F238E27FC236}">
+                <a16:creationId xmlns:a16="http://schemas.microsoft.com/office/drawing/2014/main" id="{97471E82-3677-49C6-8FC7-0A2AE03A63E0}"/>
+              </a:ext>
+            </a:extLst>
+          </p:cNvPr>
+          <p:cNvSpPr>
+            <a:spLocks xmlns:a="http://schemas.openxmlformats.org/drawingml/2006/main" noGrp="1"/>
+          </p:cNvSpPr>
+          <p:nvPr/>
+        </p:nvSpPr>
+        <p:spPr>
+          <a:xfrm xmlns:a="http://schemas.openxmlformats.org/drawingml/2006/main">
+            <a:off x="6667500" y="5391150"/>
+            <a:ext cx="4591050" cy="228600"/>
+          </a:xfrm>
+          <a:prstGeom xmlns:a="http://schemas.openxmlformats.org/drawingml/2006/main" prst="rect">
+            <a:avLst/>
+          </a:prstGeom>
+          <a:noFill xmlns:a="http://schemas.openxmlformats.org/drawingml/2006/main"/>
+          <a:ln xmlns:a="http://schemas.openxmlformats.org/drawingml/2006/main" w="0">
+            <a:noFill/>
+            <a:prstDash val="solid"/>
+          </a:ln>
+        </p:spPr>
+        <p:txBody>
+          <a:bodyPr xmlns:a="http://schemas.openxmlformats.org/drawingml/2006/main" lIns="0" tIns="0" rIns="0" bIns="0" anchor="t">
+            <a:normAutofit fontScale="100000"/>
+          </a:bodyPr>
+          <a:lstStyle xmlns:a="http://schemas.openxmlformats.org/drawingml/2006/main"/>
+          <a:p xmlns:a="http://schemas.openxmlformats.org/drawingml/2006/main">
+            <a:pPr algn="l">
+              <a:buNone/>
+              <a:defRPr sz="975" b="1" i="0">
+                <a:solidFill>
+                  <a:srgbClr val="5E666D"/>
+                </a:solidFill>
+                <a:latin typeface="Menlo"/>
+                <a:ea typeface="Menlo"/>
+                <a:cs typeface="Menlo"/>
+              </a:defRPr>
+            </a:pPr>
+            <a:r>
+              <a:rPr sz="975" b="1" i="0">
+                <a:solidFill>
+                  <a:srgbClr val="5E666D"/>
+                </a:solidFill>
+                <a:latin typeface="Menlo"/>
+                <a:ea typeface="Menlo"/>
+                <a:cs typeface="Menlo"/>
+              </a:rPr>
+              <a:t>EXTERNAL EVIDENCE RUNS ONLY AGAINST THE FROZEN RELEASE.</a:t>
+            </a:r>
+          </a:p>
+        </p:txBody>
+      </p:sp>
+    </p:spTree>
+    <p:extLst>
+      <p:ext uri="{BB962C8B-B14F-4D97-AF65-F5344CB8AC3E}">
+        <p14:creationId xmlns:p14="http://schemas.microsoft.com/office/powerpoint/2010/main" val="834199393"/>
+      </p:ext>
+    </p:extLst>
+  </p:cSld>
+</p:sld>
+</file>
+
+<file path=ppt/slides/slide11.xml><?xml version="1.0" encoding="utf-8"?>
+<p:sld xmlns:p="http://schemas.openxmlformats.org/presentationml/2006/main">
+  <p:cSld>
+    <p:bg>
+      <p:bgPr>
+        <a:solidFill xmlns:a="http://schemas.openxmlformats.org/drawingml/2006/main">
+          <a:srgbClr val="FFFFFF"/>
+        </a:solidFill>
+      </p:bgPr>
+    </p:bg>
+    <p:spTree>
+      <p:nvGrpSpPr>
+        <p:cNvPr id="1" name=""/>
+        <p:cNvGrpSpPr/>
+        <p:nvPr/>
+      </p:nvGrpSpPr>
+      <p:grpSpPr>
+        <a:xfrm xmlns:a="http://schemas.openxmlformats.org/drawingml/2006/main"/>
+      </p:grpSpPr>
+      <p:sp>
+        <p:nvSpPr>
+          <p:cNvPr id="24" name="">
+            <a:extLst xmlns:a="http://schemas.openxmlformats.org/drawingml/2006/main">
+              <a:ext uri="{FF2B5EF4-FFF2-40B4-BE49-F238E27FC236}">
+                <a16:creationId xmlns:a16="http://schemas.microsoft.com/office/drawing/2014/main" id="{AB2191F0-2E06-41A8-A101-0072BB1AB539}"/>
+              </a:ext>
+            </a:extLst>
+          </p:cNvPr>
+          <p:cNvSpPr>
+            <a:spLocks xmlns:a="http://schemas.openxmlformats.org/drawingml/2006/main" noGrp="1"/>
+          </p:cNvSpPr>
+          <p:nvPr/>
+        </p:nvSpPr>
+        <p:spPr>
+          <a:xfrm xmlns:a="http://schemas.openxmlformats.org/drawingml/2006/main">
+            <a:off x="533400" y="381000"/>
+            <a:ext cx="6096000" cy="228600"/>
+          </a:xfrm>
+          <a:prstGeom xmlns:a="http://schemas.openxmlformats.org/drawingml/2006/main" prst="rect">
+            <a:avLst/>
+          </a:prstGeom>
+          <a:noFill xmlns:a="http://schemas.openxmlformats.org/drawingml/2006/main"/>
+          <a:ln xmlns:a="http://schemas.openxmlformats.org/drawingml/2006/main" w="0">
+            <a:noFill/>
+            <a:prstDash val="solid"/>
+          </a:ln>
+        </p:spPr>
+        <p:txBody>
+          <a:bodyPr xmlns:a="http://schemas.openxmlformats.org/drawingml/2006/main" lIns="0" tIns="0" rIns="0" bIns="0" anchor="t">
+            <a:normAutofit fontScale="100000"/>
+          </a:bodyPr>
+          <a:lstStyle xmlns:a="http://schemas.openxmlformats.org/drawingml/2006/main"/>
+          <a:p xmlns:a="http://schemas.openxmlformats.org/drawingml/2006/main">
+            <a:pPr algn="l">
+              <a:buNone/>
+              <a:defRPr sz="975" b="1" i="0">
+                <a:solidFill>
+                  <a:srgbClr val="1769FF"/>
+                </a:solidFill>
+                <a:latin typeface="Menlo"/>
+                <a:ea typeface="Menlo"/>
+                <a:cs typeface="Menlo"/>
+              </a:defRPr>
+            </a:pPr>
+            <a:r>
+              <a:rPr sz="975" b="1" i="0">
+                <a:solidFill>
+                  <a:srgbClr val="1769FF"/>
+                </a:solidFill>
+                <a:latin typeface="Menlo"/>
+                <a:ea typeface="Menlo"/>
+                <a:cs typeface="Menlo"/>
+              </a:rPr>
+              <a:t>PROOF</a:t>
+            </a:r>
+          </a:p>
+        </p:txBody>
+      </p:sp>
+      <p:sp>
+        <p:nvSpPr>
+          <p:cNvPr id="2" name="">
+            <a:extLst xmlns:a="http://schemas.openxmlformats.org/drawingml/2006/main">
+              <a:ext uri="{FF2B5EF4-FFF2-40B4-BE49-F238E27FC236}">
+                <a16:creationId xmlns:a16="http://schemas.microsoft.com/office/drawing/2014/main" id="{554A02D3-69CF-45D7-8D83-4914905B8499}"/>
+              </a:ext>
+            </a:extLst>
+          </p:cNvPr>
+          <p:cNvSpPr>
+            <a:spLocks xmlns:a="http://schemas.openxmlformats.org/drawingml/2006/main" noGrp="1"/>
+          </p:cNvSpPr>
+          <p:nvPr/>
+        </p:nvSpPr>
+        <p:spPr>
+          <a:xfrm xmlns:a="http://schemas.openxmlformats.org/drawingml/2006/main">
+            <a:off x="533400" y="723900"/>
+            <a:ext cx="11125200" cy="857250"/>
+          </a:xfrm>
+          <a:prstGeom xmlns:a="http://schemas.openxmlformats.org/drawingml/2006/main" prst="rect">
+            <a:avLst/>
+          </a:prstGeom>
+          <a:noFill xmlns:a="http://schemas.openxmlformats.org/drawingml/2006/main"/>
+          <a:ln xmlns:a="http://schemas.openxmlformats.org/drawingml/2006/main" w="0">
+            <a:noFill/>
+            <a:prstDash val="solid"/>
+          </a:ln>
+        </p:spPr>
+        <p:txBody>
+          <a:bodyPr xmlns:a="http://schemas.openxmlformats.org/drawingml/2006/main" lIns="0" tIns="0" rIns="0" bIns="0" anchor="t">
+            <a:normAutofit fontScale="100000"/>
+          </a:bodyPr>
+          <a:lstStyle xmlns:a="http://schemas.openxmlformats.org/drawingml/2006/main"/>
+          <a:p xmlns:a="http://schemas.openxmlformats.org/drawingml/2006/main">
+            <a:pPr algn="l">
+              <a:buNone/>
+              <a:defRPr sz="3150" b="1" i="0">
+                <a:solidFill>
+                  <a:srgbClr val="111111"/>
+                </a:solidFill>
+                <a:latin typeface="Helvetica Neue"/>
+                <a:ea typeface="Helvetica Neue"/>
+                <a:cs typeface="Helvetica Neue"/>
+              </a:defRPr>
+            </a:pPr>
+            <a:r>
+              <a:rPr sz="3150" b="1" i="0">
+                <a:solidFill>
+                  <a:srgbClr val="111111"/>
+                </a:solidFill>
+                <a:latin typeface="Helvetica Neue"/>
+                <a:ea typeface="Helvetica Neue"/>
+                <a:cs typeface="Helvetica Neue"/>
+              </a:rPr>
+              <a:t>The critical boundaries are tested, not staged.</a:t>
+            </a:r>
+          </a:p>
+        </p:txBody>
+      </p:sp>
+      <p:cxnSp>
+        <p:nvCxnSpPr>
+          <p:cNvPr id="180" name=""/>
+          <p:cNvCxnSpPr/>
+          <p:nvPr/>
+        </p:nvCxnSpPr>
+        <p:spPr>
+          <a:xfrm xmlns:a="http://schemas.openxmlformats.org/drawingml/2006/main">
+            <a:off x="533400" y="6457950"/>
+            <a:ext cx="11125200" cy="0"/>
+          </a:xfrm>
+          <a:prstGeom xmlns:a="http://schemas.openxmlformats.org/drawingml/2006/main" prst="straightConnector1">
+            <a:avLst/>
+          </a:prstGeom>
+          <a:ln xmlns:a="http://schemas.openxmlformats.org/drawingml/2006/main" w="9525">
+            <a:solidFill>
+              <a:srgbClr val="D1D5D8"/>
+            </a:solidFill>
+            <a:prstDash val="solid"/>
+          </a:ln>
+        </p:spPr>
+      </p:cxnSp>
+      <p:sp>
+        <p:nvSpPr>
+          <p:cNvPr id="4" name="">
+            <a:extLst xmlns:a="http://schemas.openxmlformats.org/drawingml/2006/main">
+              <a:ext uri="{FF2B5EF4-FFF2-40B4-BE49-F238E27FC236}">
+                <a16:creationId xmlns:a16="http://schemas.microsoft.com/office/drawing/2014/main" id="{E20B2E0A-BB09-46B7-82E4-234C9EA69585}"/>
+              </a:ext>
+            </a:extLst>
+          </p:cNvPr>
+          <p:cNvSpPr>
+            <a:spLocks xmlns:a="http://schemas.openxmlformats.org/drawingml/2006/main" noGrp="1"/>
+          </p:cNvSpPr>
+          <p:nvPr/>
+        </p:nvSpPr>
+        <p:spPr>
+          <a:xfrm xmlns:a="http://schemas.openxmlformats.org/drawingml/2006/main">
+            <a:off x="533400" y="6553200"/>
+            <a:ext cx="3048000" cy="228600"/>
+          </a:xfrm>
+          <a:prstGeom xmlns:a="http://schemas.openxmlformats.org/drawingml/2006/main" prst="rect">
+            <a:avLst/>
+          </a:prstGeom>
+          <a:noFill xmlns:a="http://schemas.openxmlformats.org/drawingml/2006/main"/>
+          <a:ln xmlns:a="http://schemas.openxmlformats.org/drawingml/2006/main" w="0">
+            <a:noFill/>
+            <a:prstDash val="solid"/>
+          </a:ln>
+        </p:spPr>
+        <p:txBody>
+          <a:bodyPr xmlns:a="http://schemas.openxmlformats.org/drawingml/2006/main" lIns="0" tIns="0" rIns="0" bIns="0" anchor="t">
+            <a:normAutofit fontScale="100000"/>
+          </a:bodyPr>
+          <a:lstStyle xmlns:a="http://schemas.openxmlformats.org/drawingml/2006/main"/>
+          <a:p xmlns:a="http://schemas.openxmlformats.org/drawingml/2006/main">
+            <a:pPr algn="l">
+              <a:buNone/>
+              <a:defRPr sz="975" b="1" i="0">
+                <a:solidFill>
+                  <a:srgbClr val="5E666D"/>
+                </a:solidFill>
+                <a:latin typeface="Menlo"/>
+                <a:ea typeface="Menlo"/>
+                <a:cs typeface="Menlo"/>
+              </a:defRPr>
+            </a:pPr>
+            <a:r>
+              <a:rPr sz="975" b="1" i="0">
+                <a:solidFill>
+                  <a:srgbClr val="5E666D"/>
+                </a:solidFill>
+                <a:latin typeface="Menlo"/>
+                <a:ea typeface="Menlo"/>
+                <a:cs typeface="Menlo"/>
+              </a:rPr>
+              <a:t>AGENT SNR · HACKATHON DEMO</a:t>
+            </a:r>
+          </a:p>
+        </p:txBody>
+      </p:sp>
+      <p:sp>
+        <p:nvSpPr>
+          <p:cNvPr id="5" name="">
+            <a:extLst xmlns:a="http://schemas.openxmlformats.org/drawingml/2006/main">
+              <a:ext uri="{FF2B5EF4-FFF2-40B4-BE49-F238E27FC236}">
+                <a16:creationId xmlns:a16="http://schemas.microsoft.com/office/drawing/2014/main" id="{392DEE81-DBCB-409E-885A-490F268243F6}"/>
+              </a:ext>
+            </a:extLst>
+          </p:cNvPr>
+          <p:cNvSpPr>
+            <a:spLocks xmlns:a="http://schemas.openxmlformats.org/drawingml/2006/main" noGrp="1"/>
+          </p:cNvSpPr>
+          <p:nvPr/>
+        </p:nvSpPr>
+        <p:spPr>
+          <a:xfrm xmlns:a="http://schemas.openxmlformats.org/drawingml/2006/main">
+            <a:off x="11049000" y="6534150"/>
+            <a:ext cx="609600" cy="190500"/>
+          </a:xfrm>
+          <a:prstGeom xmlns:a="http://schemas.openxmlformats.org/drawingml/2006/main" prst="rect">
+            <a:avLst/>
+          </a:prstGeom>
+          <a:noFill xmlns:a="http://schemas.openxmlformats.org/drawingml/2006/main"/>
+          <a:ln xmlns:a="http://schemas.openxmlformats.org/drawingml/2006/main" w="0">
+            <a:noFill/>
+            <a:prstDash val="solid"/>
+          </a:ln>
+        </p:spPr>
+        <p:txBody>
+          <a:bodyPr xmlns:a="http://schemas.openxmlformats.org/drawingml/2006/main" lIns="0" tIns="0" rIns="0" bIns="0" anchor="t">
+            <a:normAutofit fontScale="100000"/>
+          </a:bodyPr>
+          <a:lstStyle xmlns:a="http://schemas.openxmlformats.org/drawingml/2006/main"/>
+          <a:p xmlns:a="http://schemas.openxmlformats.org/drawingml/2006/main">
+            <a:pPr algn="r">
+              <a:buNone/>
+              <a:defRPr sz="975" b="1" i="0">
+                <a:solidFill>
+                  <a:srgbClr val="5E666D"/>
+                </a:solidFill>
+                <a:latin typeface="Menlo"/>
+                <a:ea typeface="Menlo"/>
+                <a:cs typeface="Menlo"/>
+              </a:defRPr>
+            </a:pPr>
+            <a:r>
+              <a:rPr sz="975" b="1" i="0">
+                <a:solidFill>
+                  <a:srgbClr val="5E666D"/>
+                </a:solidFill>
+                <a:latin typeface="Menlo"/>
+                <a:ea typeface="Menlo"/>
+                <a:cs typeface="Menlo"/>
+              </a:rPr>
+              <a:t>11</a:t>
+            </a:r>
+          </a:p>
+        </p:txBody>
+      </p:sp>
       <p:sp>
         <p:nvSpPr>
           <p:cNvPr id="6" name="">
@@ -2914,14 +4808,14 @@
                 <a:ea typeface="Helvetica Neue"/>
                 <a:cs typeface="Helvetica Neue"/>
               </a:rPr>
-              <a:t>91</a:t>
+              <a:t>108</a:t>
             </a:r>
           </a:p>
         </p:txBody>
       </p:sp>
       <p:cxnSp>
         <p:nvCxnSpPr>
-          <p:cNvPr id="140" name=""/>
+          <p:cNvPr id="184" name=""/>
           <p:cNvCxnSpPr/>
           <p:nvPr/>
         </p:nvCxnSpPr>
@@ -3054,14 +4948,14 @@
                 <a:ea typeface="Helvetica Neue"/>
                 <a:cs typeface="Helvetica Neue"/>
               </a:rPr>
-              <a:t>102</a:t>
+              <a:t>106</a:t>
             </a:r>
           </a:p>
         </p:txBody>
       </p:sp>
       <p:cxnSp>
         <p:nvCxnSpPr>
-          <p:cNvPr id="143" name=""/>
+          <p:cNvPr id="187" name=""/>
           <p:cNvCxnSpPr/>
           <p:nvPr/>
         </p:nvCxnSpPr>
@@ -3135,7 +5029,7 @@
                 <a:ea typeface="Helvetica Neue"/>
                 <a:cs typeface="Helvetica Neue"/>
               </a:rPr>
-              <a:t>PHP tests / 858 assertions</a:t>
+              <a:t>PHP tests / 1,940 assertions</a:t>
             </a:r>
           </a:p>
         </p:txBody>
@@ -3201,7 +5095,7 @@
       </p:sp>
       <p:cxnSp>
         <p:nvCxnSpPr>
-          <p:cNvPr id="146" name=""/>
+          <p:cNvPr id="190" name=""/>
           <p:cNvCxnSpPr/>
           <p:nvPr/>
         </p:nvCxnSpPr>
@@ -3334,14 +5228,14 @@
                 <a:ea typeface="Helvetica Neue"/>
                 <a:cs typeface="Helvetica Neue"/>
               </a:rPr>
-              <a:t>3</a:t>
+              <a:t>11/11</a:t>
             </a:r>
           </a:p>
         </p:txBody>
       </p:sp>
       <p:cxnSp>
         <p:nvCxnSpPr>
-          <p:cNvPr id="149" name=""/>
+          <p:cNvPr id="193" name=""/>
           <p:cNvCxnSpPr/>
           <p:nvPr/>
         </p:nvCxnSpPr>
@@ -3415,7 +5309,7 @@
                 <a:ea typeface="Helvetica Neue"/>
                 <a:cs typeface="Helvetica Neue"/>
               </a:rPr>
-              <a:t>Exact-ZIP WordPress / Woo environments</a:t>
+              <a:t>Native WebMCP smoke steps</a:t>
             </a:r>
           </a:p>
         </p:txBody>
@@ -3474,14 +5368,14 @@
                 <a:ea typeface="Helvetica Neue"/>
                 <a:cs typeface="Helvetica Neue"/>
               </a:rPr>
-              <a:t>0</a:t>
+              <a:t>3</a:t>
             </a:r>
           </a:p>
         </p:txBody>
       </p:sp>
       <p:cxnSp>
         <p:nvCxnSpPr>
-          <p:cNvPr id="152" name=""/>
+          <p:cNvPr id="196" name=""/>
           <p:cNvCxnSpPr/>
           <p:nvPr/>
         </p:nvCxnSpPr>
@@ -3555,7 +5449,7 @@
                 <a:ea typeface="Helvetica Neue"/>
                 <a:cs typeface="Helvetica Neue"/>
               </a:rPr>
-              <a:t>Plugin Check errors</a:t>
+              <a:t>Exact-ZIP WordPress / Woo environments</a:t>
             </a:r>
           </a:p>
         </p:txBody>
@@ -3614,14 +5508,14 @@
                 <a:ea typeface="Helvetica Neue"/>
                 <a:cs typeface="Helvetica Neue"/>
               </a:rPr>
-              <a:t>2×</a:t>
+              <a:t>0</a:t>
             </a:r>
           </a:p>
         </p:txBody>
       </p:sp>
       <p:cxnSp>
         <p:nvCxnSpPr>
-          <p:cNvPr id="155" name=""/>
+          <p:cNvPr id="199" name=""/>
           <p:cNvCxnSpPr/>
           <p:nvPr/>
         </p:nvCxnSpPr>
@@ -3695,7 +5589,7 @@
                 <a:ea typeface="Helvetica Neue"/>
                 <a:cs typeface="Helvetica Neue"/>
               </a:rPr>
-              <a:t>Clean builds, identical bytes</a:t>
+              <a:t>Plugin Check errors</a:t>
             </a:r>
           </a:p>
         </p:txBody>
@@ -3710,7 +5604,7 @@
 </p:sld>
 </file>
 
-<file path=ppt/slides/slide11.xml><?xml version="1.0" encoding="utf-8"?>
+<file path=ppt/slides/slide12.xml><?xml version="1.0" encoding="utf-8"?>
 <p:sld xmlns:p="http://schemas.openxmlformats.org/presentationml/2006/main">
   <p:cSld>
     <p:bg>
@@ -4078,7 +5972,7 @@
                 <a:ea typeface="Menlo"/>
                 <a:cs typeface="Menlo"/>
               </a:rPr>
-              <a:t>13 storefront + 9 Agent SNR tools</a:t>
+              <a:t>12 storefront + 8 Agent SNR tools</a:t>
             </a:r>
           </a:p>
         </p:txBody>
@@ -4568,7 +6462,7 @@
       </p:sp>
       <p:cxnSp>
         <p:nvCxnSpPr>
-          <p:cNvPr id="114" name=""/>
+          <p:cNvPr id="146" name=""/>
           <p:cNvCxnSpPr/>
           <p:nvPr/>
         </p:nvCxnSpPr>
@@ -4701,7 +6595,7 @@
                 <a:ea typeface="Menlo"/>
                 <a:cs typeface="Menlo"/>
               </a:rPr>
-              <a:t>11</a:t>
+              <a:t>12</a:t>
             </a:r>
           </a:p>
         </p:txBody>
@@ -4855,7 +6749,7 @@
       </p:sp>
       <p:cxnSp>
         <p:nvCxnSpPr>
-          <p:cNvPr id="57" name=""/>
+          <p:cNvPr id="69" name=""/>
           <p:cNvCxnSpPr/>
           <p:nvPr/>
         </p:nvCxnSpPr>
@@ -4995,7 +6889,7 @@
       </p:sp>
       <p:cxnSp>
         <p:nvCxnSpPr>
-          <p:cNvPr id="60" name=""/>
+          <p:cNvPr id="72" name=""/>
           <p:cNvCxnSpPr/>
           <p:nvPr/>
         </p:nvCxnSpPr>
@@ -6052,7 +7946,7 @@
       </p:sp>
       <p:cxnSp>
         <p:nvCxnSpPr>
-          <p:cNvPr id="109" name=""/>
+          <p:cNvPr id="143" name=""/>
           <p:cNvCxnSpPr/>
           <p:nvPr/>
         </p:nvCxnSpPr>
@@ -6369,7 +8263,7 @@
       </p:sp>
       <p:cxnSp>
         <p:nvCxnSpPr>
-          <p:cNvPr id="115" name=""/>
+          <p:cNvPr id="149" name=""/>
           <p:cNvCxnSpPr/>
           <p:nvPr/>
         </p:nvCxnSpPr>
@@ -6568,7 +8462,7 @@
       </p:sp>
       <p:cxnSp>
         <p:nvCxnSpPr>
-          <p:cNvPr id="119" name=""/>
+          <p:cNvPr id="153" name=""/>
           <p:cNvCxnSpPr/>
           <p:nvPr/>
         </p:nvCxnSpPr>
@@ -6767,7 +8661,7 @@
       </p:sp>
       <p:cxnSp>
         <p:nvCxnSpPr>
-          <p:cNvPr id="123" name=""/>
+          <p:cNvPr id="157" name=""/>
           <p:cNvCxnSpPr/>
           <p:nvPr/>
         </p:nvCxnSpPr>
@@ -7146,7 +9040,7 @@
       </p:sp>
       <p:cxnSp>
         <p:nvCxnSpPr>
-          <p:cNvPr id="113" name=""/>
+          <p:cNvPr id="139" name=""/>
           <p:cNvCxnSpPr/>
           <p:nvPr/>
         </p:nvCxnSpPr>
@@ -7595,7 +9489,7 @@
       </p:sp>
       <p:cxnSp>
         <p:nvCxnSpPr>
-          <p:cNvPr id="123" name=""/>
+          <p:cNvPr id="149" name=""/>
           <p:cNvCxnSpPr/>
           <p:nvPr/>
         </p:nvCxnSpPr>
@@ -8015,7 +9909,7 @@
                 <a:ea typeface="Menlo"/>
                 <a:cs typeface="Menlo"/>
               </a:rPr>
-              <a:t>13 storefront tools</a:t>
+              <a:t>12 storefront tools</a:t>
             </a:r>
           </a:p>
         </p:txBody>
@@ -8933,7 +10827,7 @@
                 <a:ea typeface="Menlo"/>
                 <a:cs typeface="Menlo"/>
               </a:rPr>
-              <a:t>9 MONITOR TOOLS · REPLAY · NET</a:t>
+              <a:t>8 MONITOR TOOLS · REPLAY · NET</a:t>
             </a:r>
           </a:p>
         </p:txBody>
@@ -9290,7 +11184,7 @@
                 <a:ea typeface="Menlo"/>
                 <a:cs typeface="Menlo"/>
               </a:rPr>
-              <a:t>TRUST BOUNDARY</a:t>
+              <a:t>TRUST BOUNDARY · 0 SENSITIVE TOOLS</a:t>
             </a:r>
           </a:p>
         </p:txBody>
@@ -9356,7 +11250,7 @@
       </p:sp>
       <p:cxnSp>
         <p:nvCxnSpPr>
-          <p:cNvPr id="34" name=""/>
+          <p:cNvPr id="40" name=""/>
           <p:cNvCxnSpPr/>
           <p:nvPr/>
         </p:nvCxnSpPr>
@@ -10458,7 +12352,7 @@
       </p:sp>
       <p:cxnSp>
         <p:nvCxnSpPr>
-          <p:cNvPr id="186" name=""/>
+          <p:cNvPr id="246" name=""/>
           <p:cNvCxnSpPr/>
           <p:nvPr/>
         </p:nvCxnSpPr>
@@ -10598,7 +12492,7 @@
       </p:sp>
       <p:cxnSp>
         <p:nvCxnSpPr>
-          <p:cNvPr id="189" name=""/>
+          <p:cNvPr id="249" name=""/>
           <p:cNvCxnSpPr/>
           <p:nvPr/>
         </p:nvCxnSpPr>
@@ -11823,7 +13717,7 @@
       </p:sp>
       <p:cxnSp>
         <p:nvCxnSpPr>
-          <p:cNvPr id="213" name=""/>
+          <p:cNvPr id="273" name=""/>
           <p:cNvCxnSpPr/>
           <p:nvPr/>
         </p:nvCxnSpPr>
@@ -12241,7 +14135,7 @@
       </p:sp>
       <p:cxnSp>
         <p:nvCxnSpPr>
-          <p:cNvPr id="47" name=""/>
+          <p:cNvPr id="55" name=""/>
           <p:cNvCxnSpPr/>
           <p:nvPr/>
         </p:nvCxnSpPr>
@@ -12381,14 +14275,14 @@
       </p:sp>
       <p:pic>
         <p:nvPicPr>
-          <p:cNvPr id="50" name=""/>
+          <p:cNvPr id="58" name=""/>
           <p:cNvPicPr>
             <a:picLocks xmlns:a="http://schemas.openxmlformats.org/drawingml/2006/main" noChangeAspect="1"/>
           </p:cNvPicPr>
           <p:nvPr/>
         </p:nvPicPr>
         <p:blipFill>
-          <a:blip xmlns:r="http://schemas.openxmlformats.org/officeDocument/2006/relationships" xmlns:a="http://schemas.openxmlformats.org/drawingml/2006/main" r:embed="R8898b70b423a43a8"/>
+          <a:blip xmlns:r="http://schemas.openxmlformats.org/officeDocument/2006/relationships" xmlns:a="http://schemas.openxmlformats.org/drawingml/2006/main" r:embed="Rd9d55a8be2bf4e87"/>
           <a:srcRect xmlns:a="http://schemas.openxmlformats.org/drawingml/2006/main" l="11607" t="0" r="11607" b="0"/>
           <a:stretch xmlns:a="http://schemas.openxmlformats.org/drawingml/2006/main">
             <a:fillRect l="0" t="0" r="0" b="0"/>
@@ -13454,7 +15348,7 @@
         </p:spPr>
         <p:txBody>
           <a:bodyPr xmlns:a="http://schemas.openxmlformats.org/drawingml/2006/main" lIns="0" tIns="0" rIns="0" bIns="0" anchor="t">
-            <a:normAutofit fontScale="89286"/>
+            <a:normAutofit fontScale="97677"/>
           </a:bodyPr>
           <a:lstStyle xmlns:a="http://schemas.openxmlformats.org/drawingml/2006/main"/>
           <a:p xmlns:a="http://schemas.openxmlformats.org/drawingml/2006/main">
@@ -13478,14 +15372,14 @@
                 <a:ea typeface="Helvetica Neue"/>
                 <a:cs typeface="Helvetica Neue"/>
               </a:rPr>
-              <a:t>The guide, missed demand, and feedback remain visible to the shopper.</a:t>
+              <a:t>The guide makes co-browsing and human authority explicit.</a:t>
             </a:r>
           </a:p>
         </p:txBody>
       </p:sp>
       <p:cxnSp>
         <p:nvCxnSpPr>
-          <p:cNvPr id="64" name=""/>
+          <p:cNvPr id="84" name=""/>
           <p:cNvCxnSpPr/>
           <p:nvPr/>
         </p:nvCxnSpPr>
@@ -13747,7 +15641,7 @@
         </p:spPr>
         <p:txBody>
           <a:bodyPr xmlns:a="http://schemas.openxmlformats.org/drawingml/2006/main" lIns="0" tIns="0" rIns="0" bIns="0" anchor="t">
-            <a:normAutofit fontScale="89861"/>
+            <a:normAutofit fontScale="92313"/>
           </a:bodyPr>
           <a:lstStyle xmlns:a="http://schemas.openxmlformats.org/drawingml/2006/main"/>
           <a:p xmlns:a="http://schemas.openxmlformats.org/drawingml/2006/main">
@@ -13771,7 +15665,7 @@
                 <a:ea typeface="Helvetica Neue"/>
                 <a:cs typeface="Helvetica Neue"/>
               </a:rPr>
-              <a:t>Read Agent Guide</a:t>
+              <a:t>Guide 1.1</a:t>
             </a:r>
           </a:p>
           <a:p xmlns:a="http://schemas.openxmlformats.org/drawingml/2006/main">
@@ -13795,6 +15689,54 @@
                 <a:ea typeface="Helvetica Neue"/>
                 <a:cs typeface="Helvetica Neue"/>
               </a:rPr>
+              <a:t>Co-browsing only</a:t>
+            </a:r>
+          </a:p>
+          <a:p xmlns:a="http://schemas.openxmlformats.org/drawingml/2006/main">
+            <a:pPr algn="l">
+              <a:buNone/>
+              <a:defRPr sz="2025" b="1" i="0">
+                <a:solidFill>
+                  <a:srgbClr val="FFFFFF"/>
+                </a:solidFill>
+                <a:latin typeface="Helvetica Neue"/>
+                <a:ea typeface="Helvetica Neue"/>
+                <a:cs typeface="Helvetica Neue"/>
+              </a:defRPr>
+            </a:pPr>
+            <a:r>
+              <a:rPr sz="2025" b="1" i="0">
+                <a:solidFill>
+                  <a:srgbClr val="FFFFFF"/>
+                </a:solidFill>
+                <a:latin typeface="Helvetica Neue"/>
+                <a:ea typeface="Helvetica Neue"/>
+                <a:cs typeface="Helvetica Neue"/>
+              </a:rPr>
+              <a:t>0 sensitive tools</a:t>
+            </a:r>
+          </a:p>
+          <a:p xmlns:a="http://schemas.openxmlformats.org/drawingml/2006/main">
+            <a:pPr algn="l">
+              <a:buNone/>
+              <a:defRPr sz="2025" b="1" i="0">
+                <a:solidFill>
+                  <a:srgbClr val="FFFFFF"/>
+                </a:solidFill>
+                <a:latin typeface="Helvetica Neue"/>
+                <a:ea typeface="Helvetica Neue"/>
+                <a:cs typeface="Helvetica Neue"/>
+              </a:defRPr>
+            </a:pPr>
+            <a:r>
+              <a:rPr sz="2025" b="1" i="0">
+                <a:solidFill>
+                  <a:srgbClr val="FFFFFF"/>
+                </a:solidFill>
+                <a:latin typeface="Helvetica Neue"/>
+                <a:ea typeface="Helvetica Neue"/>
+                <a:cs typeface="Helvetica Neue"/>
+              </a:rPr>
               <a:t>Zero-result signal</a:t>
             </a:r>
           </a:p>
@@ -13819,7 +15761,7 @@
                 <a:ea typeface="Helvetica Neue"/>
                 <a:cs typeface="Helvetica Neue"/>
               </a:rPr>
-              <a:t>Compare two IPX4 options</a:t>
+              <a:t>Linked feedback</a:t>
             </a:r>
           </a:p>
           <a:p xmlns:a="http://schemas.openxmlformats.org/drawingml/2006/main">
@@ -13843,38 +15785,14 @@
                 <a:ea typeface="Helvetica Neue"/>
                 <a:cs typeface="Helvetica Neue"/>
               </a:rPr>
-              <a:t>Linked feedback receipt</a:t>
-            </a:r>
-          </a:p>
-          <a:p xmlns:a="http://schemas.openxmlformats.org/drawingml/2006/main">
-            <a:pPr algn="l">
-              <a:buNone/>
-              <a:defRPr sz="2025" b="1" i="0">
-                <a:solidFill>
-                  <a:srgbClr val="FFFFFF"/>
-                </a:solidFill>
-                <a:latin typeface="Helvetica Neue"/>
-                <a:ea typeface="Helvetica Neue"/>
-                <a:cs typeface="Helvetica Neue"/>
-              </a:defRPr>
-            </a:pPr>
-            <a:r>
-              <a:rPr sz="2025" b="1" i="0">
-                <a:solidFill>
-                  <a:srgbClr val="FFFFFF"/>
-                </a:solidFill>
-                <a:latin typeface="Helvetica Neue"/>
-                <a:ea typeface="Helvetica Neue"/>
-                <a:cs typeface="Helvetica Neue"/>
-              </a:rPr>
-              <a:t>Checkout handoff</a:t>
+              <a:t>Human checkout</a:t>
             </a:r>
           </a:p>
         </p:txBody>
       </p:sp>
       <p:cxnSp>
         <p:nvCxnSpPr>
-          <p:cNvPr id="70" name=""/>
+          <p:cNvPr id="90" name=""/>
           <p:cNvCxnSpPr/>
           <p:nvPr/>
         </p:nvCxnSpPr>
@@ -13955,14 +15873,14 @@
       </p:sp>
       <p:pic>
         <p:nvPicPr>
-          <p:cNvPr id="72" name=""/>
+          <p:cNvPr id="92" name=""/>
           <p:cNvPicPr>
             <a:picLocks xmlns:a="http://schemas.openxmlformats.org/drawingml/2006/main" noChangeAspect="1"/>
           </p:cNvPicPr>
           <p:nvPr/>
         </p:nvPicPr>
         <p:blipFill>
-          <a:blip xmlns:r="http://schemas.openxmlformats.org/officeDocument/2006/relationships" xmlns:a="http://schemas.openxmlformats.org/drawingml/2006/main" r:embed="R3991df8d44434100"/>
+          <a:blip xmlns:r="http://schemas.openxmlformats.org/officeDocument/2006/relationships" xmlns:a="http://schemas.openxmlformats.org/drawingml/2006/main" r:embed="Rf298b7916d234b76"/>
           <a:srcRect xmlns:a="http://schemas.openxmlformats.org/drawingml/2006/main" l="0" t="9356" r="0" b="9356"/>
           <a:stretch xmlns:a="http://schemas.openxmlformats.org/drawingml/2006/main">
             <a:fillRect l="0" t="0" r="0" b="0"/>
@@ -14127,7 +16045,7 @@
       </p:sp>
       <p:cxnSp>
         <p:nvCxnSpPr>
-          <p:cNvPr id="45" name=""/>
+          <p:cNvPr id="55" name=""/>
           <p:cNvCxnSpPr/>
           <p:nvPr/>
         </p:nvCxnSpPr>
@@ -14267,14 +16185,14 @@
       </p:sp>
       <p:pic>
         <p:nvPicPr>
-          <p:cNvPr id="48" name=""/>
+          <p:cNvPr id="58" name=""/>
           <p:cNvPicPr>
             <a:picLocks xmlns:a="http://schemas.openxmlformats.org/drawingml/2006/main" noChangeAspect="1"/>
           </p:cNvPicPr>
           <p:nvPr/>
         </p:nvPicPr>
         <p:blipFill>
-          <a:blip xmlns:r="http://schemas.openxmlformats.org/officeDocument/2006/relationships" xmlns:a="http://schemas.openxmlformats.org/drawingml/2006/main" r:embed="Rfda67edf09794ebe"/>
+          <a:blip xmlns:r="http://schemas.openxmlformats.org/officeDocument/2006/relationships" xmlns:a="http://schemas.openxmlformats.org/drawingml/2006/main" r:embed="Rc640bc0a34fc4a66"/>
           <a:srcRect xmlns:a="http://schemas.openxmlformats.org/drawingml/2006/main" l="316" t="0" r="316" b="0"/>
           <a:stretch xmlns:a="http://schemas.openxmlformats.org/drawingml/2006/main">
             <a:fillRect l="0" t="0" r="0" b="0"/>
@@ -14292,14 +16210,14 @@
       </p:pic>
       <p:pic>
         <p:nvPicPr>
-          <p:cNvPr id="49" name=""/>
+          <p:cNvPr id="59" name=""/>
           <p:cNvPicPr>
             <a:picLocks xmlns:a="http://schemas.openxmlformats.org/drawingml/2006/main" noChangeAspect="1"/>
           </p:cNvPicPr>
           <p:nvPr/>
         </p:nvPicPr>
         <p:blipFill>
-          <a:blip xmlns:r="http://schemas.openxmlformats.org/officeDocument/2006/relationships" xmlns:a="http://schemas.openxmlformats.org/drawingml/2006/main" r:embed="R4d472687e4994c02"/>
+          <a:blip xmlns:r="http://schemas.openxmlformats.org/officeDocument/2006/relationships" xmlns:a="http://schemas.openxmlformats.org/drawingml/2006/main" r:embed="R13c5b2ac75fd48ce"/>
           <a:srcRect xmlns:a="http://schemas.openxmlformats.org/drawingml/2006/main" l="0" t="383" r="0" b="383"/>
           <a:stretch xmlns:a="http://schemas.openxmlformats.org/drawingml/2006/main">
             <a:fillRect l="0" t="0" r="0" b="0"/>

</xml_diff>

<commit_message>
docs(submission): finalize Devpost compliance package
</commit_message>
<xml_diff>
--- a/submission/agent-snr-hackathon-demo.pptx
+++ b/submission/agent-snr-hackathon-demo.pptx
@@ -2,24 +2,24 @@
 <file path=ppt/presentation.xml><?xml version="1.0" encoding="utf-8"?>
 <p:presentation xmlns:p="http://schemas.openxmlformats.org/presentationml/2006/main">
   <p:sldMasterIdLst>
-    <p:sldMasterId xmlns:r="http://schemas.openxmlformats.org/officeDocument/2006/relationships" id="2147483648" r:id="R7b1f538e05f64dba"/>
+    <p:sldMasterId xmlns:r="http://schemas.openxmlformats.org/officeDocument/2006/relationships" id="2147483648" r:id="R9859e258e05c4b1d"/>
   </p:sldMasterIdLst>
   <p:notesMasterIdLst>
-    <p:notesMasterId xmlns:r="http://schemas.openxmlformats.org/officeDocument/2006/relationships" r:id="R408a100d73d5422a"/>
+    <p:notesMasterId xmlns:r="http://schemas.openxmlformats.org/officeDocument/2006/relationships" r:id="Rdb2c070390b7439c"/>
   </p:notesMasterIdLst>
   <p:sldIdLst>
-    <p:sldId xmlns:r="http://schemas.openxmlformats.org/officeDocument/2006/relationships" id="256" r:id="R01823746f837464c"/>
-    <p:sldId xmlns:r="http://schemas.openxmlformats.org/officeDocument/2006/relationships" id="257" r:id="R1d3b1b4311614e69"/>
-    <p:sldId xmlns:r="http://schemas.openxmlformats.org/officeDocument/2006/relationships" id="258" r:id="R7de896ce7b9a4d77"/>
-    <p:sldId xmlns:r="http://schemas.openxmlformats.org/officeDocument/2006/relationships" id="259" r:id="R991816a3d4034549"/>
-    <p:sldId xmlns:r="http://schemas.openxmlformats.org/officeDocument/2006/relationships" id="260" r:id="R6fea63dd63f344d1"/>
-    <p:sldId xmlns:r="http://schemas.openxmlformats.org/officeDocument/2006/relationships" id="261" r:id="Rc28c7e3665664b97"/>
-    <p:sldId xmlns:r="http://schemas.openxmlformats.org/officeDocument/2006/relationships" id="262" r:id="Rc3bc69174763480a"/>
-    <p:sldId xmlns:r="http://schemas.openxmlformats.org/officeDocument/2006/relationships" id="263" r:id="R2b84c46b89fc4636"/>
-    <p:sldId xmlns:r="http://schemas.openxmlformats.org/officeDocument/2006/relationships" id="264" r:id="R35f9148df5b04a98"/>
-    <p:sldId xmlns:r="http://schemas.openxmlformats.org/officeDocument/2006/relationships" id="265" r:id="Rb1d47839f4d3438a"/>
-    <p:sldId xmlns:r="http://schemas.openxmlformats.org/officeDocument/2006/relationships" id="266" r:id="R7d5732a4756e46b8"/>
-    <p:sldId xmlns:r="http://schemas.openxmlformats.org/officeDocument/2006/relationships" id="267" r:id="R760added1df94896"/>
+    <p:sldId xmlns:r="http://schemas.openxmlformats.org/officeDocument/2006/relationships" id="256" r:id="R396f8a37443f4361"/>
+    <p:sldId xmlns:r="http://schemas.openxmlformats.org/officeDocument/2006/relationships" id="257" r:id="R408c9a90bb1448fe"/>
+    <p:sldId xmlns:r="http://schemas.openxmlformats.org/officeDocument/2006/relationships" id="258" r:id="R20645dbc89704485"/>
+    <p:sldId xmlns:r="http://schemas.openxmlformats.org/officeDocument/2006/relationships" id="259" r:id="Rff9d24dbdda547ba"/>
+    <p:sldId xmlns:r="http://schemas.openxmlformats.org/officeDocument/2006/relationships" id="260" r:id="Rae1403b324c54c75"/>
+    <p:sldId xmlns:r="http://schemas.openxmlformats.org/officeDocument/2006/relationships" id="261" r:id="R0b1e33ba93874e81"/>
+    <p:sldId xmlns:r="http://schemas.openxmlformats.org/officeDocument/2006/relationships" id="262" r:id="R7a19e0d970a94ed4"/>
+    <p:sldId xmlns:r="http://schemas.openxmlformats.org/officeDocument/2006/relationships" id="263" r:id="Ra942c15e8c50441a"/>
+    <p:sldId xmlns:r="http://schemas.openxmlformats.org/officeDocument/2006/relationships" id="264" r:id="Rb84c2a936b064036"/>
+    <p:sldId xmlns:r="http://schemas.openxmlformats.org/officeDocument/2006/relationships" id="265" r:id="Ra58e542732f24158"/>
+    <p:sldId xmlns:r="http://schemas.openxmlformats.org/officeDocument/2006/relationships" id="266" r:id="R2ae511c479f04cfd"/>
+    <p:sldId xmlns:r="http://schemas.openxmlformats.org/officeDocument/2006/relationships" id="267" r:id="R4466aa3962e34013"/>
   </p:sldIdLst>
   <p:sldSz cx="12192000" cy="6858000"/>
   <p:notesSz cx="6858000" cy="9144000"/>
@@ -573,12 +573,22 @@
           </a:p>
           <a:p xmlns:a="http://schemas.openxmlformats.org/drawingml/2006/main">
             <a:r>
+              <a:t>- submission/webmcp-eval-report-2026-09-01.md</a:t>
+            </a:r>
+          </a:p>
+          <a:p xmlns:a="http://schemas.openxmlformats.org/drawingml/2006/main">
+            <a:r>
+              <a:t>- submission/verification-report.md</a:t>
+            </a:r>
+          </a:p>
+          <a:p xmlns:a="http://schemas.openxmlformats.org/drawingml/2006/main">
+            <a:r>
               <a:t>[/Sources]</a:t>
             </a:r>
           </a:p>
           <a:p xmlns:a="http://schemas.openxmlformats.org/drawingml/2006/main">
             <a:r>
-              <a:t>The first two gates are reproducible repository evidence. Model-backed, Workbench, scanner, and directory evidence are owner gates against the frozen release.</a:t>
+              <a:t>Contract parity, native smoke, and protected model-backed evaluation are verified repository evidence. Real-client validation is required before submission. Workbench, hosted scanner, and directory listing are optional additional checks against the frozen public release.</a:t>
             </a:r>
           </a:p>
         </p:txBody>
@@ -1023,7 +1033,7 @@
           <a:lstStyle xmlns:a="http://schemas.openxmlformats.org/drawingml/2006/main"/>
           <a:p xmlns:a="http://schemas.openxmlformats.org/drawingml/2006/main">
             <a:r>
-              <a:t>Two independent top-level WebMCP surfaces expose 12 storefront tools and 8 Agent SNR tools from one first-party catalog. Two older gap abilities remain registered only for compatibility and are absent from public discovery. Guide 1.1 is shared by people and agents. WordPress keeps opportunity evidence, agent testimony, catalog facts, and WooCommerce outcomes separate.</a:t>
+              <a:t>Two independent top-level WebMCP surfaces expose 12 storefront tools and 8 Agent SNR tools from one first-party catalog. Two older gap abilities remain registered only for compatibility and are absent from public discovery. Guide 1.1 is shared by people and agents. WordPress keeps opportunity evidence, agent testimony, catalog facts, and WooCommerce outcomes separate. The black scope bar describes only Agent SNR's monitoring ledger; ordinary WooCommerce order and billing data remains in WooCommerce.</a:t>
             </a:r>
           </a:p>
           <a:p xmlns:a="http://schemas.openxmlformats.org/drawingml/2006/main">
@@ -1133,7 +1143,7 @@
           <a:lstStyle xmlns:a="http://schemas.openxmlformats.org/drawingml/2006/main"/>
           <a:p xmlns:a="http://schemas.openxmlformats.org/drawingml/2006/main">
             <a:r>
-              <a:t>The agent can reduce work and report friction without crossing the consequential boundary. It never places an order, accepts terms, submits customer details, charges, cancels, or refunds. Feedback is bounded testimony; the human decision and WooCommerce outcome remain separate facts.</a:t>
+              <a:t>The agent can reduce work and report friction without crossing the consequential boundary. It never places an order, accepts terms, submits customer details, charges, cancels, or refunds. Feedback is bounded testimony; the human decision and WooCommerce outcome remain separate facts. The privacy line applies only to Agent SNR's monitoring ledger: ordinary WooCommerce order and billing data remains in WooCommerce and is not copied into that ledger.</a:t>
             </a:r>
           </a:p>
           <a:p xmlns:a="http://schemas.openxmlformats.org/drawingml/2006/main">
@@ -1164,6 +1174,11 @@
           <a:p xmlns:a="http://schemas.openxmlformats.org/drawingml/2006/main">
             <a:r>
               <a:t>- submission/devpost-description.md</a:t>
+            </a:r>
+          </a:p>
+          <a:p xmlns:a="http://schemas.openxmlformats.org/drawingml/2006/main">
+            <a:r>
+              <a:t>[/Sources]</a:t>
             </a:r>
           </a:p>
         </p:txBody>
@@ -1626,7 +1641,7 @@
   </p:cSld>
   <p:clrMap bg1="lt1" tx1="dk1" bg2="lt2" tx2="dk2" accent1="accent1" accent2="accent2" accent3="accent3" accent4="accent4" accent5="accent5" accent6="accent6" hlink="hlink" folHlink="folHlink"/>
   <p:sldLayoutIdLst>
-    <p:sldLayoutId xmlns:r="http://schemas.openxmlformats.org/officeDocument/2006/relationships" id="2147483649" r:id="R357c7a790e8049d6"/>
+    <p:sldLayoutId xmlns:r="http://schemas.openxmlformats.org/officeDocument/2006/relationships" id="2147483649" r:id="R61fec53a798a4c7d"/>
   </p:sldLayoutIdLst>
   <p:txStyles>
     <p:titleStyle>
@@ -2546,7 +2561,7 @@
       </p:sp>
       <p:cxnSp>
         <p:nvCxnSpPr>
-          <p:cNvPr id="65" name=""/>
+          <p:cNvPr id="79" name=""/>
           <p:cNvCxnSpPr/>
           <p:nvPr/>
         </p:nvCxnSpPr>
@@ -2833,7 +2848,7 @@
       </p:sp>
       <p:cxnSp>
         <p:nvCxnSpPr>
-          <p:cNvPr id="246" name=""/>
+          <p:cNvPr id="306" name=""/>
           <p:cNvCxnSpPr/>
           <p:nvPr/>
         </p:nvCxnSpPr>
@@ -2973,7 +2988,7 @@
       </p:sp>
       <p:cxnSp>
         <p:nvCxnSpPr>
-          <p:cNvPr id="249" name=""/>
+          <p:cNvPr id="309" name=""/>
           <p:cNvCxnSpPr/>
           <p:nvPr/>
         </p:nvCxnSpPr>
@@ -4191,14 +4206,14 @@
                 <a:ea typeface="Helvetica Neue"/>
                 <a:cs typeface="Helvetica Neue"/>
               </a:rPr>
-              <a:t>Native + deterministic</a:t>
+              <a:t>Native + model evals</a:t>
             </a:r>
           </a:p>
         </p:txBody>
       </p:sp>
       <p:cxnSp>
         <p:nvCxnSpPr>
-          <p:cNvPr id="273" name=""/>
+          <p:cNvPr id="333" name=""/>
           <p:cNvCxnSpPr/>
           <p:nvPr/>
         </p:nvCxnSpPr>
@@ -4272,7 +4287,7 @@
                 <a:ea typeface="Menlo"/>
                 <a:cs typeface="Menlo"/>
               </a:rPr>
-              <a:t>RELEASE OWNER GATES</a:t>
+              <a:t>RELEASE OWNER CHECKS</a:t>
             </a:r>
           </a:p>
         </p:txBody>
@@ -4331,7 +4346,7 @@
                 <a:ea typeface="Helvetica Neue"/>
                 <a:cs typeface="Helvetica Neue"/>
               </a:rPr>
-              <a:t>Model evals</a:t>
+              <a:t>Required · real client</a:t>
             </a:r>
           </a:p>
           <a:p xmlns:a="http://schemas.openxmlformats.org/drawingml/2006/main">
@@ -4355,7 +4370,7 @@
                 <a:ea typeface="Helvetica Neue"/>
                 <a:cs typeface="Helvetica Neue"/>
               </a:rPr>
-              <a:t>Workbench</a:t>
+              <a:t>Optional · Workbench</a:t>
             </a:r>
           </a:p>
           <a:p xmlns:a="http://schemas.openxmlformats.org/drawingml/2006/main">
@@ -4379,7 +4394,7 @@
                 <a:ea typeface="Helvetica Neue"/>
                 <a:cs typeface="Helvetica Neue"/>
               </a:rPr>
-              <a:t>Hosted scanner</a:t>
+              <a:t>Optional · scanner</a:t>
             </a:r>
           </a:p>
           <a:p xmlns:a="http://schemas.openxmlformats.org/drawingml/2006/main">
@@ -4403,7 +4418,7 @@
                 <a:ea typeface="Helvetica Neue"/>
                 <a:cs typeface="Helvetica Neue"/>
               </a:rPr>
-              <a:t>Directory listing</a:t>
+              <a:t>Optional · directory</a:t>
             </a:r>
           </a:p>
         </p:txBody>
@@ -4616,7 +4631,7 @@
       </p:sp>
       <p:cxnSp>
         <p:nvCxnSpPr>
-          <p:cNvPr id="180" name=""/>
+          <p:cNvPr id="224" name=""/>
           <p:cNvCxnSpPr/>
           <p:nvPr/>
         </p:nvCxnSpPr>
@@ -4808,14 +4823,14 @@
                 <a:ea typeface="Helvetica Neue"/>
                 <a:cs typeface="Helvetica Neue"/>
               </a:rPr>
-              <a:t>108</a:t>
+              <a:t>112</a:t>
             </a:r>
           </a:p>
         </p:txBody>
       </p:sp>
       <p:cxnSp>
         <p:nvCxnSpPr>
-          <p:cNvPr id="184" name=""/>
+          <p:cNvPr id="228" name=""/>
           <p:cNvCxnSpPr/>
           <p:nvPr/>
         </p:nvCxnSpPr>
@@ -4948,14 +4963,14 @@
                 <a:ea typeface="Helvetica Neue"/>
                 <a:cs typeface="Helvetica Neue"/>
               </a:rPr>
-              <a:t>106</a:t>
+              <a:t>111</a:t>
             </a:r>
           </a:p>
         </p:txBody>
       </p:sp>
       <p:cxnSp>
         <p:nvCxnSpPr>
-          <p:cNvPr id="187" name=""/>
+          <p:cNvPr id="231" name=""/>
           <p:cNvCxnSpPr/>
           <p:nvPr/>
         </p:nvCxnSpPr>
@@ -5029,7 +5044,7 @@
                 <a:ea typeface="Helvetica Neue"/>
                 <a:cs typeface="Helvetica Neue"/>
               </a:rPr>
-              <a:t>PHP tests / 1,940 assertions</a:t>
+              <a:t>PHP tests / 1,964 assertions</a:t>
             </a:r>
           </a:p>
         </p:txBody>
@@ -5088,14 +5103,14 @@
                 <a:ea typeface="Helvetica Neue"/>
                 <a:cs typeface="Helvetica Neue"/>
               </a:rPr>
-              <a:t>15/15</a:t>
+              <a:t>16/16</a:t>
             </a:r>
           </a:p>
         </p:txBody>
       </p:sp>
       <p:cxnSp>
         <p:nvCxnSpPr>
-          <p:cNvPr id="190" name=""/>
+          <p:cNvPr id="234" name=""/>
           <p:cNvCxnSpPr/>
           <p:nvPr/>
         </p:nvCxnSpPr>
@@ -5235,7 +5250,7 @@
       </p:sp>
       <p:cxnSp>
         <p:nvCxnSpPr>
-          <p:cNvPr id="193" name=""/>
+          <p:cNvPr id="237" name=""/>
           <p:cNvCxnSpPr/>
           <p:nvPr/>
         </p:nvCxnSpPr>
@@ -5375,7 +5390,7 @@
       </p:sp>
       <p:cxnSp>
         <p:nvCxnSpPr>
-          <p:cNvPr id="196" name=""/>
+          <p:cNvPr id="240" name=""/>
           <p:cNvCxnSpPr/>
           <p:nvPr/>
         </p:nvCxnSpPr>
@@ -5515,7 +5530,7 @@
       </p:sp>
       <p:cxnSp>
         <p:nvCxnSpPr>
-          <p:cNvPr id="199" name=""/>
+          <p:cNvPr id="243" name=""/>
           <p:cNvCxnSpPr/>
           <p:nvPr/>
         </p:nvCxnSpPr>
@@ -6462,7 +6477,7 @@
       </p:sp>
       <p:cxnSp>
         <p:nvCxnSpPr>
-          <p:cNvPr id="146" name=""/>
+          <p:cNvPr id="178" name=""/>
           <p:cNvCxnSpPr/>
           <p:nvPr/>
         </p:nvCxnSpPr>
@@ -6749,7 +6764,7 @@
       </p:sp>
       <p:cxnSp>
         <p:nvCxnSpPr>
-          <p:cNvPr id="69" name=""/>
+          <p:cNvPr id="81" name=""/>
           <p:cNvCxnSpPr/>
           <p:nvPr/>
         </p:nvCxnSpPr>
@@ -6889,7 +6904,7 @@
       </p:sp>
       <p:cxnSp>
         <p:nvCxnSpPr>
-          <p:cNvPr id="72" name=""/>
+          <p:cNvPr id="84" name=""/>
           <p:cNvCxnSpPr/>
           <p:nvPr/>
         </p:nvCxnSpPr>
@@ -7946,7 +7961,7 @@
       </p:sp>
       <p:cxnSp>
         <p:nvCxnSpPr>
-          <p:cNvPr id="143" name=""/>
+          <p:cNvPr id="177" name=""/>
           <p:cNvCxnSpPr/>
           <p:nvPr/>
         </p:nvCxnSpPr>
@@ -8197,7 +8212,7 @@
                 <a:ea typeface="Helvetica Neue"/>
                 <a:cs typeface="Helvetica Neue"/>
               </a:rPr>
-              <a:t>Fullstory / LogRocket</a:t>
+              <a:t>Journey replay</a:t>
             </a:r>
           </a:p>
         </p:txBody>
@@ -8263,7 +8278,7 @@
       </p:sp>
       <p:cxnSp>
         <p:nvCxnSpPr>
-          <p:cNvPr id="149" name=""/>
+          <p:cNvPr id="183" name=""/>
           <p:cNvCxnSpPr/>
           <p:nvPr/>
         </p:nvCxnSpPr>
@@ -8396,7 +8411,7 @@
                 <a:ea typeface="Helvetica Neue"/>
                 <a:cs typeface="Helvetica Neue"/>
               </a:rPr>
-              <a:t>Datadog / Sentry</a:t>
+              <a:t>Tool observability</a:t>
             </a:r>
           </a:p>
         </p:txBody>
@@ -8462,7 +8477,7 @@
       </p:sp>
       <p:cxnSp>
         <p:nvCxnSpPr>
-          <p:cNvPr id="153" name=""/>
+          <p:cNvPr id="187" name=""/>
           <p:cNvCxnSpPr/>
           <p:nvPr/>
         </p:nvCxnSpPr>
@@ -8595,7 +8610,7 @@
                 <a:ea typeface="Helvetica Neue"/>
                 <a:cs typeface="Helvetica Neue"/>
               </a:rPr>
-              <a:t>Amplitude</a:t>
+              <a:t>Product analytics</a:t>
             </a:r>
           </a:p>
         </p:txBody>
@@ -8661,7 +8676,7 @@
       </p:sp>
       <p:cxnSp>
         <p:nvCxnSpPr>
-          <p:cNvPr id="157" name=""/>
+          <p:cNvPr id="191" name=""/>
           <p:cNvCxnSpPr/>
           <p:nvPr/>
         </p:nvCxnSpPr>
@@ -9040,7 +9055,7 @@
       </p:sp>
       <p:cxnSp>
         <p:nvCxnSpPr>
-          <p:cNvPr id="139" name=""/>
+          <p:cNvPr id="165" name=""/>
           <p:cNvCxnSpPr/>
           <p:nvPr/>
         </p:nvCxnSpPr>
@@ -9489,7 +9504,7 @@
       </p:sp>
       <p:cxnSp>
         <p:nvCxnSpPr>
-          <p:cNvPr id="149" name=""/>
+          <p:cNvPr id="175" name=""/>
           <p:cNvCxnSpPr/>
           <p:nvPr/>
         </p:nvCxnSpPr>
@@ -10919,7 +10934,7 @@
                 <a:ea typeface="Menlo"/>
                 <a:cs typeface="Menlo"/>
               </a:rPr>
-              <a:t>STORED</a:t>
+              <a:t>SNR STORES</a:t>
             </a:r>
           </a:p>
         </p:txBody>
@@ -11037,7 +11052,7 @@
                 <a:ea typeface="Menlo"/>
                 <a:cs typeface="Menlo"/>
               </a:rPr>
-              <a:t>EXCLUDED</a:t>
+              <a:t>SNR EXCLUDES</a:t>
             </a:r>
           </a:p>
         </p:txBody>
@@ -11250,7 +11265,7 @@
       </p:sp>
       <p:cxnSp>
         <p:nvCxnSpPr>
-          <p:cNvPr id="40" name=""/>
+          <p:cNvPr id="46" name=""/>
           <p:cNvCxnSpPr/>
           <p:nvPr/>
         </p:nvCxnSpPr>
@@ -12198,7 +12213,7 @@
                 <a:ea typeface="Menlo"/>
                 <a:cs typeface="Menlo"/>
               </a:rPr>
-              <a:t>NEVER STORED: RAW SEARCH OR PROMPTS · FREE-TEXT FEEDBACK · IDENTITY · ADDRESS · PAYMENT</a:t>
+              <a:t>AGENT SNR LEDGER EXCLUDES: RAW PROMPTS · FREE-TEXT FEEDBACK · IDENTITY · ADDRESS · PAYMENT</a:t>
             </a:r>
           </a:p>
         </p:txBody>
@@ -12352,7 +12367,7 @@
       </p:sp>
       <p:cxnSp>
         <p:nvCxnSpPr>
-          <p:cNvPr id="246" name=""/>
+          <p:cNvPr id="306" name=""/>
           <p:cNvCxnSpPr/>
           <p:nvPr/>
         </p:nvCxnSpPr>
@@ -12492,7 +12507,7 @@
       </p:sp>
       <p:cxnSp>
         <p:nvCxnSpPr>
-          <p:cNvPr id="249" name=""/>
+          <p:cNvPr id="309" name=""/>
           <p:cNvCxnSpPr/>
           <p:nvPr/>
         </p:nvCxnSpPr>
@@ -13717,7 +13732,7 @@
       </p:sp>
       <p:cxnSp>
         <p:nvCxnSpPr>
-          <p:cNvPr id="273" name=""/>
+          <p:cNvPr id="333" name=""/>
           <p:cNvCxnSpPr/>
           <p:nvPr/>
         </p:nvCxnSpPr>
@@ -14135,7 +14150,7 @@
       </p:sp>
       <p:cxnSp>
         <p:nvCxnSpPr>
-          <p:cNvPr id="55" name=""/>
+          <p:cNvPr id="63" name=""/>
           <p:cNvCxnSpPr/>
           <p:nvPr/>
         </p:nvCxnSpPr>
@@ -14275,14 +14290,14 @@
       </p:sp>
       <p:pic>
         <p:nvPicPr>
-          <p:cNvPr id="58" name=""/>
+          <p:cNvPr id="66" name=""/>
           <p:cNvPicPr>
             <a:picLocks xmlns:a="http://schemas.openxmlformats.org/drawingml/2006/main" noChangeAspect="1"/>
           </p:cNvPicPr>
           <p:nvPr/>
         </p:nvPicPr>
         <p:blipFill>
-          <a:blip xmlns:r="http://schemas.openxmlformats.org/officeDocument/2006/relationships" xmlns:a="http://schemas.openxmlformats.org/drawingml/2006/main" r:embed="Rd9d55a8be2bf4e87"/>
+          <a:blip xmlns:r="http://schemas.openxmlformats.org/officeDocument/2006/relationships" xmlns:a="http://schemas.openxmlformats.org/drawingml/2006/main" r:embed="Rcb52b0a863d34133"/>
           <a:srcRect xmlns:a="http://schemas.openxmlformats.org/drawingml/2006/main" l="11607" t="0" r="11607" b="0"/>
           <a:stretch xmlns:a="http://schemas.openxmlformats.org/drawingml/2006/main">
             <a:fillRect l="0" t="0" r="0" b="0"/>
@@ -15379,7 +15394,7 @@
       </p:sp>
       <p:cxnSp>
         <p:nvCxnSpPr>
-          <p:cNvPr id="84" name=""/>
+          <p:cNvPr id="104" name=""/>
           <p:cNvCxnSpPr/>
           <p:nvPr/>
         </p:nvCxnSpPr>
@@ -15792,7 +15807,7 @@
       </p:sp>
       <p:cxnSp>
         <p:nvCxnSpPr>
-          <p:cNvPr id="90" name=""/>
+          <p:cNvPr id="110" name=""/>
           <p:cNvCxnSpPr/>
           <p:nvPr/>
         </p:nvCxnSpPr>
@@ -15873,14 +15888,14 @@
       </p:sp>
       <p:pic>
         <p:nvPicPr>
-          <p:cNvPr id="92" name=""/>
+          <p:cNvPr id="112" name=""/>
           <p:cNvPicPr>
             <a:picLocks xmlns:a="http://schemas.openxmlformats.org/drawingml/2006/main" noChangeAspect="1"/>
           </p:cNvPicPr>
           <p:nvPr/>
         </p:nvPicPr>
         <p:blipFill>
-          <a:blip xmlns:r="http://schemas.openxmlformats.org/officeDocument/2006/relationships" xmlns:a="http://schemas.openxmlformats.org/drawingml/2006/main" r:embed="Rf298b7916d234b76"/>
+          <a:blip xmlns:r="http://schemas.openxmlformats.org/officeDocument/2006/relationships" xmlns:a="http://schemas.openxmlformats.org/drawingml/2006/main" r:embed="R314c44e9231043a5"/>
           <a:srcRect xmlns:a="http://schemas.openxmlformats.org/drawingml/2006/main" l="0" t="9356" r="0" b="9356"/>
           <a:stretch xmlns:a="http://schemas.openxmlformats.org/drawingml/2006/main">
             <a:fillRect l="0" t="0" r="0" b="0"/>
@@ -16045,7 +16060,7 @@
       </p:sp>
       <p:cxnSp>
         <p:nvCxnSpPr>
-          <p:cNvPr id="55" name=""/>
+          <p:cNvPr id="65" name=""/>
           <p:cNvCxnSpPr/>
           <p:nvPr/>
         </p:nvCxnSpPr>
@@ -16185,14 +16200,14 @@
       </p:sp>
       <p:pic>
         <p:nvPicPr>
-          <p:cNvPr id="58" name=""/>
+          <p:cNvPr id="68" name=""/>
           <p:cNvPicPr>
             <a:picLocks xmlns:a="http://schemas.openxmlformats.org/drawingml/2006/main" noChangeAspect="1"/>
           </p:cNvPicPr>
           <p:nvPr/>
         </p:nvPicPr>
         <p:blipFill>
-          <a:blip xmlns:r="http://schemas.openxmlformats.org/officeDocument/2006/relationships" xmlns:a="http://schemas.openxmlformats.org/drawingml/2006/main" r:embed="Rc640bc0a34fc4a66"/>
+          <a:blip xmlns:r="http://schemas.openxmlformats.org/officeDocument/2006/relationships" xmlns:a="http://schemas.openxmlformats.org/drawingml/2006/main" r:embed="R356c7f20e39d41ee"/>
           <a:srcRect xmlns:a="http://schemas.openxmlformats.org/drawingml/2006/main" l="316" t="0" r="316" b="0"/>
           <a:stretch xmlns:a="http://schemas.openxmlformats.org/drawingml/2006/main">
             <a:fillRect l="0" t="0" r="0" b="0"/>
@@ -16210,14 +16225,14 @@
       </p:pic>
       <p:pic>
         <p:nvPicPr>
-          <p:cNvPr id="59" name=""/>
+          <p:cNvPr id="69" name=""/>
           <p:cNvPicPr>
             <a:picLocks xmlns:a="http://schemas.openxmlformats.org/drawingml/2006/main" noChangeAspect="1"/>
           </p:cNvPicPr>
           <p:nvPr/>
         </p:nvPicPr>
         <p:blipFill>
-          <a:blip xmlns:r="http://schemas.openxmlformats.org/officeDocument/2006/relationships" xmlns:a="http://schemas.openxmlformats.org/drawingml/2006/main" r:embed="R13c5b2ac75fd48ce"/>
+          <a:blip xmlns:r="http://schemas.openxmlformats.org/officeDocument/2006/relationships" xmlns:a="http://schemas.openxmlformats.org/drawingml/2006/main" r:embed="Rc533932bdf2b49af"/>
           <a:srcRect xmlns:a="http://schemas.openxmlformats.org/drawingml/2006/main" l="0" t="383" r="0" b="383"/>
           <a:stretch xmlns:a="http://schemas.openxmlformats.org/drawingml/2006/main">
             <a:fillRect l="0" t="0" r="0" b="0"/>

</xml_diff>

<commit_message>
feat(deploy): add production Render demo
</commit_message>
<xml_diff>
--- a/submission/agent-snr-hackathon-demo.pptx
+++ b/submission/agent-snr-hackathon-demo.pptx
@@ -2,24 +2,24 @@
 <file path=ppt/presentation.xml><?xml version="1.0" encoding="utf-8"?>
 <p:presentation xmlns:p="http://schemas.openxmlformats.org/presentationml/2006/main">
   <p:sldMasterIdLst>
-    <p:sldMasterId xmlns:r="http://schemas.openxmlformats.org/officeDocument/2006/relationships" id="2147483648" r:id="R9859e258e05c4b1d"/>
+    <p:sldMasterId xmlns:r="http://schemas.openxmlformats.org/officeDocument/2006/relationships" id="2147483648" r:id="R6ebd6191931e4ac7"/>
   </p:sldMasterIdLst>
   <p:notesMasterIdLst>
-    <p:notesMasterId xmlns:r="http://schemas.openxmlformats.org/officeDocument/2006/relationships" r:id="Rdb2c070390b7439c"/>
+    <p:notesMasterId xmlns:r="http://schemas.openxmlformats.org/officeDocument/2006/relationships" r:id="Rb529cf6a31b3471d"/>
   </p:notesMasterIdLst>
   <p:sldIdLst>
-    <p:sldId xmlns:r="http://schemas.openxmlformats.org/officeDocument/2006/relationships" id="256" r:id="R396f8a37443f4361"/>
-    <p:sldId xmlns:r="http://schemas.openxmlformats.org/officeDocument/2006/relationships" id="257" r:id="R408c9a90bb1448fe"/>
-    <p:sldId xmlns:r="http://schemas.openxmlformats.org/officeDocument/2006/relationships" id="258" r:id="R20645dbc89704485"/>
-    <p:sldId xmlns:r="http://schemas.openxmlformats.org/officeDocument/2006/relationships" id="259" r:id="Rff9d24dbdda547ba"/>
-    <p:sldId xmlns:r="http://schemas.openxmlformats.org/officeDocument/2006/relationships" id="260" r:id="Rae1403b324c54c75"/>
-    <p:sldId xmlns:r="http://schemas.openxmlformats.org/officeDocument/2006/relationships" id="261" r:id="R0b1e33ba93874e81"/>
-    <p:sldId xmlns:r="http://schemas.openxmlformats.org/officeDocument/2006/relationships" id="262" r:id="R7a19e0d970a94ed4"/>
-    <p:sldId xmlns:r="http://schemas.openxmlformats.org/officeDocument/2006/relationships" id="263" r:id="Ra942c15e8c50441a"/>
-    <p:sldId xmlns:r="http://schemas.openxmlformats.org/officeDocument/2006/relationships" id="264" r:id="Rb84c2a936b064036"/>
-    <p:sldId xmlns:r="http://schemas.openxmlformats.org/officeDocument/2006/relationships" id="265" r:id="Ra58e542732f24158"/>
-    <p:sldId xmlns:r="http://schemas.openxmlformats.org/officeDocument/2006/relationships" id="266" r:id="R2ae511c479f04cfd"/>
-    <p:sldId xmlns:r="http://schemas.openxmlformats.org/officeDocument/2006/relationships" id="267" r:id="R4466aa3962e34013"/>
+    <p:sldId xmlns:r="http://schemas.openxmlformats.org/officeDocument/2006/relationships" id="256" r:id="Rd74fb338f96f486d"/>
+    <p:sldId xmlns:r="http://schemas.openxmlformats.org/officeDocument/2006/relationships" id="257" r:id="Ra082e77bcbf4411e"/>
+    <p:sldId xmlns:r="http://schemas.openxmlformats.org/officeDocument/2006/relationships" id="258" r:id="Rafdff9c40d384852"/>
+    <p:sldId xmlns:r="http://schemas.openxmlformats.org/officeDocument/2006/relationships" id="259" r:id="R246bb18832bc41fe"/>
+    <p:sldId xmlns:r="http://schemas.openxmlformats.org/officeDocument/2006/relationships" id="260" r:id="R42232372c56c4981"/>
+    <p:sldId xmlns:r="http://schemas.openxmlformats.org/officeDocument/2006/relationships" id="261" r:id="Rbbaa0f6b66c14469"/>
+    <p:sldId xmlns:r="http://schemas.openxmlformats.org/officeDocument/2006/relationships" id="262" r:id="Rdb9936478dd54d37"/>
+    <p:sldId xmlns:r="http://schemas.openxmlformats.org/officeDocument/2006/relationships" id="263" r:id="R542a2b846524494d"/>
+    <p:sldId xmlns:r="http://schemas.openxmlformats.org/officeDocument/2006/relationships" id="264" r:id="R7398fac4d0ce4cb0"/>
+    <p:sldId xmlns:r="http://schemas.openxmlformats.org/officeDocument/2006/relationships" id="265" r:id="R5fff805d17734dce"/>
+    <p:sldId xmlns:r="http://schemas.openxmlformats.org/officeDocument/2006/relationships" id="266" r:id="R7c7c596750814109"/>
+    <p:sldId xmlns:r="http://schemas.openxmlformats.org/officeDocument/2006/relationships" id="267" r:id="R686224610d884c4d"/>
   </p:sldIdLst>
   <p:sldSz cx="12192000" cy="6858000"/>
   <p:notesSz cx="6858000" cy="9144000"/>
@@ -1641,7 +1641,7 @@
   </p:cSld>
   <p:clrMap bg1="lt1" tx1="dk1" bg2="lt2" tx2="dk2" accent1="accent1" accent2="accent2" accent3="accent3" accent4="accent4" accent5="accent5" accent6="accent6" hlink="hlink" folHlink="folHlink"/>
   <p:sldLayoutIdLst>
-    <p:sldLayoutId xmlns:r="http://schemas.openxmlformats.org/officeDocument/2006/relationships" id="2147483649" r:id="R61fec53a798a4c7d"/>
+    <p:sldLayoutId xmlns:r="http://schemas.openxmlformats.org/officeDocument/2006/relationships" id="2147483649" r:id="R745fe6dcb62249ec"/>
   </p:sldLayoutIdLst>
   <p:txStyles>
     <p:titleStyle>
@@ -2561,7 +2561,7 @@
       </p:sp>
       <p:cxnSp>
         <p:nvCxnSpPr>
-          <p:cNvPr id="79" name=""/>
+          <p:cNvPr id="107" name=""/>
           <p:cNvCxnSpPr/>
           <p:nvPr/>
         </p:nvCxnSpPr>
@@ -2848,7 +2848,7 @@
       </p:sp>
       <p:cxnSp>
         <p:nvCxnSpPr>
-          <p:cNvPr id="306" name=""/>
+          <p:cNvPr id="426" name=""/>
           <p:cNvCxnSpPr/>
           <p:nvPr/>
         </p:nvCxnSpPr>
@@ -2988,7 +2988,7 @@
       </p:sp>
       <p:cxnSp>
         <p:nvCxnSpPr>
-          <p:cNvPr id="309" name=""/>
+          <p:cNvPr id="429" name=""/>
           <p:cNvCxnSpPr/>
           <p:nvPr/>
         </p:nvCxnSpPr>
@@ -4213,7 +4213,7 @@
       </p:sp>
       <p:cxnSp>
         <p:nvCxnSpPr>
-          <p:cNvPr id="333" name=""/>
+          <p:cNvPr id="453" name=""/>
           <p:cNvCxnSpPr/>
           <p:nvPr/>
         </p:nvCxnSpPr>
@@ -4631,7 +4631,7 @@
       </p:sp>
       <p:cxnSp>
         <p:nvCxnSpPr>
-          <p:cNvPr id="224" name=""/>
+          <p:cNvPr id="312" name=""/>
           <p:cNvCxnSpPr/>
           <p:nvPr/>
         </p:nvCxnSpPr>
@@ -4823,14 +4823,14 @@
                 <a:ea typeface="Helvetica Neue"/>
                 <a:cs typeface="Helvetica Neue"/>
               </a:rPr>
-              <a:t>112</a:t>
+              <a:t>125</a:t>
             </a:r>
           </a:p>
         </p:txBody>
       </p:sp>
       <p:cxnSp>
         <p:nvCxnSpPr>
-          <p:cNvPr id="228" name=""/>
+          <p:cNvPr id="316" name=""/>
           <p:cNvCxnSpPr/>
           <p:nvPr/>
         </p:nvCxnSpPr>
@@ -4970,7 +4970,7 @@
       </p:sp>
       <p:cxnSp>
         <p:nvCxnSpPr>
-          <p:cNvPr id="231" name=""/>
+          <p:cNvPr id="319" name=""/>
           <p:cNvCxnSpPr/>
           <p:nvPr/>
         </p:nvCxnSpPr>
@@ -5110,7 +5110,7 @@
       </p:sp>
       <p:cxnSp>
         <p:nvCxnSpPr>
-          <p:cNvPr id="234" name=""/>
+          <p:cNvPr id="322" name=""/>
           <p:cNvCxnSpPr/>
           <p:nvPr/>
         </p:nvCxnSpPr>
@@ -5250,7 +5250,7 @@
       </p:sp>
       <p:cxnSp>
         <p:nvCxnSpPr>
-          <p:cNvPr id="237" name=""/>
+          <p:cNvPr id="325" name=""/>
           <p:cNvCxnSpPr/>
           <p:nvPr/>
         </p:nvCxnSpPr>
@@ -5390,7 +5390,7 @@
       </p:sp>
       <p:cxnSp>
         <p:nvCxnSpPr>
-          <p:cNvPr id="240" name=""/>
+          <p:cNvPr id="328" name=""/>
           <p:cNvCxnSpPr/>
           <p:nvPr/>
         </p:nvCxnSpPr>
@@ -5530,7 +5530,7 @@
       </p:sp>
       <p:cxnSp>
         <p:nvCxnSpPr>
-          <p:cNvPr id="243" name=""/>
+          <p:cNvPr id="331" name=""/>
           <p:cNvCxnSpPr/>
           <p:nvPr/>
         </p:nvCxnSpPr>
@@ -6477,7 +6477,7 @@
       </p:sp>
       <p:cxnSp>
         <p:nvCxnSpPr>
-          <p:cNvPr id="178" name=""/>
+          <p:cNvPr id="242" name=""/>
           <p:cNvCxnSpPr/>
           <p:nvPr/>
         </p:nvCxnSpPr>
@@ -6764,7 +6764,7 @@
       </p:sp>
       <p:cxnSp>
         <p:nvCxnSpPr>
-          <p:cNvPr id="81" name=""/>
+          <p:cNvPr id="105" name=""/>
           <p:cNvCxnSpPr/>
           <p:nvPr/>
         </p:nvCxnSpPr>
@@ -6904,7 +6904,7 @@
       </p:sp>
       <p:cxnSp>
         <p:nvCxnSpPr>
-          <p:cNvPr id="84" name=""/>
+          <p:cNvPr id="108" name=""/>
           <p:cNvCxnSpPr/>
           <p:nvPr/>
         </p:nvCxnSpPr>
@@ -7961,7 +7961,7 @@
       </p:sp>
       <p:cxnSp>
         <p:nvCxnSpPr>
-          <p:cNvPr id="177" name=""/>
+          <p:cNvPr id="245" name=""/>
           <p:cNvCxnSpPr/>
           <p:nvPr/>
         </p:nvCxnSpPr>
@@ -8278,7 +8278,7 @@
       </p:sp>
       <p:cxnSp>
         <p:nvCxnSpPr>
-          <p:cNvPr id="183" name=""/>
+          <p:cNvPr id="251" name=""/>
           <p:cNvCxnSpPr/>
           <p:nvPr/>
         </p:nvCxnSpPr>
@@ -8477,7 +8477,7 @@
       </p:sp>
       <p:cxnSp>
         <p:nvCxnSpPr>
-          <p:cNvPr id="187" name=""/>
+          <p:cNvPr id="255" name=""/>
           <p:cNvCxnSpPr/>
           <p:nvPr/>
         </p:nvCxnSpPr>
@@ -8676,7 +8676,7 @@
       </p:sp>
       <p:cxnSp>
         <p:nvCxnSpPr>
-          <p:cNvPr id="191" name=""/>
+          <p:cNvPr id="259" name=""/>
           <p:cNvCxnSpPr/>
           <p:nvPr/>
         </p:nvCxnSpPr>
@@ -9055,7 +9055,7 @@
       </p:sp>
       <p:cxnSp>
         <p:nvCxnSpPr>
-          <p:cNvPr id="165" name=""/>
+          <p:cNvPr id="217" name=""/>
           <p:cNvCxnSpPr/>
           <p:nvPr/>
         </p:nvCxnSpPr>
@@ -9504,7 +9504,7 @@
       </p:sp>
       <p:cxnSp>
         <p:nvCxnSpPr>
-          <p:cNvPr id="175" name=""/>
+          <p:cNvPr id="227" name=""/>
           <p:cNvCxnSpPr/>
           <p:nvPr/>
         </p:nvCxnSpPr>
@@ -11265,7 +11265,7 @@
       </p:sp>
       <p:cxnSp>
         <p:nvCxnSpPr>
-          <p:cNvPr id="46" name=""/>
+          <p:cNvPr id="58" name=""/>
           <p:cNvCxnSpPr/>
           <p:nvPr/>
         </p:nvCxnSpPr>
@@ -12367,7 +12367,7 @@
       </p:sp>
       <p:cxnSp>
         <p:nvCxnSpPr>
-          <p:cNvPr id="306" name=""/>
+          <p:cNvPr id="426" name=""/>
           <p:cNvCxnSpPr/>
           <p:nvPr/>
         </p:nvCxnSpPr>
@@ -12507,7 +12507,7 @@
       </p:sp>
       <p:cxnSp>
         <p:nvCxnSpPr>
-          <p:cNvPr id="309" name=""/>
+          <p:cNvPr id="429" name=""/>
           <p:cNvCxnSpPr/>
           <p:nvPr/>
         </p:nvCxnSpPr>
@@ -13732,7 +13732,7 @@
       </p:sp>
       <p:cxnSp>
         <p:nvCxnSpPr>
-          <p:cNvPr id="333" name=""/>
+          <p:cNvPr id="453" name=""/>
           <p:cNvCxnSpPr/>
           <p:nvPr/>
         </p:nvCxnSpPr>
@@ -14150,7 +14150,7 @@
       </p:sp>
       <p:cxnSp>
         <p:nvCxnSpPr>
-          <p:cNvPr id="63" name=""/>
+          <p:cNvPr id="79" name=""/>
           <p:cNvCxnSpPr/>
           <p:nvPr/>
         </p:nvCxnSpPr>
@@ -14290,14 +14290,14 @@
       </p:sp>
       <p:pic>
         <p:nvPicPr>
-          <p:cNvPr id="66" name=""/>
+          <p:cNvPr id="82" name=""/>
           <p:cNvPicPr>
             <a:picLocks xmlns:a="http://schemas.openxmlformats.org/drawingml/2006/main" noChangeAspect="1"/>
           </p:cNvPicPr>
           <p:nvPr/>
         </p:nvPicPr>
         <p:blipFill>
-          <a:blip xmlns:r="http://schemas.openxmlformats.org/officeDocument/2006/relationships" xmlns:a="http://schemas.openxmlformats.org/drawingml/2006/main" r:embed="Rcb52b0a863d34133"/>
+          <a:blip xmlns:r="http://schemas.openxmlformats.org/officeDocument/2006/relationships" xmlns:a="http://schemas.openxmlformats.org/drawingml/2006/main" r:embed="Rcaaf7dc2126a4a3c"/>
           <a:srcRect xmlns:a="http://schemas.openxmlformats.org/drawingml/2006/main" l="11607" t="0" r="11607" b="0"/>
           <a:stretch xmlns:a="http://schemas.openxmlformats.org/drawingml/2006/main">
             <a:fillRect l="0" t="0" r="0" b="0"/>
@@ -15394,7 +15394,7 @@
       </p:sp>
       <p:cxnSp>
         <p:nvCxnSpPr>
-          <p:cNvPr id="104" name=""/>
+          <p:cNvPr id="144" name=""/>
           <p:cNvCxnSpPr/>
           <p:nvPr/>
         </p:nvCxnSpPr>
@@ -15807,7 +15807,7 @@
       </p:sp>
       <p:cxnSp>
         <p:nvCxnSpPr>
-          <p:cNvPr id="110" name=""/>
+          <p:cNvPr id="150" name=""/>
           <p:cNvCxnSpPr/>
           <p:nvPr/>
         </p:nvCxnSpPr>
@@ -15888,14 +15888,14 @@
       </p:sp>
       <p:pic>
         <p:nvPicPr>
-          <p:cNvPr id="112" name=""/>
+          <p:cNvPr id="152" name=""/>
           <p:cNvPicPr>
             <a:picLocks xmlns:a="http://schemas.openxmlformats.org/drawingml/2006/main" noChangeAspect="1"/>
           </p:cNvPicPr>
           <p:nvPr/>
         </p:nvPicPr>
         <p:blipFill>
-          <a:blip xmlns:r="http://schemas.openxmlformats.org/officeDocument/2006/relationships" xmlns:a="http://schemas.openxmlformats.org/drawingml/2006/main" r:embed="R314c44e9231043a5"/>
+          <a:blip xmlns:r="http://schemas.openxmlformats.org/officeDocument/2006/relationships" xmlns:a="http://schemas.openxmlformats.org/drawingml/2006/main" r:embed="R2a3f8b3717484cd3"/>
           <a:srcRect xmlns:a="http://schemas.openxmlformats.org/drawingml/2006/main" l="0" t="9356" r="0" b="9356"/>
           <a:stretch xmlns:a="http://schemas.openxmlformats.org/drawingml/2006/main">
             <a:fillRect l="0" t="0" r="0" b="0"/>
@@ -16060,7 +16060,7 @@
       </p:sp>
       <p:cxnSp>
         <p:nvCxnSpPr>
-          <p:cNvPr id="65" name=""/>
+          <p:cNvPr id="85" name=""/>
           <p:cNvCxnSpPr/>
           <p:nvPr/>
         </p:nvCxnSpPr>
@@ -16200,14 +16200,14 @@
       </p:sp>
       <p:pic>
         <p:nvPicPr>
-          <p:cNvPr id="68" name=""/>
+          <p:cNvPr id="88" name=""/>
           <p:cNvPicPr>
             <a:picLocks xmlns:a="http://schemas.openxmlformats.org/drawingml/2006/main" noChangeAspect="1"/>
           </p:cNvPicPr>
           <p:nvPr/>
         </p:nvPicPr>
         <p:blipFill>
-          <a:blip xmlns:r="http://schemas.openxmlformats.org/officeDocument/2006/relationships" xmlns:a="http://schemas.openxmlformats.org/drawingml/2006/main" r:embed="R356c7f20e39d41ee"/>
+          <a:blip xmlns:r="http://schemas.openxmlformats.org/officeDocument/2006/relationships" xmlns:a="http://schemas.openxmlformats.org/drawingml/2006/main" r:embed="R292fb77ff7ad4d9a"/>
           <a:srcRect xmlns:a="http://schemas.openxmlformats.org/drawingml/2006/main" l="316" t="0" r="316" b="0"/>
           <a:stretch xmlns:a="http://schemas.openxmlformats.org/drawingml/2006/main">
             <a:fillRect l="0" t="0" r="0" b="0"/>
@@ -16225,14 +16225,14 @@
       </p:pic>
       <p:pic>
         <p:nvPicPr>
-          <p:cNvPr id="69" name=""/>
+          <p:cNvPr id="89" name=""/>
           <p:cNvPicPr>
             <a:picLocks xmlns:a="http://schemas.openxmlformats.org/drawingml/2006/main" noChangeAspect="1"/>
           </p:cNvPicPr>
           <p:nvPr/>
         </p:nvPicPr>
         <p:blipFill>
-          <a:blip xmlns:r="http://schemas.openxmlformats.org/officeDocument/2006/relationships" xmlns:a="http://schemas.openxmlformats.org/drawingml/2006/main" r:embed="Rc533932bdf2b49af"/>
+          <a:blip xmlns:r="http://schemas.openxmlformats.org/officeDocument/2006/relationships" xmlns:a="http://schemas.openxmlformats.org/drawingml/2006/main" r:embed="Rb3f6c5e1967c4a37"/>
           <a:srcRect xmlns:a="http://schemas.openxmlformats.org/drawingml/2006/main" l="0" t="383" r="0" b="383"/>
           <a:stretch xmlns:a="http://schemas.openxmlformats.org/drawingml/2006/main">
             <a:fillRect l="0" t="0" r="0" b="0"/>

</xml_diff>

<commit_message>
refactor(brand): standardize Agent SNR identity
</commit_message>
<xml_diff>
--- a/submission/agent-snr-hackathon-demo.pptx
+++ b/submission/agent-snr-hackathon-demo.pptx
@@ -2,24 +2,24 @@
 <file path=ppt/presentation.xml><?xml version="1.0" encoding="utf-8"?>
 <p:presentation xmlns:p="http://schemas.openxmlformats.org/presentationml/2006/main">
   <p:sldMasterIdLst>
-    <p:sldMasterId xmlns:r="http://schemas.openxmlformats.org/officeDocument/2006/relationships" id="2147483648" r:id="R6ebd6191931e4ac7"/>
+    <p:sldMasterId xmlns:r="http://schemas.openxmlformats.org/officeDocument/2006/relationships" id="2147483648" r:id="R9607a022c3dc4e8d"/>
   </p:sldMasterIdLst>
   <p:notesMasterIdLst>
-    <p:notesMasterId xmlns:r="http://schemas.openxmlformats.org/officeDocument/2006/relationships" r:id="Rb529cf6a31b3471d"/>
+    <p:notesMasterId xmlns:r="http://schemas.openxmlformats.org/officeDocument/2006/relationships" r:id="R88283fc3538744b7"/>
   </p:notesMasterIdLst>
   <p:sldIdLst>
-    <p:sldId xmlns:r="http://schemas.openxmlformats.org/officeDocument/2006/relationships" id="256" r:id="Rd74fb338f96f486d"/>
-    <p:sldId xmlns:r="http://schemas.openxmlformats.org/officeDocument/2006/relationships" id="257" r:id="Ra082e77bcbf4411e"/>
-    <p:sldId xmlns:r="http://schemas.openxmlformats.org/officeDocument/2006/relationships" id="258" r:id="Rafdff9c40d384852"/>
-    <p:sldId xmlns:r="http://schemas.openxmlformats.org/officeDocument/2006/relationships" id="259" r:id="R246bb18832bc41fe"/>
-    <p:sldId xmlns:r="http://schemas.openxmlformats.org/officeDocument/2006/relationships" id="260" r:id="R42232372c56c4981"/>
-    <p:sldId xmlns:r="http://schemas.openxmlformats.org/officeDocument/2006/relationships" id="261" r:id="Rbbaa0f6b66c14469"/>
-    <p:sldId xmlns:r="http://schemas.openxmlformats.org/officeDocument/2006/relationships" id="262" r:id="Rdb9936478dd54d37"/>
-    <p:sldId xmlns:r="http://schemas.openxmlformats.org/officeDocument/2006/relationships" id="263" r:id="R542a2b846524494d"/>
-    <p:sldId xmlns:r="http://schemas.openxmlformats.org/officeDocument/2006/relationships" id="264" r:id="R7398fac4d0ce4cb0"/>
-    <p:sldId xmlns:r="http://schemas.openxmlformats.org/officeDocument/2006/relationships" id="265" r:id="R5fff805d17734dce"/>
-    <p:sldId xmlns:r="http://schemas.openxmlformats.org/officeDocument/2006/relationships" id="266" r:id="R7c7c596750814109"/>
-    <p:sldId xmlns:r="http://schemas.openxmlformats.org/officeDocument/2006/relationships" id="267" r:id="R686224610d884c4d"/>
+    <p:sldId xmlns:r="http://schemas.openxmlformats.org/officeDocument/2006/relationships" id="256" r:id="Rffeeba1b60294776"/>
+    <p:sldId xmlns:r="http://schemas.openxmlformats.org/officeDocument/2006/relationships" id="257" r:id="R99e79e84348c4d6d"/>
+    <p:sldId xmlns:r="http://schemas.openxmlformats.org/officeDocument/2006/relationships" id="258" r:id="R58a3d07e7f804cd4"/>
+    <p:sldId xmlns:r="http://schemas.openxmlformats.org/officeDocument/2006/relationships" id="259" r:id="Rc97a703d54d5459b"/>
+    <p:sldId xmlns:r="http://schemas.openxmlformats.org/officeDocument/2006/relationships" id="260" r:id="R8063d0d4fb8f4f1f"/>
+    <p:sldId xmlns:r="http://schemas.openxmlformats.org/officeDocument/2006/relationships" id="261" r:id="R9004ad9df96c4ddd"/>
+    <p:sldId xmlns:r="http://schemas.openxmlformats.org/officeDocument/2006/relationships" id="262" r:id="R6714d3db6a8445ad"/>
+    <p:sldId xmlns:r="http://schemas.openxmlformats.org/officeDocument/2006/relationships" id="263" r:id="R2e01ff0ad6224701"/>
+    <p:sldId xmlns:r="http://schemas.openxmlformats.org/officeDocument/2006/relationships" id="264" r:id="R624a4c746bb84eda"/>
+    <p:sldId xmlns:r="http://schemas.openxmlformats.org/officeDocument/2006/relationships" id="265" r:id="R36af8fada079412a"/>
+    <p:sldId xmlns:r="http://schemas.openxmlformats.org/officeDocument/2006/relationships" id="266" r:id="R3741c2e03dfd4bd8"/>
+    <p:sldId xmlns:r="http://schemas.openxmlformats.org/officeDocument/2006/relationships" id="267" r:id="Ra6cd83bb08394012"/>
   </p:sldIdLst>
   <p:sldSz cx="12192000" cy="6858000"/>
   <p:notesSz cx="6858000" cy="9144000"/>
@@ -1048,27 +1048,27 @@
           </a:p>
           <a:p xmlns:a="http://schemas.openxmlformats.org/drawingml/2006/main">
             <a:r>
-              <a:t>- plugin/wmcp-agentops/src/Contract/ToolName.php</a:t>
-            </a:r>
-          </a:p>
-          <a:p xmlns:a="http://schemas.openxmlformats.org/drawingml/2006/main">
-            <a:r>
-              <a:t>- plugin/wmcp-agentops/src/Abilities/ToolCatalog.php</a:t>
-            </a:r>
-          </a:p>
-          <a:p xmlns:a="http://schemas.openxmlformats.org/drawingml/2006/main">
-            <a:r>
-              <a:t>- plugin/wmcp-agentops/src/Guidance/AgentGuide.php</a:t>
-            </a:r>
-          </a:p>
-          <a:p xmlns:a="http://schemas.openxmlformats.org/drawingml/2006/main">
-            <a:r>
-              <a:t>- plugin/wmcp-agentops/src/Analytics/SignalService.php</a:t>
-            </a:r>
-          </a:p>
-          <a:p xmlns:a="http://schemas.openxmlformats.org/drawingml/2006/main">
-            <a:r>
-              <a:t>- plugin/wmcp-agentops/src/WebMCP/ExecutionController.php</a:t>
+              <a:t>- plugin/wmcp-agentsnr/src/Contract/ToolName.php</a:t>
+            </a:r>
+          </a:p>
+          <a:p xmlns:a="http://schemas.openxmlformats.org/drawingml/2006/main">
+            <a:r>
+              <a:t>- plugin/wmcp-agentsnr/src/Abilities/ToolCatalog.php</a:t>
+            </a:r>
+          </a:p>
+          <a:p xmlns:a="http://schemas.openxmlformats.org/drawingml/2006/main">
+            <a:r>
+              <a:t>- plugin/wmcp-agentsnr/src/Guidance/AgentGuide.php</a:t>
+            </a:r>
+          </a:p>
+          <a:p xmlns:a="http://schemas.openxmlformats.org/drawingml/2006/main">
+            <a:r>
+              <a:t>- plugin/wmcp-agentsnr/src/Analytics/SignalService.php</a:t>
+            </a:r>
+          </a:p>
+          <a:p xmlns:a="http://schemas.openxmlformats.org/drawingml/2006/main">
+            <a:r>
+              <a:t>- plugin/wmcp-agentsnr/src/WebMCP/ExecutionController.php</a:t>
             </a:r>
           </a:p>
           <a:p xmlns:a="http://schemas.openxmlformats.org/drawingml/2006/main">
@@ -1163,12 +1163,12 @@
           </a:p>
           <a:p xmlns:a="http://schemas.openxmlformats.org/drawingml/2006/main">
             <a:r>
-              <a:t>- plugin/wmcp-agentops/src/Guidance/AgentGuide.php</a:t>
-            </a:r>
-          </a:p>
-          <a:p xmlns:a="http://schemas.openxmlformats.org/drawingml/2006/main">
-            <a:r>
-              <a:t>- plugin/wmcp-agentops/src/Analytics/FeedbackMetricResolver.php</a:t>
+              <a:t>- plugin/wmcp-agentsnr/src/Guidance/AgentGuide.php</a:t>
+            </a:r>
+          </a:p>
+          <a:p xmlns:a="http://schemas.openxmlformats.org/drawingml/2006/main">
+            <a:r>
+              <a:t>- plugin/wmcp-agentsnr/src/Analytics/FeedbackMetricResolver.php</a:t>
             </a:r>
           </a:p>
           <a:p xmlns:a="http://schemas.openxmlformats.org/drawingml/2006/main">
@@ -1468,7 +1468,7 @@
           </a:p>
           <a:p xmlns:a="http://schemas.openxmlformats.org/drawingml/2006/main">
             <a:r>
-              <a:t>- plugin/wmcp-agentops/src/Guidance/AgentGuide.php</a:t>
+              <a:t>- plugin/wmcp-agentsnr/src/Guidance/AgentGuide.php</a:t>
             </a:r>
           </a:p>
           <a:p xmlns:a="http://schemas.openxmlformats.org/drawingml/2006/main">
@@ -1568,12 +1568,12 @@
           </a:p>
           <a:p xmlns:a="http://schemas.openxmlformats.org/drawingml/2006/main">
             <a:r>
-              <a:t>- plugin/wmcp-agentops/src/Analytics/SignalService.php</a:t>
-            </a:r>
-          </a:p>
-          <a:p xmlns:a="http://schemas.openxmlformats.org/drawingml/2006/main">
-            <a:r>
-              <a:t>- plugin/wmcp-agentops/src/WooCommerce/AttributionRules.php</a:t>
+              <a:t>- plugin/wmcp-agentsnr/src/Analytics/SignalService.php</a:t>
+            </a:r>
+          </a:p>
+          <a:p xmlns:a="http://schemas.openxmlformats.org/drawingml/2006/main">
+            <a:r>
+              <a:t>- plugin/wmcp-agentsnr/src/WooCommerce/AttributionRules.php</a:t>
             </a:r>
           </a:p>
         </p:txBody>
@@ -1641,7 +1641,7 @@
   </p:cSld>
   <p:clrMap bg1="lt1" tx1="dk1" bg2="lt2" tx2="dk2" accent1="accent1" accent2="accent2" accent3="accent3" accent4="accent4" accent5="accent5" accent6="accent6" hlink="hlink" folHlink="folHlink"/>
   <p:sldLayoutIdLst>
-    <p:sldLayoutId xmlns:r="http://schemas.openxmlformats.org/officeDocument/2006/relationships" id="2147483649" r:id="R745fe6dcb62249ec"/>
+    <p:sldLayoutId xmlns:r="http://schemas.openxmlformats.org/officeDocument/2006/relationships" id="2147483649" r:id="Raebb484edddc4931"/>
   </p:sldLayoutIdLst>
   <p:txStyles>
     <p:titleStyle>
@@ -2561,7 +2561,7 @@
       </p:sp>
       <p:cxnSp>
         <p:nvCxnSpPr>
-          <p:cNvPr id="107" name=""/>
+          <p:cNvPr id="121" name=""/>
           <p:cNvCxnSpPr/>
           <p:nvPr/>
         </p:nvCxnSpPr>
@@ -2848,7 +2848,7 @@
       </p:sp>
       <p:cxnSp>
         <p:nvCxnSpPr>
-          <p:cNvPr id="426" name=""/>
+          <p:cNvPr id="486" name=""/>
           <p:cNvCxnSpPr/>
           <p:nvPr/>
         </p:nvCxnSpPr>
@@ -2988,7 +2988,7 @@
       </p:sp>
       <p:cxnSp>
         <p:nvCxnSpPr>
-          <p:cNvPr id="429" name=""/>
+          <p:cNvPr id="489" name=""/>
           <p:cNvCxnSpPr/>
           <p:nvPr/>
         </p:nvCxnSpPr>
@@ -4213,7 +4213,7 @@
       </p:sp>
       <p:cxnSp>
         <p:nvCxnSpPr>
-          <p:cNvPr id="453" name=""/>
+          <p:cNvPr id="513" name=""/>
           <p:cNvCxnSpPr/>
           <p:nvPr/>
         </p:nvCxnSpPr>
@@ -4631,7 +4631,7 @@
       </p:sp>
       <p:cxnSp>
         <p:nvCxnSpPr>
-          <p:cNvPr id="312" name=""/>
+          <p:cNvPr id="356" name=""/>
           <p:cNvCxnSpPr/>
           <p:nvPr/>
         </p:nvCxnSpPr>
@@ -4830,7 +4830,7 @@
       </p:sp>
       <p:cxnSp>
         <p:nvCxnSpPr>
-          <p:cNvPr id="316" name=""/>
+          <p:cNvPr id="360" name=""/>
           <p:cNvCxnSpPr/>
           <p:nvPr/>
         </p:nvCxnSpPr>
@@ -4970,7 +4970,7 @@
       </p:sp>
       <p:cxnSp>
         <p:nvCxnSpPr>
-          <p:cNvPr id="319" name=""/>
+          <p:cNvPr id="363" name=""/>
           <p:cNvCxnSpPr/>
           <p:nvPr/>
         </p:nvCxnSpPr>
@@ -5110,7 +5110,7 @@
       </p:sp>
       <p:cxnSp>
         <p:nvCxnSpPr>
-          <p:cNvPr id="322" name=""/>
+          <p:cNvPr id="366" name=""/>
           <p:cNvCxnSpPr/>
           <p:nvPr/>
         </p:nvCxnSpPr>
@@ -5250,7 +5250,7 @@
       </p:sp>
       <p:cxnSp>
         <p:nvCxnSpPr>
-          <p:cNvPr id="325" name=""/>
+          <p:cNvPr id="369" name=""/>
           <p:cNvCxnSpPr/>
           <p:nvPr/>
         </p:nvCxnSpPr>
@@ -5390,7 +5390,7 @@
       </p:sp>
       <p:cxnSp>
         <p:nvCxnSpPr>
-          <p:cNvPr id="328" name=""/>
+          <p:cNvPr id="372" name=""/>
           <p:cNvCxnSpPr/>
           <p:nvPr/>
         </p:nvCxnSpPr>
@@ -5530,7 +5530,7 @@
       </p:sp>
       <p:cxnSp>
         <p:nvCxnSpPr>
-          <p:cNvPr id="331" name=""/>
+          <p:cNvPr id="375" name=""/>
           <p:cNvCxnSpPr/>
           <p:nvPr/>
         </p:nvCxnSpPr>
@@ -6477,7 +6477,7 @@
       </p:sp>
       <p:cxnSp>
         <p:nvCxnSpPr>
-          <p:cNvPr id="242" name=""/>
+          <p:cNvPr id="274" name=""/>
           <p:cNvCxnSpPr/>
           <p:nvPr/>
         </p:nvCxnSpPr>
@@ -6764,7 +6764,7 @@
       </p:sp>
       <p:cxnSp>
         <p:nvCxnSpPr>
-          <p:cNvPr id="105" name=""/>
+          <p:cNvPr id="117" name=""/>
           <p:cNvCxnSpPr/>
           <p:nvPr/>
         </p:nvCxnSpPr>
@@ -6904,7 +6904,7 @@
       </p:sp>
       <p:cxnSp>
         <p:nvCxnSpPr>
-          <p:cNvPr id="108" name=""/>
+          <p:cNvPr id="120" name=""/>
           <p:cNvCxnSpPr/>
           <p:nvPr/>
         </p:nvCxnSpPr>
@@ -7961,7 +7961,7 @@
       </p:sp>
       <p:cxnSp>
         <p:nvCxnSpPr>
-          <p:cNvPr id="245" name=""/>
+          <p:cNvPr id="279" name=""/>
           <p:cNvCxnSpPr/>
           <p:nvPr/>
         </p:nvCxnSpPr>
@@ -8278,7 +8278,7 @@
       </p:sp>
       <p:cxnSp>
         <p:nvCxnSpPr>
-          <p:cNvPr id="251" name=""/>
+          <p:cNvPr id="285" name=""/>
           <p:cNvCxnSpPr/>
           <p:nvPr/>
         </p:nvCxnSpPr>
@@ -8477,7 +8477,7 @@
       </p:sp>
       <p:cxnSp>
         <p:nvCxnSpPr>
-          <p:cNvPr id="255" name=""/>
+          <p:cNvPr id="289" name=""/>
           <p:cNvCxnSpPr/>
           <p:nvPr/>
         </p:nvCxnSpPr>
@@ -8676,7 +8676,7 @@
       </p:sp>
       <p:cxnSp>
         <p:nvCxnSpPr>
-          <p:cNvPr id="259" name=""/>
+          <p:cNvPr id="293" name=""/>
           <p:cNvCxnSpPr/>
           <p:nvPr/>
         </p:nvCxnSpPr>
@@ -9055,7 +9055,7 @@
       </p:sp>
       <p:cxnSp>
         <p:nvCxnSpPr>
-          <p:cNvPr id="217" name=""/>
+          <p:cNvPr id="243" name=""/>
           <p:cNvCxnSpPr/>
           <p:nvPr/>
         </p:nvCxnSpPr>
@@ -9504,7 +9504,7 @@
       </p:sp>
       <p:cxnSp>
         <p:nvCxnSpPr>
-          <p:cNvPr id="227" name=""/>
+          <p:cNvPr id="253" name=""/>
           <p:cNvCxnSpPr/>
           <p:nvPr/>
         </p:nvCxnSpPr>
@@ -11265,7 +11265,7 @@
       </p:sp>
       <p:cxnSp>
         <p:nvCxnSpPr>
-          <p:cNvPr id="58" name=""/>
+          <p:cNvPr id="64" name=""/>
           <p:cNvCxnSpPr/>
           <p:nvPr/>
         </p:nvCxnSpPr>
@@ -12367,7 +12367,7 @@
       </p:sp>
       <p:cxnSp>
         <p:nvCxnSpPr>
-          <p:cNvPr id="426" name=""/>
+          <p:cNvPr id="486" name=""/>
           <p:cNvCxnSpPr/>
           <p:nvPr/>
         </p:nvCxnSpPr>
@@ -12507,7 +12507,7 @@
       </p:sp>
       <p:cxnSp>
         <p:nvCxnSpPr>
-          <p:cNvPr id="429" name=""/>
+          <p:cNvPr id="489" name=""/>
           <p:cNvCxnSpPr/>
           <p:nvPr/>
         </p:nvCxnSpPr>
@@ -13732,7 +13732,7 @@
       </p:sp>
       <p:cxnSp>
         <p:nvCxnSpPr>
-          <p:cNvPr id="453" name=""/>
+          <p:cNvPr id="513" name=""/>
           <p:cNvCxnSpPr/>
           <p:nvPr/>
         </p:nvCxnSpPr>
@@ -14150,7 +14150,7 @@
       </p:sp>
       <p:cxnSp>
         <p:nvCxnSpPr>
-          <p:cNvPr id="79" name=""/>
+          <p:cNvPr id="87" name=""/>
           <p:cNvCxnSpPr/>
           <p:nvPr/>
         </p:nvCxnSpPr>
@@ -14290,14 +14290,14 @@
       </p:sp>
       <p:pic>
         <p:nvPicPr>
-          <p:cNvPr id="82" name=""/>
+          <p:cNvPr id="90" name=""/>
           <p:cNvPicPr>
             <a:picLocks xmlns:a="http://schemas.openxmlformats.org/drawingml/2006/main" noChangeAspect="1"/>
           </p:cNvPicPr>
           <p:nvPr/>
         </p:nvPicPr>
         <p:blipFill>
-          <a:blip xmlns:r="http://schemas.openxmlformats.org/officeDocument/2006/relationships" xmlns:a="http://schemas.openxmlformats.org/drawingml/2006/main" r:embed="Rcaaf7dc2126a4a3c"/>
+          <a:blip xmlns:r="http://schemas.openxmlformats.org/officeDocument/2006/relationships" xmlns:a="http://schemas.openxmlformats.org/drawingml/2006/main" r:embed="Rd6f0b2cf31194814"/>
           <a:srcRect xmlns:a="http://schemas.openxmlformats.org/drawingml/2006/main" l="11607" t="0" r="11607" b="0"/>
           <a:stretch xmlns:a="http://schemas.openxmlformats.org/drawingml/2006/main">
             <a:fillRect l="0" t="0" r="0" b="0"/>
@@ -15394,7 +15394,7 @@
       </p:sp>
       <p:cxnSp>
         <p:nvCxnSpPr>
-          <p:cNvPr id="144" name=""/>
+          <p:cNvPr id="164" name=""/>
           <p:cNvCxnSpPr/>
           <p:nvPr/>
         </p:nvCxnSpPr>
@@ -15807,7 +15807,7 @@
       </p:sp>
       <p:cxnSp>
         <p:nvCxnSpPr>
-          <p:cNvPr id="150" name=""/>
+          <p:cNvPr id="170" name=""/>
           <p:cNvCxnSpPr/>
           <p:nvPr/>
         </p:nvCxnSpPr>
@@ -15888,14 +15888,14 @@
       </p:sp>
       <p:pic>
         <p:nvPicPr>
-          <p:cNvPr id="152" name=""/>
+          <p:cNvPr id="172" name=""/>
           <p:cNvPicPr>
             <a:picLocks xmlns:a="http://schemas.openxmlformats.org/drawingml/2006/main" noChangeAspect="1"/>
           </p:cNvPicPr>
           <p:nvPr/>
         </p:nvPicPr>
         <p:blipFill>
-          <a:blip xmlns:r="http://schemas.openxmlformats.org/officeDocument/2006/relationships" xmlns:a="http://schemas.openxmlformats.org/drawingml/2006/main" r:embed="R2a3f8b3717484cd3"/>
+          <a:blip xmlns:r="http://schemas.openxmlformats.org/officeDocument/2006/relationships" xmlns:a="http://schemas.openxmlformats.org/drawingml/2006/main" r:embed="R29283b677ba54eb1"/>
           <a:srcRect xmlns:a="http://schemas.openxmlformats.org/drawingml/2006/main" l="0" t="9356" r="0" b="9356"/>
           <a:stretch xmlns:a="http://schemas.openxmlformats.org/drawingml/2006/main">
             <a:fillRect l="0" t="0" r="0" b="0"/>
@@ -16060,7 +16060,7 @@
       </p:sp>
       <p:cxnSp>
         <p:nvCxnSpPr>
-          <p:cNvPr id="85" name=""/>
+          <p:cNvPr id="95" name=""/>
           <p:cNvCxnSpPr/>
           <p:nvPr/>
         </p:nvCxnSpPr>
@@ -16200,14 +16200,14 @@
       </p:sp>
       <p:pic>
         <p:nvPicPr>
-          <p:cNvPr id="88" name=""/>
+          <p:cNvPr id="98" name=""/>
           <p:cNvPicPr>
             <a:picLocks xmlns:a="http://schemas.openxmlformats.org/drawingml/2006/main" noChangeAspect="1"/>
           </p:cNvPicPr>
           <p:nvPr/>
         </p:nvPicPr>
         <p:blipFill>
-          <a:blip xmlns:r="http://schemas.openxmlformats.org/officeDocument/2006/relationships" xmlns:a="http://schemas.openxmlformats.org/drawingml/2006/main" r:embed="R292fb77ff7ad4d9a"/>
+          <a:blip xmlns:r="http://schemas.openxmlformats.org/officeDocument/2006/relationships" xmlns:a="http://schemas.openxmlformats.org/drawingml/2006/main" r:embed="R8b60c569f7d84b61"/>
           <a:srcRect xmlns:a="http://schemas.openxmlformats.org/drawingml/2006/main" l="316" t="0" r="316" b="0"/>
           <a:stretch xmlns:a="http://schemas.openxmlformats.org/drawingml/2006/main">
             <a:fillRect l="0" t="0" r="0" b="0"/>
@@ -16225,14 +16225,14 @@
       </p:pic>
       <p:pic>
         <p:nvPicPr>
-          <p:cNvPr id="89" name=""/>
+          <p:cNvPr id="99" name=""/>
           <p:cNvPicPr>
             <a:picLocks xmlns:a="http://schemas.openxmlformats.org/drawingml/2006/main" noChangeAspect="1"/>
           </p:cNvPicPr>
           <p:nvPr/>
         </p:nvPicPr>
         <p:blipFill>
-          <a:blip xmlns:r="http://schemas.openxmlformats.org/officeDocument/2006/relationships" xmlns:a="http://schemas.openxmlformats.org/drawingml/2006/main" r:embed="Rb3f6c5e1967c4a37"/>
+          <a:blip xmlns:r="http://schemas.openxmlformats.org/officeDocument/2006/relationships" xmlns:a="http://schemas.openxmlformats.org/drawingml/2006/main" r:embed="R40c9a4773bf24c86"/>
           <a:srcRect xmlns:a="http://schemas.openxmlformats.org/drawingml/2006/main" l="0" t="383" r="0" b="383"/>
           <a:stretch xmlns:a="http://schemas.openxmlformats.org/drawingml/2006/main">
             <a:fillRect l="0" t="0" r="0" b="0"/>

</xml_diff>